<commit_message>
Clarify provisional DINOv2 classroom recommendation in slides
</commit_message>
<xml_diff>
--- a/reports/presentation/material_classification.pptx
+++ b/reports/presentation/material_classification.pptx
@@ -1790,7 +1790,7 @@
             </a:lvl1pPr>
           </a:lstStyle>
           <a:p>
-            <a:fld id="{127906F3-6F13-4B99-8ABC-99F8547AB650}" type="datetimeFigureOut">
+            <a:fld id="{2316FD41-E0BC-48A7-B3A2-4D36D74FA440}" type="datetimeFigureOut">
               <a:rPr lang="en-ZA" smtClean="0"/>
               <a:t>2026/10/27</a:t>
             </a:fld>
@@ -1949,7 +1949,7 @@
             </a:lvl1pPr>
           </a:lstStyle>
           <a:p>
-            <a:fld id="{45D663C8-05CE-4906-AB29-1A4C11E3845E}" type="slidenum">
+            <a:fld id="{E1BAD130-31BD-445B-9E2A-3B0017C46E9F}" type="slidenum">
               <a:rPr lang="en-ZA" smtClean="0"/>
               <a:t>‹#›</a:t>
             </a:fld>
@@ -1960,7 +1960,7 @@
     </p:spTree>
     <p:extLst>
       <p:ext uri="{BB962C8B-B14F-4D97-AF65-F5344CB8AC3E}">
-        <p14:creationId xmlns:p14="http://schemas.microsoft.com/office/powerpoint/2010/main" val="2421687946"/>
+        <p14:creationId xmlns:p14="http://schemas.microsoft.com/office/powerpoint/2010/main" val="982316689"/>
       </p:ext>
     </p:extLst>
   </p:cSld>
@@ -2130,7 +2130,7 @@
           <a:bodyPr/>
           <a:lstStyle/>
           <a:p>
-            <a:fld id="{45D663C8-05CE-4906-AB29-1A4C11E3845E}" type="slidenum">
+            <a:fld id="{E1BAD130-31BD-445B-9E2A-3B0017C46E9F}" type="slidenum">
               <a:rPr lang="en-ZA" smtClean="0"/>
               <a:t>1</a:t>
             </a:fld>
@@ -2141,7 +2141,7 @@
     </p:spTree>
     <p:extLst>
       <p:ext uri="{BB962C8B-B14F-4D97-AF65-F5344CB8AC3E}">
-        <p14:creationId xmlns:p14="http://schemas.microsoft.com/office/powerpoint/2010/main" val="3821697717"/>
+        <p14:creationId xmlns:p14="http://schemas.microsoft.com/office/powerpoint/2010/main" val="1780643376"/>
       </p:ext>
     </p:extLst>
   </p:cSld>
@@ -2222,7 +2222,7 @@
           <a:bodyPr/>
           <a:lstStyle/>
           <a:p>
-            <a:fld id="{45D663C8-05CE-4906-AB29-1A4C11E3845E}" type="slidenum">
+            <a:fld id="{E1BAD130-31BD-445B-9E2A-3B0017C46E9F}" type="slidenum">
               <a:rPr lang="en-ZA" smtClean="0"/>
               <a:t>10</a:t>
             </a:fld>
@@ -2233,7 +2233,7 @@
     </p:spTree>
     <p:extLst>
       <p:ext uri="{BB962C8B-B14F-4D97-AF65-F5344CB8AC3E}">
-        <p14:creationId xmlns:p14="http://schemas.microsoft.com/office/powerpoint/2010/main" val="984824027"/>
+        <p14:creationId xmlns:p14="http://schemas.microsoft.com/office/powerpoint/2010/main" val="3953955489"/>
       </p:ext>
     </p:extLst>
   </p:cSld>
@@ -2289,7 +2289,7 @@
           <a:p>
             <a:r>
               <a:rPr lang="en-US"/>
-              <a:t>On the recorded RTX 4070 Laptop GPU, ResNet has the lowest warm batch-one median latency. The primary is slower because it uses multiple backbone passes. Required storage includes the backbones, not just the small classifier head. Timing starts from predecoded RGB and includes preprocessing and probabilities, but excludes disk reading and decoding. These are CUDA measurements, not classroom CPU measurements. Keep frozen fusion as the preselected study result. Fine-tuned DINOv2 is a promising next deployment candidate because it has higher observed accuracy and lower measured latency than the primary, but it needs an independently planned confirmation. Choose ResNet only if the speed trade-off is acceptable.
+              <a:t>On the recorded RTX 4070 Laptop GPU, ResNet has the lowest warm batch-one median latency. The primary is slower because it uses multiple backbone passes. Required storage includes the backbones, not just the small classifier head. Timing starts from predecoded RGB and includes preprocessing and probabilities, but excludes disk reading and decoding. These are CUDA measurements, not classroom CPU measurements. Provisionally recommend fine-tuned DINOv2 for classroom use with comparable renders; retain fusion as the predeclared study primary; independently confirm before broader deployment. DINOv2 has higher observed accuracy and lower measured latency than the primary, but the paired uncertainty does not establish superiority. Choose ResNet only if the speed trade-off is acceptable.
 Sources:
 reports/results/v3/benchmarks/frozen_selected/benchmark.json
 reports/results/v3/benchmarks/frozen_control/benchmark.json
@@ -2315,7 +2315,7 @@
           <a:bodyPr/>
           <a:lstStyle/>
           <a:p>
-            <a:fld id="{45D663C8-05CE-4906-AB29-1A4C11E3845E}" type="slidenum">
+            <a:fld id="{E1BAD130-31BD-445B-9E2A-3B0017C46E9F}" type="slidenum">
               <a:rPr lang="en-ZA" smtClean="0"/>
               <a:t>11</a:t>
             </a:fld>
@@ -2326,7 +2326,7 @@
     </p:spTree>
     <p:extLst>
       <p:ext uri="{BB962C8B-B14F-4D97-AF65-F5344CB8AC3E}">
-        <p14:creationId xmlns:p14="http://schemas.microsoft.com/office/powerpoint/2010/main" val="1009114852"/>
+        <p14:creationId xmlns:p14="http://schemas.microsoft.com/office/powerpoint/2010/main" val="2678602747"/>
       </p:ext>
     </p:extLst>
   </p:cSld>
@@ -2406,7 +2406,7 @@
           <a:bodyPr/>
           <a:lstStyle/>
           <a:p>
-            <a:fld id="{45D663C8-05CE-4906-AB29-1A4C11E3845E}" type="slidenum">
+            <a:fld id="{E1BAD130-31BD-445B-9E2A-3B0017C46E9F}" type="slidenum">
               <a:rPr lang="en-ZA" smtClean="0"/>
               <a:t>12</a:t>
             </a:fld>
@@ -2417,7 +2417,7 @@
     </p:spTree>
     <p:extLst>
       <p:ext uri="{BB962C8B-B14F-4D97-AF65-F5344CB8AC3E}">
-        <p14:creationId xmlns:p14="http://schemas.microsoft.com/office/powerpoint/2010/main" val="1622290772"/>
+        <p14:creationId xmlns:p14="http://schemas.microsoft.com/office/powerpoint/2010/main" val="175005412"/>
       </p:ext>
     </p:extLst>
   </p:cSld>
@@ -2497,7 +2497,7 @@
           <a:bodyPr/>
           <a:lstStyle/>
           <a:p>
-            <a:fld id="{45D663C8-05CE-4906-AB29-1A4C11E3845E}" type="slidenum">
+            <a:fld id="{E1BAD130-31BD-445B-9E2A-3B0017C46E9F}" type="slidenum">
               <a:rPr lang="en-ZA" smtClean="0"/>
               <a:t>13</a:t>
             </a:fld>
@@ -2508,7 +2508,7 @@
     </p:spTree>
     <p:extLst>
       <p:ext uri="{BB962C8B-B14F-4D97-AF65-F5344CB8AC3E}">
-        <p14:creationId xmlns:p14="http://schemas.microsoft.com/office/powerpoint/2010/main" val="3432982464"/>
+        <p14:creationId xmlns:p14="http://schemas.microsoft.com/office/powerpoint/2010/main" val="3351955254"/>
       </p:ext>
     </p:extLst>
   </p:cSld>
@@ -2588,7 +2588,7 @@
           <a:bodyPr/>
           <a:lstStyle/>
           <a:p>
-            <a:fld id="{45D663C8-05CE-4906-AB29-1A4C11E3845E}" type="slidenum">
+            <a:fld id="{E1BAD130-31BD-445B-9E2A-3B0017C46E9F}" type="slidenum">
               <a:rPr lang="en-ZA" smtClean="0"/>
               <a:t>14</a:t>
             </a:fld>
@@ -2599,7 +2599,7 @@
     </p:spTree>
     <p:extLst>
       <p:ext uri="{BB962C8B-B14F-4D97-AF65-F5344CB8AC3E}">
-        <p14:creationId xmlns:p14="http://schemas.microsoft.com/office/powerpoint/2010/main" val="3962832344"/>
+        <p14:creationId xmlns:p14="http://schemas.microsoft.com/office/powerpoint/2010/main" val="3410265068"/>
       </p:ext>
     </p:extLst>
   </p:cSld>
@@ -2679,7 +2679,7 @@
           <a:bodyPr/>
           <a:lstStyle/>
           <a:p>
-            <a:fld id="{45D663C8-05CE-4906-AB29-1A4C11E3845E}" type="slidenum">
+            <a:fld id="{E1BAD130-31BD-445B-9E2A-3B0017C46E9F}" type="slidenum">
               <a:rPr lang="en-ZA" smtClean="0"/>
               <a:t>2</a:t>
             </a:fld>
@@ -2690,7 +2690,7 @@
     </p:spTree>
     <p:extLst>
       <p:ext uri="{BB962C8B-B14F-4D97-AF65-F5344CB8AC3E}">
-        <p14:creationId xmlns:p14="http://schemas.microsoft.com/office/powerpoint/2010/main" val="1277550355"/>
+        <p14:creationId xmlns:p14="http://schemas.microsoft.com/office/powerpoint/2010/main" val="2047262979"/>
       </p:ext>
     </p:extLst>
   </p:cSld>
@@ -2773,7 +2773,7 @@
           <a:bodyPr/>
           <a:lstStyle/>
           <a:p>
-            <a:fld id="{45D663C8-05CE-4906-AB29-1A4C11E3845E}" type="slidenum">
+            <a:fld id="{E1BAD130-31BD-445B-9E2A-3B0017C46E9F}" type="slidenum">
               <a:rPr lang="en-ZA" smtClean="0"/>
               <a:t>3</a:t>
             </a:fld>
@@ -2784,7 +2784,7 @@
     </p:spTree>
     <p:extLst>
       <p:ext uri="{BB962C8B-B14F-4D97-AF65-F5344CB8AC3E}">
-        <p14:creationId xmlns:p14="http://schemas.microsoft.com/office/powerpoint/2010/main" val="790338631"/>
+        <p14:creationId xmlns:p14="http://schemas.microsoft.com/office/powerpoint/2010/main" val="2512518647"/>
       </p:ext>
     </p:extLst>
   </p:cSld>
@@ -2869,7 +2869,7 @@
           <a:bodyPr/>
           <a:lstStyle/>
           <a:p>
-            <a:fld id="{45D663C8-05CE-4906-AB29-1A4C11E3845E}" type="slidenum">
+            <a:fld id="{E1BAD130-31BD-445B-9E2A-3B0017C46E9F}" type="slidenum">
               <a:rPr lang="en-ZA" smtClean="0"/>
               <a:t>4</a:t>
             </a:fld>
@@ -2880,7 +2880,7 @@
     </p:spTree>
     <p:extLst>
       <p:ext uri="{BB962C8B-B14F-4D97-AF65-F5344CB8AC3E}">
-        <p14:creationId xmlns:p14="http://schemas.microsoft.com/office/powerpoint/2010/main" val="2840838941"/>
+        <p14:creationId xmlns:p14="http://schemas.microsoft.com/office/powerpoint/2010/main" val="1555926778"/>
       </p:ext>
     </p:extLst>
   </p:cSld>
@@ -2963,7 +2963,7 @@
           <a:bodyPr/>
           <a:lstStyle/>
           <a:p>
-            <a:fld id="{45D663C8-05CE-4906-AB29-1A4C11E3845E}" type="slidenum">
+            <a:fld id="{E1BAD130-31BD-445B-9E2A-3B0017C46E9F}" type="slidenum">
               <a:rPr lang="en-ZA" smtClean="0"/>
               <a:t>5</a:t>
             </a:fld>
@@ -2974,7 +2974,7 @@
     </p:spTree>
     <p:extLst>
       <p:ext uri="{BB962C8B-B14F-4D97-AF65-F5344CB8AC3E}">
-        <p14:creationId xmlns:p14="http://schemas.microsoft.com/office/powerpoint/2010/main" val="2943549667"/>
+        <p14:creationId xmlns:p14="http://schemas.microsoft.com/office/powerpoint/2010/main" val="388580393"/>
       </p:ext>
     </p:extLst>
   </p:cSld>
@@ -3057,7 +3057,7 @@
           <a:bodyPr/>
           <a:lstStyle/>
           <a:p>
-            <a:fld id="{45D663C8-05CE-4906-AB29-1A4C11E3845E}" type="slidenum">
+            <a:fld id="{E1BAD130-31BD-445B-9E2A-3B0017C46E9F}" type="slidenum">
               <a:rPr lang="en-ZA" smtClean="0"/>
               <a:t>6</a:t>
             </a:fld>
@@ -3068,7 +3068,7 @@
     </p:spTree>
     <p:extLst>
       <p:ext uri="{BB962C8B-B14F-4D97-AF65-F5344CB8AC3E}">
-        <p14:creationId xmlns:p14="http://schemas.microsoft.com/office/powerpoint/2010/main" val="2601898084"/>
+        <p14:creationId xmlns:p14="http://schemas.microsoft.com/office/powerpoint/2010/main" val="2096959774"/>
       </p:ext>
     </p:extLst>
   </p:cSld>
@@ -3151,7 +3151,7 @@
           <a:bodyPr/>
           <a:lstStyle/>
           <a:p>
-            <a:fld id="{45D663C8-05CE-4906-AB29-1A4C11E3845E}" type="slidenum">
+            <a:fld id="{E1BAD130-31BD-445B-9E2A-3B0017C46E9F}" type="slidenum">
               <a:rPr lang="en-ZA" smtClean="0"/>
               <a:t>7</a:t>
             </a:fld>
@@ -3162,7 +3162,7 @@
     </p:spTree>
     <p:extLst>
       <p:ext uri="{BB962C8B-B14F-4D97-AF65-F5344CB8AC3E}">
-        <p14:creationId xmlns:p14="http://schemas.microsoft.com/office/powerpoint/2010/main" val="430503606"/>
+        <p14:creationId xmlns:p14="http://schemas.microsoft.com/office/powerpoint/2010/main" val="677590259"/>
       </p:ext>
     </p:extLst>
   </p:cSld>
@@ -3242,7 +3242,7 @@
           <a:bodyPr/>
           <a:lstStyle/>
           <a:p>
-            <a:fld id="{45D663C8-05CE-4906-AB29-1A4C11E3845E}" type="slidenum">
+            <a:fld id="{E1BAD130-31BD-445B-9E2A-3B0017C46E9F}" type="slidenum">
               <a:rPr lang="en-ZA" smtClean="0"/>
               <a:t>8</a:t>
             </a:fld>
@@ -3253,7 +3253,7 @@
     </p:spTree>
     <p:extLst>
       <p:ext uri="{BB962C8B-B14F-4D97-AF65-F5344CB8AC3E}">
-        <p14:creationId xmlns:p14="http://schemas.microsoft.com/office/powerpoint/2010/main" val="3866157300"/>
+        <p14:creationId xmlns:p14="http://schemas.microsoft.com/office/powerpoint/2010/main" val="2481147158"/>
       </p:ext>
     </p:extLst>
   </p:cSld>
@@ -3333,7 +3333,7 @@
           <a:bodyPr/>
           <a:lstStyle/>
           <a:p>
-            <a:fld id="{45D663C8-05CE-4906-AB29-1A4C11E3845E}" type="slidenum">
+            <a:fld id="{E1BAD130-31BD-445B-9E2A-3B0017C46E9F}" type="slidenum">
               <a:rPr lang="en-ZA" smtClean="0"/>
               <a:t>9</a:t>
             </a:fld>
@@ -3344,7 +3344,7 @@
     </p:spTree>
     <p:extLst>
       <p:ext uri="{BB962C8B-B14F-4D97-AF65-F5344CB8AC3E}">
-        <p14:creationId xmlns:p14="http://schemas.microsoft.com/office/powerpoint/2010/main" val="1430911823"/>
+        <p14:creationId xmlns:p14="http://schemas.microsoft.com/office/powerpoint/2010/main" val="284482326"/>
       </p:ext>
     </p:extLst>
   </p:cSld>
@@ -3376,7 +3376,7 @@
           <p:cNvPr id="2" name="Title 1">
             <a:extLst>
               <a:ext uri="{FF2B5EF4-FFF2-40B4-BE49-F238E27FC236}">
-                <a16:creationId xmlns:a16="http://schemas.microsoft.com/office/drawing/2014/main" id="{2BC057EC-5DF8-1A8A-27E9-D430377AD80D}"/>
+                <a16:creationId xmlns:a16="http://schemas.microsoft.com/office/drawing/2014/main" id="{D75F3056-F4A4-DB53-185F-F1DE08038E4F}"/>
               </a:ext>
             </a:extLst>
           </p:cNvPr>
@@ -3414,7 +3414,7 @@
           <p:cNvPr id="3" name="Subtitle 2">
             <a:extLst>
               <a:ext uri="{FF2B5EF4-FFF2-40B4-BE49-F238E27FC236}">
-                <a16:creationId xmlns:a16="http://schemas.microsoft.com/office/drawing/2014/main" id="{05A4B182-9F31-EC55-764B-0B3C62B4EB3E}"/>
+                <a16:creationId xmlns:a16="http://schemas.microsoft.com/office/drawing/2014/main" id="{CD620FE6-45EE-3657-0FE6-277A94F9E2C2}"/>
               </a:ext>
             </a:extLst>
           </p:cNvPr>
@@ -3485,7 +3485,7 @@
           <p:cNvPr id="4" name="Date Placeholder 3">
             <a:extLst>
               <a:ext uri="{FF2B5EF4-FFF2-40B4-BE49-F238E27FC236}">
-                <a16:creationId xmlns:a16="http://schemas.microsoft.com/office/drawing/2014/main" id="{298C527A-8F85-C694-8657-42A921826C86}"/>
+                <a16:creationId xmlns:a16="http://schemas.microsoft.com/office/drawing/2014/main" id="{F6DAF359-75D8-13B7-5953-BE597A7EFC74}"/>
               </a:ext>
             </a:extLst>
           </p:cNvPr>
@@ -3501,7 +3501,7 @@
           <a:bodyPr/>
           <a:lstStyle/>
           <a:p>
-            <a:fld id="{5D5527CF-4D46-45AA-9299-A5EF512A898B}" type="datetimeFigureOut">
+            <a:fld id="{68AB6C0A-96D3-480E-84E1-5AAAF379C7DC}" type="datetimeFigureOut">
               <a:rPr lang="en-ZA" smtClean="0"/>
               <a:t>2026/10/27</a:t>
             </a:fld>
@@ -3514,7 +3514,7 @@
           <p:cNvPr id="5" name="Footer Placeholder 4">
             <a:extLst>
               <a:ext uri="{FF2B5EF4-FFF2-40B4-BE49-F238E27FC236}">
-                <a16:creationId xmlns:a16="http://schemas.microsoft.com/office/drawing/2014/main" id="{630BF67D-638A-95F5-D6AD-10B6802D7C7D}"/>
+                <a16:creationId xmlns:a16="http://schemas.microsoft.com/office/drawing/2014/main" id="{34169A32-88CC-A007-6F47-64D16DCD79E3}"/>
               </a:ext>
             </a:extLst>
           </p:cNvPr>
@@ -3539,7 +3539,7 @@
           <p:cNvPr id="6" name="Slide Number Placeholder 5">
             <a:extLst>
               <a:ext uri="{FF2B5EF4-FFF2-40B4-BE49-F238E27FC236}">
-                <a16:creationId xmlns:a16="http://schemas.microsoft.com/office/drawing/2014/main" id="{F1B130DB-D0BF-A12D-6F54-173AA2721353}"/>
+                <a16:creationId xmlns:a16="http://schemas.microsoft.com/office/drawing/2014/main" id="{30A5EF19-41CC-E38F-D23E-AE0A68A33340}"/>
               </a:ext>
             </a:extLst>
           </p:cNvPr>
@@ -3555,7 +3555,7 @@
           <a:bodyPr/>
           <a:lstStyle/>
           <a:p>
-            <a:fld id="{7310985F-0F73-45E6-917E-CF8899F58CCF}" type="slidenum">
+            <a:fld id="{1D551152-66F7-4AC9-B92F-B6D6C08E8FCF}" type="slidenum">
               <a:rPr lang="en-ZA" smtClean="0"/>
               <a:t>‹#›</a:t>
             </a:fld>
@@ -3566,7 +3566,7 @@
     </p:spTree>
     <p:extLst>
       <p:ext uri="{BB962C8B-B14F-4D97-AF65-F5344CB8AC3E}">
-        <p14:creationId xmlns:p14="http://schemas.microsoft.com/office/powerpoint/2010/main" val="3115822412"/>
+        <p14:creationId xmlns:p14="http://schemas.microsoft.com/office/powerpoint/2010/main" val="3474054869"/>
       </p:ext>
     </p:extLst>
   </p:cSld>
@@ -3598,7 +3598,7 @@
           <p:cNvPr id="2" name="Title 1">
             <a:extLst>
               <a:ext uri="{FF2B5EF4-FFF2-40B4-BE49-F238E27FC236}">
-                <a16:creationId xmlns:a16="http://schemas.microsoft.com/office/drawing/2014/main" id="{1368808B-7065-8FE2-8FE7-A25738100D43}"/>
+                <a16:creationId xmlns:a16="http://schemas.microsoft.com/office/drawing/2014/main" id="{BFB8A844-2235-424B-E6DA-3CCE1411A84E}"/>
               </a:ext>
             </a:extLst>
           </p:cNvPr>
@@ -3627,7 +3627,7 @@
           <p:cNvPr id="3" name="Vertical Text Placeholder 2">
             <a:extLst>
               <a:ext uri="{FF2B5EF4-FFF2-40B4-BE49-F238E27FC236}">
-                <a16:creationId xmlns:a16="http://schemas.microsoft.com/office/drawing/2014/main" id="{9E7064E7-ED0B-FB4E-0700-F5FD2EF441E0}"/>
+                <a16:creationId xmlns:a16="http://schemas.microsoft.com/office/drawing/2014/main" id="{1B6DC0C4-EBBE-0A1D-9D30-B72AF7040BA8}"/>
               </a:ext>
             </a:extLst>
           </p:cNvPr>
@@ -3685,7 +3685,7 @@
           <p:cNvPr id="4" name="Date Placeholder 3">
             <a:extLst>
               <a:ext uri="{FF2B5EF4-FFF2-40B4-BE49-F238E27FC236}">
-                <a16:creationId xmlns:a16="http://schemas.microsoft.com/office/drawing/2014/main" id="{B16230CE-A56E-9C53-FC99-F115257C811C}"/>
+                <a16:creationId xmlns:a16="http://schemas.microsoft.com/office/drawing/2014/main" id="{2FA9D137-6F23-6197-545D-B83D992CDC15}"/>
               </a:ext>
             </a:extLst>
           </p:cNvPr>
@@ -3701,7 +3701,7 @@
           <a:bodyPr/>
           <a:lstStyle/>
           <a:p>
-            <a:fld id="{5D5527CF-4D46-45AA-9299-A5EF512A898B}" type="datetimeFigureOut">
+            <a:fld id="{68AB6C0A-96D3-480E-84E1-5AAAF379C7DC}" type="datetimeFigureOut">
               <a:rPr lang="en-ZA" smtClean="0"/>
               <a:t>2026/10/27</a:t>
             </a:fld>
@@ -3714,7 +3714,7 @@
           <p:cNvPr id="5" name="Footer Placeholder 4">
             <a:extLst>
               <a:ext uri="{FF2B5EF4-FFF2-40B4-BE49-F238E27FC236}">
-                <a16:creationId xmlns:a16="http://schemas.microsoft.com/office/drawing/2014/main" id="{4ADD43D6-9C3F-9FE3-224D-F00052CB88A3}"/>
+                <a16:creationId xmlns:a16="http://schemas.microsoft.com/office/drawing/2014/main" id="{3FAB85B4-DC87-3B22-1936-DC3FE3964BEB}"/>
               </a:ext>
             </a:extLst>
           </p:cNvPr>
@@ -3739,7 +3739,7 @@
           <p:cNvPr id="6" name="Slide Number Placeholder 5">
             <a:extLst>
               <a:ext uri="{FF2B5EF4-FFF2-40B4-BE49-F238E27FC236}">
-                <a16:creationId xmlns:a16="http://schemas.microsoft.com/office/drawing/2014/main" id="{63BFE453-8F34-A429-DC33-76BD99C0D705}"/>
+                <a16:creationId xmlns:a16="http://schemas.microsoft.com/office/drawing/2014/main" id="{22FD260A-B235-A4F8-60E9-F82D432938C5}"/>
               </a:ext>
             </a:extLst>
           </p:cNvPr>
@@ -3755,7 +3755,7 @@
           <a:bodyPr/>
           <a:lstStyle/>
           <a:p>
-            <a:fld id="{7310985F-0F73-45E6-917E-CF8899F58CCF}" type="slidenum">
+            <a:fld id="{1D551152-66F7-4AC9-B92F-B6D6C08E8FCF}" type="slidenum">
               <a:rPr lang="en-ZA" smtClean="0"/>
               <a:t>‹#›</a:t>
             </a:fld>
@@ -3766,7 +3766,7 @@
     </p:spTree>
     <p:extLst>
       <p:ext uri="{BB962C8B-B14F-4D97-AF65-F5344CB8AC3E}">
-        <p14:creationId xmlns:p14="http://schemas.microsoft.com/office/powerpoint/2010/main" val="3198882330"/>
+        <p14:creationId xmlns:p14="http://schemas.microsoft.com/office/powerpoint/2010/main" val="2000092271"/>
       </p:ext>
     </p:extLst>
   </p:cSld>
@@ -3798,7 +3798,7 @@
           <p:cNvPr id="2" name="Vertical Title 1">
             <a:extLst>
               <a:ext uri="{FF2B5EF4-FFF2-40B4-BE49-F238E27FC236}">
-                <a16:creationId xmlns:a16="http://schemas.microsoft.com/office/drawing/2014/main" id="{B989C9B0-C1BA-F064-1970-F57C138DE806}"/>
+                <a16:creationId xmlns:a16="http://schemas.microsoft.com/office/drawing/2014/main" id="{858EC38A-6778-2249-9FEC-974ACC54868C}"/>
               </a:ext>
             </a:extLst>
           </p:cNvPr>
@@ -3832,7 +3832,7 @@
           <p:cNvPr id="3" name="Vertical Text Placeholder 2">
             <a:extLst>
               <a:ext uri="{FF2B5EF4-FFF2-40B4-BE49-F238E27FC236}">
-                <a16:creationId xmlns:a16="http://schemas.microsoft.com/office/drawing/2014/main" id="{0CEAC20E-201E-9260-36DA-24387E0C0646}"/>
+                <a16:creationId xmlns:a16="http://schemas.microsoft.com/office/drawing/2014/main" id="{B346C353-F14A-0CE4-0A77-BBF4D41F5472}"/>
               </a:ext>
             </a:extLst>
           </p:cNvPr>
@@ -3895,7 +3895,7 @@
           <p:cNvPr id="4" name="Date Placeholder 3">
             <a:extLst>
               <a:ext uri="{FF2B5EF4-FFF2-40B4-BE49-F238E27FC236}">
-                <a16:creationId xmlns:a16="http://schemas.microsoft.com/office/drawing/2014/main" id="{342FC995-9A3B-BD85-A6CF-2AEEDCC6F355}"/>
+                <a16:creationId xmlns:a16="http://schemas.microsoft.com/office/drawing/2014/main" id="{417B5813-6E40-D93B-D46E-C9FE3317E926}"/>
               </a:ext>
             </a:extLst>
           </p:cNvPr>
@@ -3911,7 +3911,7 @@
           <a:bodyPr/>
           <a:lstStyle/>
           <a:p>
-            <a:fld id="{5D5527CF-4D46-45AA-9299-A5EF512A898B}" type="datetimeFigureOut">
+            <a:fld id="{68AB6C0A-96D3-480E-84E1-5AAAF379C7DC}" type="datetimeFigureOut">
               <a:rPr lang="en-ZA" smtClean="0"/>
               <a:t>2026/10/27</a:t>
             </a:fld>
@@ -3924,7 +3924,7 @@
           <p:cNvPr id="5" name="Footer Placeholder 4">
             <a:extLst>
               <a:ext uri="{FF2B5EF4-FFF2-40B4-BE49-F238E27FC236}">
-                <a16:creationId xmlns:a16="http://schemas.microsoft.com/office/drawing/2014/main" id="{AAAA86A0-2410-B8BE-99DC-CC594F938B74}"/>
+                <a16:creationId xmlns:a16="http://schemas.microsoft.com/office/drawing/2014/main" id="{83642CBA-74E2-5BA1-832A-0132A1C00331}"/>
               </a:ext>
             </a:extLst>
           </p:cNvPr>
@@ -3949,7 +3949,7 @@
           <p:cNvPr id="6" name="Slide Number Placeholder 5">
             <a:extLst>
               <a:ext uri="{FF2B5EF4-FFF2-40B4-BE49-F238E27FC236}">
-                <a16:creationId xmlns:a16="http://schemas.microsoft.com/office/drawing/2014/main" id="{28A6AF74-C6A3-422D-44E6-9589E401F461}"/>
+                <a16:creationId xmlns:a16="http://schemas.microsoft.com/office/drawing/2014/main" id="{E6396422-E55B-C80B-F614-FFE54A0E2A46}"/>
               </a:ext>
             </a:extLst>
           </p:cNvPr>
@@ -3965,7 +3965,7 @@
           <a:bodyPr/>
           <a:lstStyle/>
           <a:p>
-            <a:fld id="{7310985F-0F73-45E6-917E-CF8899F58CCF}" type="slidenum">
+            <a:fld id="{1D551152-66F7-4AC9-B92F-B6D6C08E8FCF}" type="slidenum">
               <a:rPr lang="en-ZA" smtClean="0"/>
               <a:t>‹#›</a:t>
             </a:fld>
@@ -3976,7 +3976,7 @@
     </p:spTree>
     <p:extLst>
       <p:ext uri="{BB962C8B-B14F-4D97-AF65-F5344CB8AC3E}">
-        <p14:creationId xmlns:p14="http://schemas.microsoft.com/office/powerpoint/2010/main" val="258346823"/>
+        <p14:creationId xmlns:p14="http://schemas.microsoft.com/office/powerpoint/2010/main" val="3597231963"/>
       </p:ext>
     </p:extLst>
   </p:cSld>
@@ -4008,7 +4008,7 @@
           <p:cNvPr id="2" name="Title 1">
             <a:extLst>
               <a:ext uri="{FF2B5EF4-FFF2-40B4-BE49-F238E27FC236}">
-                <a16:creationId xmlns:a16="http://schemas.microsoft.com/office/drawing/2014/main" id="{3F3CFEBB-5DCA-D682-A3DD-FB7A7D5ADE24}"/>
+                <a16:creationId xmlns:a16="http://schemas.microsoft.com/office/drawing/2014/main" id="{12FA3AA5-A1EC-CF8F-6D6D-CD5C30074565}"/>
               </a:ext>
             </a:extLst>
           </p:cNvPr>
@@ -4037,7 +4037,7 @@
           <p:cNvPr id="3" name="Content Placeholder 2">
             <a:extLst>
               <a:ext uri="{FF2B5EF4-FFF2-40B4-BE49-F238E27FC236}">
-                <a16:creationId xmlns:a16="http://schemas.microsoft.com/office/drawing/2014/main" id="{1F557D80-EB1D-1372-7479-C3AED92516AE}"/>
+                <a16:creationId xmlns:a16="http://schemas.microsoft.com/office/drawing/2014/main" id="{865D8BF7-3C4C-AEF0-FB93-4DE9DE398A01}"/>
               </a:ext>
             </a:extLst>
           </p:cNvPr>
@@ -4095,7 +4095,7 @@
           <p:cNvPr id="4" name="Date Placeholder 3">
             <a:extLst>
               <a:ext uri="{FF2B5EF4-FFF2-40B4-BE49-F238E27FC236}">
-                <a16:creationId xmlns:a16="http://schemas.microsoft.com/office/drawing/2014/main" id="{EF87F64D-6F00-9E8F-6425-4546B9390332}"/>
+                <a16:creationId xmlns:a16="http://schemas.microsoft.com/office/drawing/2014/main" id="{BD74F1C1-A8F5-BD3A-4690-E0158A2693D0}"/>
               </a:ext>
             </a:extLst>
           </p:cNvPr>
@@ -4111,7 +4111,7 @@
           <a:bodyPr/>
           <a:lstStyle/>
           <a:p>
-            <a:fld id="{5D5527CF-4D46-45AA-9299-A5EF512A898B}" type="datetimeFigureOut">
+            <a:fld id="{68AB6C0A-96D3-480E-84E1-5AAAF379C7DC}" type="datetimeFigureOut">
               <a:rPr lang="en-ZA" smtClean="0"/>
               <a:t>2026/10/27</a:t>
             </a:fld>
@@ -4124,7 +4124,7 @@
           <p:cNvPr id="5" name="Footer Placeholder 4">
             <a:extLst>
               <a:ext uri="{FF2B5EF4-FFF2-40B4-BE49-F238E27FC236}">
-                <a16:creationId xmlns:a16="http://schemas.microsoft.com/office/drawing/2014/main" id="{E1F69532-2B55-DE7E-9502-FCB2761BB139}"/>
+                <a16:creationId xmlns:a16="http://schemas.microsoft.com/office/drawing/2014/main" id="{293CA3A2-4C69-32A5-F73C-E54D4583E45C}"/>
               </a:ext>
             </a:extLst>
           </p:cNvPr>
@@ -4149,7 +4149,7 @@
           <p:cNvPr id="6" name="Slide Number Placeholder 5">
             <a:extLst>
               <a:ext uri="{FF2B5EF4-FFF2-40B4-BE49-F238E27FC236}">
-                <a16:creationId xmlns:a16="http://schemas.microsoft.com/office/drawing/2014/main" id="{45680AF7-E83E-2075-B95E-AFCFB2110882}"/>
+                <a16:creationId xmlns:a16="http://schemas.microsoft.com/office/drawing/2014/main" id="{D3BD2188-A724-6BAC-3950-B32BA293A73C}"/>
               </a:ext>
             </a:extLst>
           </p:cNvPr>
@@ -4165,7 +4165,7 @@
           <a:bodyPr/>
           <a:lstStyle/>
           <a:p>
-            <a:fld id="{7310985F-0F73-45E6-917E-CF8899F58CCF}" type="slidenum">
+            <a:fld id="{1D551152-66F7-4AC9-B92F-B6D6C08E8FCF}" type="slidenum">
               <a:rPr lang="en-ZA" smtClean="0"/>
               <a:t>‹#›</a:t>
             </a:fld>
@@ -4176,7 +4176,7 @@
     </p:spTree>
     <p:extLst>
       <p:ext uri="{BB962C8B-B14F-4D97-AF65-F5344CB8AC3E}">
-        <p14:creationId xmlns:p14="http://schemas.microsoft.com/office/powerpoint/2010/main" val="3381431296"/>
+        <p14:creationId xmlns:p14="http://schemas.microsoft.com/office/powerpoint/2010/main" val="1450797302"/>
       </p:ext>
     </p:extLst>
   </p:cSld>
@@ -4208,7 +4208,7 @@
           <p:cNvPr id="2" name="Title 1">
             <a:extLst>
               <a:ext uri="{FF2B5EF4-FFF2-40B4-BE49-F238E27FC236}">
-                <a16:creationId xmlns:a16="http://schemas.microsoft.com/office/drawing/2014/main" id="{46E5749E-2604-A83C-64F6-A1C88260EC3F}"/>
+                <a16:creationId xmlns:a16="http://schemas.microsoft.com/office/drawing/2014/main" id="{64E618DE-FF5D-D0EF-ACD8-2B2EBBA8E166}"/>
               </a:ext>
             </a:extLst>
           </p:cNvPr>
@@ -4246,7 +4246,7 @@
           <p:cNvPr id="3" name="Text Placeholder 2">
             <a:extLst>
               <a:ext uri="{FF2B5EF4-FFF2-40B4-BE49-F238E27FC236}">
-                <a16:creationId xmlns:a16="http://schemas.microsoft.com/office/drawing/2014/main" id="{FEC75479-141A-2A11-BBDE-77E34314B69A}"/>
+                <a16:creationId xmlns:a16="http://schemas.microsoft.com/office/drawing/2014/main" id="{F973E2BE-F6F4-D8B0-D451-34BC116C4631}"/>
               </a:ext>
             </a:extLst>
           </p:cNvPr>
@@ -4371,7 +4371,7 @@
           <p:cNvPr id="4" name="Date Placeholder 3">
             <a:extLst>
               <a:ext uri="{FF2B5EF4-FFF2-40B4-BE49-F238E27FC236}">
-                <a16:creationId xmlns:a16="http://schemas.microsoft.com/office/drawing/2014/main" id="{B074685F-309D-8ECE-85B8-BF1AEC0DBF2F}"/>
+                <a16:creationId xmlns:a16="http://schemas.microsoft.com/office/drawing/2014/main" id="{BE334837-01E8-EDAC-2BFB-7188BBAFCC36}"/>
               </a:ext>
             </a:extLst>
           </p:cNvPr>
@@ -4387,7 +4387,7 @@
           <a:bodyPr/>
           <a:lstStyle/>
           <a:p>
-            <a:fld id="{5D5527CF-4D46-45AA-9299-A5EF512A898B}" type="datetimeFigureOut">
+            <a:fld id="{68AB6C0A-96D3-480E-84E1-5AAAF379C7DC}" type="datetimeFigureOut">
               <a:rPr lang="en-ZA" smtClean="0"/>
               <a:t>2026/10/27</a:t>
             </a:fld>
@@ -4400,7 +4400,7 @@
           <p:cNvPr id="5" name="Footer Placeholder 4">
             <a:extLst>
               <a:ext uri="{FF2B5EF4-FFF2-40B4-BE49-F238E27FC236}">
-                <a16:creationId xmlns:a16="http://schemas.microsoft.com/office/drawing/2014/main" id="{BFD0B07A-BC9F-1EE2-AFBD-AC99A3D564DB}"/>
+                <a16:creationId xmlns:a16="http://schemas.microsoft.com/office/drawing/2014/main" id="{7E6F3287-789F-4B43-431A-204E45D28F71}"/>
               </a:ext>
             </a:extLst>
           </p:cNvPr>
@@ -4425,7 +4425,7 @@
           <p:cNvPr id="6" name="Slide Number Placeholder 5">
             <a:extLst>
               <a:ext uri="{FF2B5EF4-FFF2-40B4-BE49-F238E27FC236}">
-                <a16:creationId xmlns:a16="http://schemas.microsoft.com/office/drawing/2014/main" id="{A0BE644F-AA84-1DC0-FEE0-7976B88E91F4}"/>
+                <a16:creationId xmlns:a16="http://schemas.microsoft.com/office/drawing/2014/main" id="{A6F4A678-A10A-F3E9-77B3-AD3AA14D27CF}"/>
               </a:ext>
             </a:extLst>
           </p:cNvPr>
@@ -4441,7 +4441,7 @@
           <a:bodyPr/>
           <a:lstStyle/>
           <a:p>
-            <a:fld id="{7310985F-0F73-45E6-917E-CF8899F58CCF}" type="slidenum">
+            <a:fld id="{1D551152-66F7-4AC9-B92F-B6D6C08E8FCF}" type="slidenum">
               <a:rPr lang="en-ZA" smtClean="0"/>
               <a:t>‹#›</a:t>
             </a:fld>
@@ -4452,7 +4452,7 @@
     </p:spTree>
     <p:extLst>
       <p:ext uri="{BB962C8B-B14F-4D97-AF65-F5344CB8AC3E}">
-        <p14:creationId xmlns:p14="http://schemas.microsoft.com/office/powerpoint/2010/main" val="808232434"/>
+        <p14:creationId xmlns:p14="http://schemas.microsoft.com/office/powerpoint/2010/main" val="3279947146"/>
       </p:ext>
     </p:extLst>
   </p:cSld>
@@ -4484,7 +4484,7 @@
           <p:cNvPr id="2" name="Title 1">
             <a:extLst>
               <a:ext uri="{FF2B5EF4-FFF2-40B4-BE49-F238E27FC236}">
-                <a16:creationId xmlns:a16="http://schemas.microsoft.com/office/drawing/2014/main" id="{22A8D1E6-CEC9-12C5-DD7D-8BD44B7A23CA}"/>
+                <a16:creationId xmlns:a16="http://schemas.microsoft.com/office/drawing/2014/main" id="{14B78311-1A50-9722-E173-8ED83B249C71}"/>
               </a:ext>
             </a:extLst>
           </p:cNvPr>
@@ -4513,7 +4513,7 @@
           <p:cNvPr id="3" name="Content Placeholder 2">
             <a:extLst>
               <a:ext uri="{FF2B5EF4-FFF2-40B4-BE49-F238E27FC236}">
-                <a16:creationId xmlns:a16="http://schemas.microsoft.com/office/drawing/2014/main" id="{252B4F72-10F1-B86D-A47E-3A416A1A5A4B}"/>
+                <a16:creationId xmlns:a16="http://schemas.microsoft.com/office/drawing/2014/main" id="{99E3C7C0-423E-784C-0F65-6B48EA796144}"/>
               </a:ext>
             </a:extLst>
           </p:cNvPr>
@@ -4576,7 +4576,7 @@
           <p:cNvPr id="4" name="Content Placeholder 3">
             <a:extLst>
               <a:ext uri="{FF2B5EF4-FFF2-40B4-BE49-F238E27FC236}">
-                <a16:creationId xmlns:a16="http://schemas.microsoft.com/office/drawing/2014/main" id="{693ADC6B-7B0D-A083-CBBC-3C0E2A54F872}"/>
+                <a16:creationId xmlns:a16="http://schemas.microsoft.com/office/drawing/2014/main" id="{5572068E-25BA-4CB9-506F-EF57527799E8}"/>
               </a:ext>
             </a:extLst>
           </p:cNvPr>
@@ -4639,7 +4639,7 @@
           <p:cNvPr id="5" name="Date Placeholder 4">
             <a:extLst>
               <a:ext uri="{FF2B5EF4-FFF2-40B4-BE49-F238E27FC236}">
-                <a16:creationId xmlns:a16="http://schemas.microsoft.com/office/drawing/2014/main" id="{1B3137B5-FB01-2523-341A-66E20FBD9900}"/>
+                <a16:creationId xmlns:a16="http://schemas.microsoft.com/office/drawing/2014/main" id="{AC5AB47B-D862-546F-8314-F9FC928DD657}"/>
               </a:ext>
             </a:extLst>
           </p:cNvPr>
@@ -4655,7 +4655,7 @@
           <a:bodyPr/>
           <a:lstStyle/>
           <a:p>
-            <a:fld id="{5D5527CF-4D46-45AA-9299-A5EF512A898B}" type="datetimeFigureOut">
+            <a:fld id="{68AB6C0A-96D3-480E-84E1-5AAAF379C7DC}" type="datetimeFigureOut">
               <a:rPr lang="en-ZA" smtClean="0"/>
               <a:t>2026/10/27</a:t>
             </a:fld>
@@ -4668,7 +4668,7 @@
           <p:cNvPr id="6" name="Footer Placeholder 5">
             <a:extLst>
               <a:ext uri="{FF2B5EF4-FFF2-40B4-BE49-F238E27FC236}">
-                <a16:creationId xmlns:a16="http://schemas.microsoft.com/office/drawing/2014/main" id="{6E34FF6C-2F4E-8297-D88B-17D31000659E}"/>
+                <a16:creationId xmlns:a16="http://schemas.microsoft.com/office/drawing/2014/main" id="{C2A729C2-421E-AF18-ED15-1CA573D3116A}"/>
               </a:ext>
             </a:extLst>
           </p:cNvPr>
@@ -4693,7 +4693,7 @@
           <p:cNvPr id="7" name="Slide Number Placeholder 6">
             <a:extLst>
               <a:ext uri="{FF2B5EF4-FFF2-40B4-BE49-F238E27FC236}">
-                <a16:creationId xmlns:a16="http://schemas.microsoft.com/office/drawing/2014/main" id="{147B3864-E537-24CF-B4D4-E76263282EE3}"/>
+                <a16:creationId xmlns:a16="http://schemas.microsoft.com/office/drawing/2014/main" id="{D4FCE812-EAC9-A708-51DE-1915BD497E76}"/>
               </a:ext>
             </a:extLst>
           </p:cNvPr>
@@ -4709,7 +4709,7 @@
           <a:bodyPr/>
           <a:lstStyle/>
           <a:p>
-            <a:fld id="{7310985F-0F73-45E6-917E-CF8899F58CCF}" type="slidenum">
+            <a:fld id="{1D551152-66F7-4AC9-B92F-B6D6C08E8FCF}" type="slidenum">
               <a:rPr lang="en-ZA" smtClean="0"/>
               <a:t>‹#›</a:t>
             </a:fld>
@@ -4720,7 +4720,7 @@
     </p:spTree>
     <p:extLst>
       <p:ext uri="{BB962C8B-B14F-4D97-AF65-F5344CB8AC3E}">
-        <p14:creationId xmlns:p14="http://schemas.microsoft.com/office/powerpoint/2010/main" val="3522071129"/>
+        <p14:creationId xmlns:p14="http://schemas.microsoft.com/office/powerpoint/2010/main" val="2865919120"/>
       </p:ext>
     </p:extLst>
   </p:cSld>
@@ -4752,7 +4752,7 @@
           <p:cNvPr id="2" name="Title 1">
             <a:extLst>
               <a:ext uri="{FF2B5EF4-FFF2-40B4-BE49-F238E27FC236}">
-                <a16:creationId xmlns:a16="http://schemas.microsoft.com/office/drawing/2014/main" id="{F90DF67C-8D0F-E6E4-EA69-0ED7566E038C}"/>
+                <a16:creationId xmlns:a16="http://schemas.microsoft.com/office/drawing/2014/main" id="{AB381AB7-3555-7638-7DCE-88F7DB9BD9B1}"/>
               </a:ext>
             </a:extLst>
           </p:cNvPr>
@@ -4786,7 +4786,7 @@
           <p:cNvPr id="3" name="Text Placeholder 2">
             <a:extLst>
               <a:ext uri="{FF2B5EF4-FFF2-40B4-BE49-F238E27FC236}">
-                <a16:creationId xmlns:a16="http://schemas.microsoft.com/office/drawing/2014/main" id="{7BEF6FE6-C6EE-DA05-1738-9CDAEFFB0A58}"/>
+                <a16:creationId xmlns:a16="http://schemas.microsoft.com/office/drawing/2014/main" id="{62889A6B-A7F2-C793-4216-5C80998D8F90}"/>
               </a:ext>
             </a:extLst>
           </p:cNvPr>
@@ -4857,7 +4857,7 @@
           <p:cNvPr id="4" name="Content Placeholder 3">
             <a:extLst>
               <a:ext uri="{FF2B5EF4-FFF2-40B4-BE49-F238E27FC236}">
-                <a16:creationId xmlns:a16="http://schemas.microsoft.com/office/drawing/2014/main" id="{A73F08E0-6B24-0CCE-D52D-D0A16E936BBA}"/>
+                <a16:creationId xmlns:a16="http://schemas.microsoft.com/office/drawing/2014/main" id="{66395E01-00F3-B666-ACCC-601E69D7710D}"/>
               </a:ext>
             </a:extLst>
           </p:cNvPr>
@@ -4920,7 +4920,7 @@
           <p:cNvPr id="5" name="Text Placeholder 4">
             <a:extLst>
               <a:ext uri="{FF2B5EF4-FFF2-40B4-BE49-F238E27FC236}">
-                <a16:creationId xmlns:a16="http://schemas.microsoft.com/office/drawing/2014/main" id="{FD190614-273C-A756-E376-A37B1433CB92}"/>
+                <a16:creationId xmlns:a16="http://schemas.microsoft.com/office/drawing/2014/main" id="{0ABD584D-0983-E007-7E2C-BD51FE9C7A9A}"/>
               </a:ext>
             </a:extLst>
           </p:cNvPr>
@@ -4991,7 +4991,7 @@
           <p:cNvPr id="6" name="Content Placeholder 5">
             <a:extLst>
               <a:ext uri="{FF2B5EF4-FFF2-40B4-BE49-F238E27FC236}">
-                <a16:creationId xmlns:a16="http://schemas.microsoft.com/office/drawing/2014/main" id="{B1BCB9D1-97CB-902A-6154-E41A034D4379}"/>
+                <a16:creationId xmlns:a16="http://schemas.microsoft.com/office/drawing/2014/main" id="{163A633E-AB3B-3095-DB46-D10C9EFF91CF}"/>
               </a:ext>
             </a:extLst>
           </p:cNvPr>
@@ -5054,7 +5054,7 @@
           <p:cNvPr id="7" name="Date Placeholder 6">
             <a:extLst>
               <a:ext uri="{FF2B5EF4-FFF2-40B4-BE49-F238E27FC236}">
-                <a16:creationId xmlns:a16="http://schemas.microsoft.com/office/drawing/2014/main" id="{75AB24B8-E179-6770-32EB-E9F4045BCA5E}"/>
+                <a16:creationId xmlns:a16="http://schemas.microsoft.com/office/drawing/2014/main" id="{297F173B-CDCF-1DA7-A8E8-92A71860F27C}"/>
               </a:ext>
             </a:extLst>
           </p:cNvPr>
@@ -5070,7 +5070,7 @@
           <a:bodyPr/>
           <a:lstStyle/>
           <a:p>
-            <a:fld id="{5D5527CF-4D46-45AA-9299-A5EF512A898B}" type="datetimeFigureOut">
+            <a:fld id="{68AB6C0A-96D3-480E-84E1-5AAAF379C7DC}" type="datetimeFigureOut">
               <a:rPr lang="en-ZA" smtClean="0"/>
               <a:t>2026/10/27</a:t>
             </a:fld>
@@ -5083,7 +5083,7 @@
           <p:cNvPr id="8" name="Footer Placeholder 7">
             <a:extLst>
               <a:ext uri="{FF2B5EF4-FFF2-40B4-BE49-F238E27FC236}">
-                <a16:creationId xmlns:a16="http://schemas.microsoft.com/office/drawing/2014/main" id="{48E8551B-4504-6A18-837B-586449C35A07}"/>
+                <a16:creationId xmlns:a16="http://schemas.microsoft.com/office/drawing/2014/main" id="{C4B5F6EE-CF19-D567-B901-563705CCC2AF}"/>
               </a:ext>
             </a:extLst>
           </p:cNvPr>
@@ -5108,7 +5108,7 @@
           <p:cNvPr id="9" name="Slide Number Placeholder 8">
             <a:extLst>
               <a:ext uri="{FF2B5EF4-FFF2-40B4-BE49-F238E27FC236}">
-                <a16:creationId xmlns:a16="http://schemas.microsoft.com/office/drawing/2014/main" id="{5CFA8910-C6C4-3F31-3F14-620B8B6AC17B}"/>
+                <a16:creationId xmlns:a16="http://schemas.microsoft.com/office/drawing/2014/main" id="{7760181F-038E-7DE2-C5CC-2104888B1DBC}"/>
               </a:ext>
             </a:extLst>
           </p:cNvPr>
@@ -5124,7 +5124,7 @@
           <a:bodyPr/>
           <a:lstStyle/>
           <a:p>
-            <a:fld id="{7310985F-0F73-45E6-917E-CF8899F58CCF}" type="slidenum">
+            <a:fld id="{1D551152-66F7-4AC9-B92F-B6D6C08E8FCF}" type="slidenum">
               <a:rPr lang="en-ZA" smtClean="0"/>
               <a:t>‹#›</a:t>
             </a:fld>
@@ -5135,7 +5135,7 @@
     </p:spTree>
     <p:extLst>
       <p:ext uri="{BB962C8B-B14F-4D97-AF65-F5344CB8AC3E}">
-        <p14:creationId xmlns:p14="http://schemas.microsoft.com/office/powerpoint/2010/main" val="481893378"/>
+        <p14:creationId xmlns:p14="http://schemas.microsoft.com/office/powerpoint/2010/main" val="2917367000"/>
       </p:ext>
     </p:extLst>
   </p:cSld>
@@ -5167,7 +5167,7 @@
           <p:cNvPr id="2" name="Title 1">
             <a:extLst>
               <a:ext uri="{FF2B5EF4-FFF2-40B4-BE49-F238E27FC236}">
-                <a16:creationId xmlns:a16="http://schemas.microsoft.com/office/drawing/2014/main" id="{A2CBC1DD-BA17-B895-0DD5-8AB7868FED70}"/>
+                <a16:creationId xmlns:a16="http://schemas.microsoft.com/office/drawing/2014/main" id="{A9672D4D-92B6-C929-75AE-2675810B6B96}"/>
               </a:ext>
             </a:extLst>
           </p:cNvPr>
@@ -5196,7 +5196,7 @@
           <p:cNvPr id="3" name="Date Placeholder 2">
             <a:extLst>
               <a:ext uri="{FF2B5EF4-FFF2-40B4-BE49-F238E27FC236}">
-                <a16:creationId xmlns:a16="http://schemas.microsoft.com/office/drawing/2014/main" id="{79BDF5CE-5E2B-C9FA-E443-63D432E0D925}"/>
+                <a16:creationId xmlns:a16="http://schemas.microsoft.com/office/drawing/2014/main" id="{144B200C-0621-CE0B-46E4-8086112AACD2}"/>
               </a:ext>
             </a:extLst>
           </p:cNvPr>
@@ -5212,7 +5212,7 @@
           <a:bodyPr/>
           <a:lstStyle/>
           <a:p>
-            <a:fld id="{5D5527CF-4D46-45AA-9299-A5EF512A898B}" type="datetimeFigureOut">
+            <a:fld id="{68AB6C0A-96D3-480E-84E1-5AAAF379C7DC}" type="datetimeFigureOut">
               <a:rPr lang="en-ZA" smtClean="0"/>
               <a:t>2026/10/27</a:t>
             </a:fld>
@@ -5225,7 +5225,7 @@
           <p:cNvPr id="4" name="Footer Placeholder 3">
             <a:extLst>
               <a:ext uri="{FF2B5EF4-FFF2-40B4-BE49-F238E27FC236}">
-                <a16:creationId xmlns:a16="http://schemas.microsoft.com/office/drawing/2014/main" id="{15E47D1C-F997-C73E-A554-A69CB6680658}"/>
+                <a16:creationId xmlns:a16="http://schemas.microsoft.com/office/drawing/2014/main" id="{3AC47599-C5EA-7528-ACF4-BFC7E5832784}"/>
               </a:ext>
             </a:extLst>
           </p:cNvPr>
@@ -5250,7 +5250,7 @@
           <p:cNvPr id="5" name="Slide Number Placeholder 4">
             <a:extLst>
               <a:ext uri="{FF2B5EF4-FFF2-40B4-BE49-F238E27FC236}">
-                <a16:creationId xmlns:a16="http://schemas.microsoft.com/office/drawing/2014/main" id="{662E3BF4-07A2-04FC-BE8C-1D332F2E485D}"/>
+                <a16:creationId xmlns:a16="http://schemas.microsoft.com/office/drawing/2014/main" id="{E2080010-A243-7E34-0C7D-33CB62083B74}"/>
               </a:ext>
             </a:extLst>
           </p:cNvPr>
@@ -5266,7 +5266,7 @@
           <a:bodyPr/>
           <a:lstStyle/>
           <a:p>
-            <a:fld id="{7310985F-0F73-45E6-917E-CF8899F58CCF}" type="slidenum">
+            <a:fld id="{1D551152-66F7-4AC9-B92F-B6D6C08E8FCF}" type="slidenum">
               <a:rPr lang="en-ZA" smtClean="0"/>
               <a:t>‹#›</a:t>
             </a:fld>
@@ -5277,7 +5277,7 @@
     </p:spTree>
     <p:extLst>
       <p:ext uri="{BB962C8B-B14F-4D97-AF65-F5344CB8AC3E}">
-        <p14:creationId xmlns:p14="http://schemas.microsoft.com/office/powerpoint/2010/main" val="2110501916"/>
+        <p14:creationId xmlns:p14="http://schemas.microsoft.com/office/powerpoint/2010/main" val="3233671003"/>
       </p:ext>
     </p:extLst>
   </p:cSld>
@@ -5309,7 +5309,7 @@
           <p:cNvPr id="2" name="Date Placeholder 1">
             <a:extLst>
               <a:ext uri="{FF2B5EF4-FFF2-40B4-BE49-F238E27FC236}">
-                <a16:creationId xmlns:a16="http://schemas.microsoft.com/office/drawing/2014/main" id="{7D2AA352-C1B1-646E-940D-E91FACC16C6D}"/>
+                <a16:creationId xmlns:a16="http://schemas.microsoft.com/office/drawing/2014/main" id="{4E644F86-29F5-2449-1FEE-0566E3904503}"/>
               </a:ext>
             </a:extLst>
           </p:cNvPr>
@@ -5325,7 +5325,7 @@
           <a:bodyPr/>
           <a:lstStyle/>
           <a:p>
-            <a:fld id="{5D5527CF-4D46-45AA-9299-A5EF512A898B}" type="datetimeFigureOut">
+            <a:fld id="{68AB6C0A-96D3-480E-84E1-5AAAF379C7DC}" type="datetimeFigureOut">
               <a:rPr lang="en-ZA" smtClean="0"/>
               <a:t>2026/10/27</a:t>
             </a:fld>
@@ -5338,7 +5338,7 @@
           <p:cNvPr id="3" name="Footer Placeholder 2">
             <a:extLst>
               <a:ext uri="{FF2B5EF4-FFF2-40B4-BE49-F238E27FC236}">
-                <a16:creationId xmlns:a16="http://schemas.microsoft.com/office/drawing/2014/main" id="{D361C5EB-C2F0-FE9E-35C6-97C3CBE30A33}"/>
+                <a16:creationId xmlns:a16="http://schemas.microsoft.com/office/drawing/2014/main" id="{BA054175-B3AC-AC76-44FE-3DBC04174134}"/>
               </a:ext>
             </a:extLst>
           </p:cNvPr>
@@ -5363,7 +5363,7 @@
           <p:cNvPr id="4" name="Slide Number Placeholder 3">
             <a:extLst>
               <a:ext uri="{FF2B5EF4-FFF2-40B4-BE49-F238E27FC236}">
-                <a16:creationId xmlns:a16="http://schemas.microsoft.com/office/drawing/2014/main" id="{1B3151B9-EC5C-C444-E992-6190213B42D9}"/>
+                <a16:creationId xmlns:a16="http://schemas.microsoft.com/office/drawing/2014/main" id="{BF0A67E2-F0CC-5FC7-0243-ED9977E7362C}"/>
               </a:ext>
             </a:extLst>
           </p:cNvPr>
@@ -5379,7 +5379,7 @@
           <a:bodyPr/>
           <a:lstStyle/>
           <a:p>
-            <a:fld id="{7310985F-0F73-45E6-917E-CF8899F58CCF}" type="slidenum">
+            <a:fld id="{1D551152-66F7-4AC9-B92F-B6D6C08E8FCF}" type="slidenum">
               <a:rPr lang="en-ZA" smtClean="0"/>
               <a:t>‹#›</a:t>
             </a:fld>
@@ -5390,7 +5390,7 @@
     </p:spTree>
     <p:extLst>
       <p:ext uri="{BB962C8B-B14F-4D97-AF65-F5344CB8AC3E}">
-        <p14:creationId xmlns:p14="http://schemas.microsoft.com/office/powerpoint/2010/main" val="450658540"/>
+        <p14:creationId xmlns:p14="http://schemas.microsoft.com/office/powerpoint/2010/main" val="869938615"/>
       </p:ext>
     </p:extLst>
   </p:cSld>
@@ -5422,7 +5422,7 @@
           <p:cNvPr id="2" name="Title 1">
             <a:extLst>
               <a:ext uri="{FF2B5EF4-FFF2-40B4-BE49-F238E27FC236}">
-                <a16:creationId xmlns:a16="http://schemas.microsoft.com/office/drawing/2014/main" id="{E43A6EA4-2EAD-A203-2E61-B1971E6AE56F}"/>
+                <a16:creationId xmlns:a16="http://schemas.microsoft.com/office/drawing/2014/main" id="{BCF101B2-CD39-D71D-243F-33EE4CD40611}"/>
               </a:ext>
             </a:extLst>
           </p:cNvPr>
@@ -5460,7 +5460,7 @@
           <p:cNvPr id="3" name="Content Placeholder 2">
             <a:extLst>
               <a:ext uri="{FF2B5EF4-FFF2-40B4-BE49-F238E27FC236}">
-                <a16:creationId xmlns:a16="http://schemas.microsoft.com/office/drawing/2014/main" id="{DC183DBD-AB08-6F55-7DFE-8C4BEBCBB899}"/>
+                <a16:creationId xmlns:a16="http://schemas.microsoft.com/office/drawing/2014/main" id="{88DB60B7-C466-D025-5FFE-4AF8F0CB4B83}"/>
               </a:ext>
             </a:extLst>
           </p:cNvPr>
@@ -5551,7 +5551,7 @@
           <p:cNvPr id="4" name="Text Placeholder 3">
             <a:extLst>
               <a:ext uri="{FF2B5EF4-FFF2-40B4-BE49-F238E27FC236}">
-                <a16:creationId xmlns:a16="http://schemas.microsoft.com/office/drawing/2014/main" id="{F9B39EF6-4FA8-A876-266A-77C8D54102BE}"/>
+                <a16:creationId xmlns:a16="http://schemas.microsoft.com/office/drawing/2014/main" id="{E58A5449-4B0D-355B-3C6B-6A0D16535B3E}"/>
               </a:ext>
             </a:extLst>
           </p:cNvPr>
@@ -5622,7 +5622,7 @@
           <p:cNvPr id="5" name="Date Placeholder 4">
             <a:extLst>
               <a:ext uri="{FF2B5EF4-FFF2-40B4-BE49-F238E27FC236}">
-                <a16:creationId xmlns:a16="http://schemas.microsoft.com/office/drawing/2014/main" id="{BA4ACDA5-FAEB-A714-8B3F-2C11D9176851}"/>
+                <a16:creationId xmlns:a16="http://schemas.microsoft.com/office/drawing/2014/main" id="{A8441685-7EDA-BD90-756D-A59CE3A0C9FD}"/>
               </a:ext>
             </a:extLst>
           </p:cNvPr>
@@ -5638,7 +5638,7 @@
           <a:bodyPr/>
           <a:lstStyle/>
           <a:p>
-            <a:fld id="{5D5527CF-4D46-45AA-9299-A5EF512A898B}" type="datetimeFigureOut">
+            <a:fld id="{68AB6C0A-96D3-480E-84E1-5AAAF379C7DC}" type="datetimeFigureOut">
               <a:rPr lang="en-ZA" smtClean="0"/>
               <a:t>2026/10/27</a:t>
             </a:fld>
@@ -5651,7 +5651,7 @@
           <p:cNvPr id="6" name="Footer Placeholder 5">
             <a:extLst>
               <a:ext uri="{FF2B5EF4-FFF2-40B4-BE49-F238E27FC236}">
-                <a16:creationId xmlns:a16="http://schemas.microsoft.com/office/drawing/2014/main" id="{063C8B16-679C-93D0-1B82-6D9A4D8D4F31}"/>
+                <a16:creationId xmlns:a16="http://schemas.microsoft.com/office/drawing/2014/main" id="{E103EC61-E12C-3B69-908E-C50700A90B4E}"/>
               </a:ext>
             </a:extLst>
           </p:cNvPr>
@@ -5676,7 +5676,7 @@
           <p:cNvPr id="7" name="Slide Number Placeholder 6">
             <a:extLst>
               <a:ext uri="{FF2B5EF4-FFF2-40B4-BE49-F238E27FC236}">
-                <a16:creationId xmlns:a16="http://schemas.microsoft.com/office/drawing/2014/main" id="{FA6BB30D-4FF0-6A28-8259-D7FD1F480951}"/>
+                <a16:creationId xmlns:a16="http://schemas.microsoft.com/office/drawing/2014/main" id="{5ABB757C-012F-3D1B-D82A-5565A7E6D3E1}"/>
               </a:ext>
             </a:extLst>
           </p:cNvPr>
@@ -5692,7 +5692,7 @@
           <a:bodyPr/>
           <a:lstStyle/>
           <a:p>
-            <a:fld id="{7310985F-0F73-45E6-917E-CF8899F58CCF}" type="slidenum">
+            <a:fld id="{1D551152-66F7-4AC9-B92F-B6D6C08E8FCF}" type="slidenum">
               <a:rPr lang="en-ZA" smtClean="0"/>
               <a:t>‹#›</a:t>
             </a:fld>
@@ -5703,7 +5703,7 @@
     </p:spTree>
     <p:extLst>
       <p:ext uri="{BB962C8B-B14F-4D97-AF65-F5344CB8AC3E}">
-        <p14:creationId xmlns:p14="http://schemas.microsoft.com/office/powerpoint/2010/main" val="4199436621"/>
+        <p14:creationId xmlns:p14="http://schemas.microsoft.com/office/powerpoint/2010/main" val="3315283771"/>
       </p:ext>
     </p:extLst>
   </p:cSld>
@@ -5735,7 +5735,7 @@
           <p:cNvPr id="2" name="Title 1">
             <a:extLst>
               <a:ext uri="{FF2B5EF4-FFF2-40B4-BE49-F238E27FC236}">
-                <a16:creationId xmlns:a16="http://schemas.microsoft.com/office/drawing/2014/main" id="{2A0BFD70-6CAF-CC40-B844-A933A7066593}"/>
+                <a16:creationId xmlns:a16="http://schemas.microsoft.com/office/drawing/2014/main" id="{DE32F532-368F-9D36-D8B5-C3FDEF90D75E}"/>
               </a:ext>
             </a:extLst>
           </p:cNvPr>
@@ -5773,7 +5773,7 @@
           <p:cNvPr id="3" name="Picture Placeholder 2">
             <a:extLst>
               <a:ext uri="{FF2B5EF4-FFF2-40B4-BE49-F238E27FC236}">
-                <a16:creationId xmlns:a16="http://schemas.microsoft.com/office/drawing/2014/main" id="{DCA69BEA-9DD9-CDF0-791F-F069793B3715}"/>
+                <a16:creationId xmlns:a16="http://schemas.microsoft.com/office/drawing/2014/main" id="{289EC226-DEC8-5118-20D2-EF63975C71B2}"/>
               </a:ext>
             </a:extLst>
           </p:cNvPr>
@@ -5840,7 +5840,7 @@
           <p:cNvPr id="4" name="Text Placeholder 3">
             <a:extLst>
               <a:ext uri="{FF2B5EF4-FFF2-40B4-BE49-F238E27FC236}">
-                <a16:creationId xmlns:a16="http://schemas.microsoft.com/office/drawing/2014/main" id="{73A8BBE1-AD70-674F-E1AD-F388257C76B3}"/>
+                <a16:creationId xmlns:a16="http://schemas.microsoft.com/office/drawing/2014/main" id="{C2D393DC-EE9B-3F21-9494-258D8C17905A}"/>
               </a:ext>
             </a:extLst>
           </p:cNvPr>
@@ -5911,7 +5911,7 @@
           <p:cNvPr id="5" name="Date Placeholder 4">
             <a:extLst>
               <a:ext uri="{FF2B5EF4-FFF2-40B4-BE49-F238E27FC236}">
-                <a16:creationId xmlns:a16="http://schemas.microsoft.com/office/drawing/2014/main" id="{A6B4F051-36DD-26B0-2514-46E5CB6B2824}"/>
+                <a16:creationId xmlns:a16="http://schemas.microsoft.com/office/drawing/2014/main" id="{178745D8-9A22-F7A3-0CF0-4668273C99EB}"/>
               </a:ext>
             </a:extLst>
           </p:cNvPr>
@@ -5927,7 +5927,7 @@
           <a:bodyPr/>
           <a:lstStyle/>
           <a:p>
-            <a:fld id="{5D5527CF-4D46-45AA-9299-A5EF512A898B}" type="datetimeFigureOut">
+            <a:fld id="{68AB6C0A-96D3-480E-84E1-5AAAF379C7DC}" type="datetimeFigureOut">
               <a:rPr lang="en-ZA" smtClean="0"/>
               <a:t>2026/10/27</a:t>
             </a:fld>
@@ -5940,7 +5940,7 @@
           <p:cNvPr id="6" name="Footer Placeholder 5">
             <a:extLst>
               <a:ext uri="{FF2B5EF4-FFF2-40B4-BE49-F238E27FC236}">
-                <a16:creationId xmlns:a16="http://schemas.microsoft.com/office/drawing/2014/main" id="{98B788E9-64CD-7FBD-BA02-88009F9C2AB6}"/>
+                <a16:creationId xmlns:a16="http://schemas.microsoft.com/office/drawing/2014/main" id="{BF6BEB9D-83EE-6ADB-BA3C-D9F8754ECFAF}"/>
               </a:ext>
             </a:extLst>
           </p:cNvPr>
@@ -5965,7 +5965,7 @@
           <p:cNvPr id="7" name="Slide Number Placeholder 6">
             <a:extLst>
               <a:ext uri="{FF2B5EF4-FFF2-40B4-BE49-F238E27FC236}">
-                <a16:creationId xmlns:a16="http://schemas.microsoft.com/office/drawing/2014/main" id="{55BD7BAB-B0C2-C3FC-5A4E-1F66D831522E}"/>
+                <a16:creationId xmlns:a16="http://schemas.microsoft.com/office/drawing/2014/main" id="{789F7AFF-AC23-27C8-9B12-79E83142B659}"/>
               </a:ext>
             </a:extLst>
           </p:cNvPr>
@@ -5981,7 +5981,7 @@
           <a:bodyPr/>
           <a:lstStyle/>
           <a:p>
-            <a:fld id="{7310985F-0F73-45E6-917E-CF8899F58CCF}" type="slidenum">
+            <a:fld id="{1D551152-66F7-4AC9-B92F-B6D6C08E8FCF}" type="slidenum">
               <a:rPr lang="en-ZA" smtClean="0"/>
               <a:t>‹#›</a:t>
             </a:fld>
@@ -5992,7 +5992,7 @@
     </p:spTree>
     <p:extLst>
       <p:ext uri="{BB962C8B-B14F-4D97-AF65-F5344CB8AC3E}">
-        <p14:creationId xmlns:p14="http://schemas.microsoft.com/office/powerpoint/2010/main" val="2557962516"/>
+        <p14:creationId xmlns:p14="http://schemas.microsoft.com/office/powerpoint/2010/main" val="964561940"/>
       </p:ext>
     </p:extLst>
   </p:cSld>
@@ -6029,7 +6029,7 @@
           <p:cNvPr id="2" name="Title Placeholder 1">
             <a:extLst>
               <a:ext uri="{FF2B5EF4-FFF2-40B4-BE49-F238E27FC236}">
-                <a16:creationId xmlns:a16="http://schemas.microsoft.com/office/drawing/2014/main" id="{C4554F92-3414-73C7-2D93-8428BE6B4C44}"/>
+                <a16:creationId xmlns:a16="http://schemas.microsoft.com/office/drawing/2014/main" id="{8686657C-1F88-7C92-E4E9-B586C268C508}"/>
               </a:ext>
             </a:extLst>
           </p:cNvPr>
@@ -6068,7 +6068,7 @@
           <p:cNvPr id="3" name="Text Placeholder 2">
             <a:extLst>
               <a:ext uri="{FF2B5EF4-FFF2-40B4-BE49-F238E27FC236}">
-                <a16:creationId xmlns:a16="http://schemas.microsoft.com/office/drawing/2014/main" id="{BD01D3A9-2D4A-77C2-63D5-B062EAED9BEA}"/>
+                <a16:creationId xmlns:a16="http://schemas.microsoft.com/office/drawing/2014/main" id="{0744D047-4DF8-8B66-79C3-174A435EAA9F}"/>
               </a:ext>
             </a:extLst>
           </p:cNvPr>
@@ -6136,7 +6136,7 @@
           <p:cNvPr id="4" name="Date Placeholder 3">
             <a:extLst>
               <a:ext uri="{FF2B5EF4-FFF2-40B4-BE49-F238E27FC236}">
-                <a16:creationId xmlns:a16="http://schemas.microsoft.com/office/drawing/2014/main" id="{D86D9DFB-9947-29D2-EE9D-24E5A00B220F}"/>
+                <a16:creationId xmlns:a16="http://schemas.microsoft.com/office/drawing/2014/main" id="{0E341E92-113C-2AAF-4602-25D999B54FD4}"/>
               </a:ext>
             </a:extLst>
           </p:cNvPr>
@@ -6170,7 +6170,7 @@
             </a:lvl1pPr>
           </a:lstStyle>
           <a:p>
-            <a:fld id="{5D5527CF-4D46-45AA-9299-A5EF512A898B}" type="datetimeFigureOut">
+            <a:fld id="{68AB6C0A-96D3-480E-84E1-5AAAF379C7DC}" type="datetimeFigureOut">
               <a:rPr lang="en-ZA" smtClean="0"/>
               <a:t>2026/10/27</a:t>
             </a:fld>
@@ -6183,7 +6183,7 @@
           <p:cNvPr id="5" name="Footer Placeholder 4">
             <a:extLst>
               <a:ext uri="{FF2B5EF4-FFF2-40B4-BE49-F238E27FC236}">
-                <a16:creationId xmlns:a16="http://schemas.microsoft.com/office/drawing/2014/main" id="{FADDEEF6-6E99-DE28-88D5-4A728717126D}"/>
+                <a16:creationId xmlns:a16="http://schemas.microsoft.com/office/drawing/2014/main" id="{3DAAC350-AD07-3355-8458-0E32433D3448}"/>
               </a:ext>
             </a:extLst>
           </p:cNvPr>
@@ -6226,7 +6226,7 @@
           <p:cNvPr id="6" name="Slide Number Placeholder 5">
             <a:extLst>
               <a:ext uri="{FF2B5EF4-FFF2-40B4-BE49-F238E27FC236}">
-                <a16:creationId xmlns:a16="http://schemas.microsoft.com/office/drawing/2014/main" id="{F2644FBD-DE63-8C9E-50BD-2C14D42B09F5}"/>
+                <a16:creationId xmlns:a16="http://schemas.microsoft.com/office/drawing/2014/main" id="{33C88B15-7A21-1289-F477-4BCFB59C341F}"/>
               </a:ext>
             </a:extLst>
           </p:cNvPr>
@@ -6260,7 +6260,7 @@
             </a:lvl1pPr>
           </a:lstStyle>
           <a:p>
-            <a:fld id="{7310985F-0F73-45E6-917E-CF8899F58CCF}" type="slidenum">
+            <a:fld id="{1D551152-66F7-4AC9-B92F-B6D6C08E8FCF}" type="slidenum">
               <a:rPr lang="en-ZA" smtClean="0"/>
               <a:t>‹#›</a:t>
             </a:fld>
@@ -6271,7 +6271,7 @@
     </p:spTree>
     <p:extLst>
       <p:ext uri="{BB962C8B-B14F-4D97-AF65-F5344CB8AC3E}">
-        <p14:creationId xmlns:p14="http://schemas.microsoft.com/office/powerpoint/2010/main" val="3913663321"/>
+        <p14:creationId xmlns:p14="http://schemas.microsoft.com/office/powerpoint/2010/main" val="2084254505"/>
       </p:ext>
     </p:extLst>
   </p:cSld>
@@ -6602,7 +6602,7 @@
           <p:cNvPr id="2" name="TextBox 1">
             <a:extLst>
               <a:ext uri="{FF2B5EF4-FFF2-40B4-BE49-F238E27FC236}">
-                <a16:creationId xmlns:a16="http://schemas.microsoft.com/office/drawing/2014/main" id="{49BA4EE5-D715-725A-615F-6DA1654FE202}"/>
+                <a16:creationId xmlns:a16="http://schemas.microsoft.com/office/drawing/2014/main" id="{A2564F0C-ACD8-CC93-38E4-F6967708B988}"/>
               </a:ext>
             </a:extLst>
           </p:cNvPr>
@@ -6654,7 +6654,7 @@
           <p:cNvPr id="3" name="TextBox 2">
             <a:extLst>
               <a:ext uri="{FF2B5EF4-FFF2-40B4-BE49-F238E27FC236}">
-                <a16:creationId xmlns:a16="http://schemas.microsoft.com/office/drawing/2014/main" id="{86297F15-7059-7ACC-BD33-674C617439BD}"/>
+                <a16:creationId xmlns:a16="http://schemas.microsoft.com/office/drawing/2014/main" id="{7F5F3259-8504-050D-EF54-F36AEF18EC53}"/>
               </a:ext>
             </a:extLst>
           </p:cNvPr>
@@ -6699,7 +6699,7 @@
           <p:cNvPr id="4" name="TextBox 3">
             <a:extLst>
               <a:ext uri="{FF2B5EF4-FFF2-40B4-BE49-F238E27FC236}">
-                <a16:creationId xmlns:a16="http://schemas.microsoft.com/office/drawing/2014/main" id="{9CA9A78F-BB9C-D1DD-32A9-08DDD752A126}"/>
+                <a16:creationId xmlns:a16="http://schemas.microsoft.com/office/drawing/2014/main" id="{5F112454-9DAF-5E95-7388-662FAFF1BAA7}"/>
               </a:ext>
             </a:extLst>
           </p:cNvPr>
@@ -6750,7 +6750,7 @@
           <p:cNvPr id="5" name="TextBox 4">
             <a:extLst>
               <a:ext uri="{FF2B5EF4-FFF2-40B4-BE49-F238E27FC236}">
-                <a16:creationId xmlns:a16="http://schemas.microsoft.com/office/drawing/2014/main" id="{C44A8925-015C-C5BA-A848-1B3231D0C60D}"/>
+                <a16:creationId xmlns:a16="http://schemas.microsoft.com/office/drawing/2014/main" id="{C071519C-C892-EA8D-70CA-F35E2B7989C1}"/>
               </a:ext>
             </a:extLst>
           </p:cNvPr>
@@ -6802,7 +6802,7 @@
           <p:cNvPr id="6" name="TextBox 5">
             <a:extLst>
               <a:ext uri="{FF2B5EF4-FFF2-40B4-BE49-F238E27FC236}">
-                <a16:creationId xmlns:a16="http://schemas.microsoft.com/office/drawing/2014/main" id="{C48EF13D-7AE6-8953-69B3-83C59244FC2C}"/>
+                <a16:creationId xmlns:a16="http://schemas.microsoft.com/office/drawing/2014/main" id="{96F2C16F-2AAB-98A5-8CE6-3C9474AC2815}"/>
               </a:ext>
             </a:extLst>
           </p:cNvPr>
@@ -6847,7 +6847,7 @@
           <p:cNvPr id="7" name="Group members - intentionally blank">
             <a:extLst>
               <a:ext uri="{FF2B5EF4-FFF2-40B4-BE49-F238E27FC236}">
-                <a16:creationId xmlns:a16="http://schemas.microsoft.com/office/drawing/2014/main" id="{21C7BE2A-8F4B-54BB-72E4-0EEBBF73662B}"/>
+                <a16:creationId xmlns:a16="http://schemas.microsoft.com/office/drawing/2014/main" id="{FFE98996-A5AD-E626-A6D9-705EFF09BE49}"/>
               </a:ext>
             </a:extLst>
           </p:cNvPr>
@@ -6887,7 +6887,7 @@
     </p:spTree>
     <p:extLst>
       <p:ext uri="{BB962C8B-B14F-4D97-AF65-F5344CB8AC3E}">
-        <p14:creationId xmlns:p14="http://schemas.microsoft.com/office/powerpoint/2010/main" val="2055212723"/>
+        <p14:creationId xmlns:p14="http://schemas.microsoft.com/office/powerpoint/2010/main" val="1392393877"/>
       </p:ext>
     </p:extLst>
   </p:cSld>
@@ -6927,7 +6927,7 @@
           <p:cNvPr id="2" name="TextBox 1">
             <a:extLst>
               <a:ext uri="{FF2B5EF4-FFF2-40B4-BE49-F238E27FC236}">
-                <a16:creationId xmlns:a16="http://schemas.microsoft.com/office/drawing/2014/main" id="{751D164D-A33A-9BF3-ABDF-FB8C970CD2B5}"/>
+                <a16:creationId xmlns:a16="http://schemas.microsoft.com/office/drawing/2014/main" id="{5E7B17DE-A084-E032-0395-9D32F90AECEA}"/>
               </a:ext>
             </a:extLst>
           </p:cNvPr>
@@ -6978,7 +6978,7 @@
           <p:cNvPr id="3" name="TextBox 2">
             <a:extLst>
               <a:ext uri="{FF2B5EF4-FFF2-40B4-BE49-F238E27FC236}">
-                <a16:creationId xmlns:a16="http://schemas.microsoft.com/office/drawing/2014/main" id="{AA96D082-2834-3957-1127-002407B9FA8F}"/>
+                <a16:creationId xmlns:a16="http://schemas.microsoft.com/office/drawing/2014/main" id="{300C3DB2-3282-10E9-D374-A2101C465DC0}"/>
               </a:ext>
             </a:extLst>
           </p:cNvPr>
@@ -7023,7 +7023,7 @@
           <p:cNvPr id="4" name="TextBox 3">
             <a:extLst>
               <a:ext uri="{FF2B5EF4-FFF2-40B4-BE49-F238E27FC236}">
-                <a16:creationId xmlns:a16="http://schemas.microsoft.com/office/drawing/2014/main" id="{0B11BD4F-8B4E-3F85-5AA8-FAFDF56A074E}"/>
+                <a16:creationId xmlns:a16="http://schemas.microsoft.com/office/drawing/2014/main" id="{C4B26C05-D0EC-2AD7-AF40-7FD41BBAC1C0}"/>
               </a:ext>
             </a:extLst>
           </p:cNvPr>
@@ -7074,7 +7074,7 @@
           <p:cNvPr id="5" name="TextBox 4">
             <a:extLst>
               <a:ext uri="{FF2B5EF4-FFF2-40B4-BE49-F238E27FC236}">
-                <a16:creationId xmlns:a16="http://schemas.microsoft.com/office/drawing/2014/main" id="{D5B3335E-88B0-AFBF-EFCE-B14BD4F9898E}"/>
+                <a16:creationId xmlns:a16="http://schemas.microsoft.com/office/drawing/2014/main" id="{07E92AAD-BEA4-5A9A-358C-CA9BB118A928}"/>
               </a:ext>
             </a:extLst>
           </p:cNvPr>
@@ -7139,7 +7139,7 @@
     </p:spTree>
     <p:extLst>
       <p:ext uri="{BB962C8B-B14F-4D97-AF65-F5344CB8AC3E}">
-        <p14:creationId xmlns:p14="http://schemas.microsoft.com/office/powerpoint/2010/main" val="3654952684"/>
+        <p14:creationId xmlns:p14="http://schemas.microsoft.com/office/powerpoint/2010/main" val="2411994209"/>
       </p:ext>
     </p:extLst>
   </p:cSld>
@@ -7179,7 +7179,7 @@
           <p:cNvPr id="2" name="TextBox 1">
             <a:extLst>
               <a:ext uri="{FF2B5EF4-FFF2-40B4-BE49-F238E27FC236}">
-                <a16:creationId xmlns:a16="http://schemas.microsoft.com/office/drawing/2014/main" id="{587DF2DE-BD58-209D-6CC1-9960961C5B63}"/>
+                <a16:creationId xmlns:a16="http://schemas.microsoft.com/office/drawing/2014/main" id="{B2CE0984-9E0F-C13C-FCB5-9C8F9181A5CF}"/>
               </a:ext>
             </a:extLst>
           </p:cNvPr>
@@ -7224,7 +7224,7 @@
           <p:cNvPr id="3" name="TextBox 2">
             <a:extLst>
               <a:ext uri="{FF2B5EF4-FFF2-40B4-BE49-F238E27FC236}">
-                <a16:creationId xmlns:a16="http://schemas.microsoft.com/office/drawing/2014/main" id="{79B77691-D473-38E2-2ABA-022DE29CE1E9}"/>
+                <a16:creationId xmlns:a16="http://schemas.microsoft.com/office/drawing/2014/main" id="{542E7C0A-ABF6-C5E3-E310-6B9B7AB3FA7F}"/>
               </a:ext>
             </a:extLst>
           </p:cNvPr>
@@ -7269,7 +7269,7 @@
           <p:cNvPr id="4" name="Table 3">
             <a:extLst>
               <a:ext uri="{FF2B5EF4-FFF2-40B4-BE49-F238E27FC236}">
-                <a16:creationId xmlns:a16="http://schemas.microsoft.com/office/drawing/2014/main" id="{05D4C3E2-21D5-71D4-6B0C-DAAD63CBA139}"/>
+                <a16:creationId xmlns:a16="http://schemas.microsoft.com/office/drawing/2014/main" id="{1500F6A6-4C7C-6A63-F876-2824FF769D5C}"/>
               </a:ext>
             </a:extLst>
           </p:cNvPr>
@@ -7279,7 +7279,7 @@
           <p:nvPr>
             <p:extLst>
               <p:ext uri="{D42A27DB-BD31-4B8C-83A1-F6EECF244321}">
-                <p14:modId xmlns:p14="http://schemas.microsoft.com/office/powerpoint/2010/main" val="1809112786"/>
+                <p14:modId xmlns:p14="http://schemas.microsoft.com/office/powerpoint/2010/main" val="2735347984"/>
               </p:ext>
             </p:extLst>
           </p:nvPr>
@@ -7298,21 +7298,21 @@
                 <a:gridCol w="5486400">
                   <a:extLst>
                     <a:ext uri="{9D8B030D-6E8A-4147-A177-3AD203B41FA5}">
-                      <a16:colId xmlns:a16="http://schemas.microsoft.com/office/drawing/2014/main" val="1260507510"/>
+                      <a16:colId xmlns:a16="http://schemas.microsoft.com/office/drawing/2014/main" val="3113583335"/>
                     </a:ext>
                   </a:extLst>
                 </a:gridCol>
                 <a:gridCol w="2743200">
                   <a:extLst>
                     <a:ext uri="{9D8B030D-6E8A-4147-A177-3AD203B41FA5}">
-                      <a16:colId xmlns:a16="http://schemas.microsoft.com/office/drawing/2014/main" val="3794802723"/>
+                      <a16:colId xmlns:a16="http://schemas.microsoft.com/office/drawing/2014/main" val="2187291762"/>
                     </a:ext>
                   </a:extLst>
                 </a:gridCol>
                 <a:gridCol w="2743200">
                   <a:extLst>
                     <a:ext uri="{9D8B030D-6E8A-4147-A177-3AD203B41FA5}">
-                      <a16:colId xmlns:a16="http://schemas.microsoft.com/office/drawing/2014/main" val="2251797591"/>
+                      <a16:colId xmlns:a16="http://schemas.microsoft.com/office/drawing/2014/main" val="1787845863"/>
                     </a:ext>
                   </a:extLst>
                 </a:gridCol>
@@ -7386,7 +7386,7 @@
                 </a:tc>
                 <a:extLst>
                   <a:ext uri="{0D108BD9-81ED-4DB2-BD59-A6C34878D82A}">
-                    <a16:rowId xmlns:a16="http://schemas.microsoft.com/office/drawing/2014/main" val="2078827982"/>
+                    <a16:rowId xmlns:a16="http://schemas.microsoft.com/office/drawing/2014/main" val="2388410184"/>
                   </a:ext>
                 </a:extLst>
               </a:tr>
@@ -7459,7 +7459,7 @@
                 </a:tc>
                 <a:extLst>
                   <a:ext uri="{0D108BD9-81ED-4DB2-BD59-A6C34878D82A}">
-                    <a16:rowId xmlns:a16="http://schemas.microsoft.com/office/drawing/2014/main" val="2158650463"/>
+                    <a16:rowId xmlns:a16="http://schemas.microsoft.com/office/drawing/2014/main" val="3551106763"/>
                   </a:ext>
                 </a:extLst>
               </a:tr>
@@ -7532,7 +7532,7 @@
                 </a:tc>
                 <a:extLst>
                   <a:ext uri="{0D108BD9-81ED-4DB2-BD59-A6C34878D82A}">
-                    <a16:rowId xmlns:a16="http://schemas.microsoft.com/office/drawing/2014/main" val="1176406551"/>
+                    <a16:rowId xmlns:a16="http://schemas.microsoft.com/office/drawing/2014/main" val="2966069229"/>
                   </a:ext>
                 </a:extLst>
               </a:tr>
@@ -7605,7 +7605,7 @@
                 </a:tc>
                 <a:extLst>
                   <a:ext uri="{0D108BD9-81ED-4DB2-BD59-A6C34878D82A}">
-                    <a16:rowId xmlns:a16="http://schemas.microsoft.com/office/drawing/2014/main" val="55737995"/>
+                    <a16:rowId xmlns:a16="http://schemas.microsoft.com/office/drawing/2014/main" val="2885859154"/>
                   </a:ext>
                 </a:extLst>
               </a:tr>
@@ -7678,7 +7678,7 @@
                 </a:tc>
                 <a:extLst>
                   <a:ext uri="{0D108BD9-81ED-4DB2-BD59-A6C34878D82A}">
-                    <a16:rowId xmlns:a16="http://schemas.microsoft.com/office/drawing/2014/main" val="1116906577"/>
+                    <a16:rowId xmlns:a16="http://schemas.microsoft.com/office/drawing/2014/main" val="4060262858"/>
                   </a:ext>
                 </a:extLst>
               </a:tr>
@@ -7691,7 +7691,7 @@
           <p:cNvPr id="5" name="TextBox 4">
             <a:extLst>
               <a:ext uri="{FF2B5EF4-FFF2-40B4-BE49-F238E27FC236}">
-                <a16:creationId xmlns:a16="http://schemas.microsoft.com/office/drawing/2014/main" id="{2E564969-358C-326C-808A-1E6CDDF737A1}"/>
+                <a16:creationId xmlns:a16="http://schemas.microsoft.com/office/drawing/2014/main" id="{20826404-E9A3-963B-1504-8BE303D9F0E5}"/>
               </a:ext>
             </a:extLst>
           </p:cNvPr>
@@ -7700,8 +7700,8 @@
         </p:nvSpPr>
         <p:spPr>
           <a:xfrm>
-            <a:off x="609600" y="4533899"/>
-            <a:ext cx="10972800" cy="1016000"/>
+            <a:off x="609600" y="4381499"/>
+            <a:ext cx="10972800" cy="1371600"/>
           </a:xfrm>
           <a:prstGeom prst="rect">
             <a:avLst/>
@@ -7720,16 +7720,17 @@
               </a:spcAft>
             </a:pPr>
             <a:r>
-              <a:rPr lang="en-US" sz="2500" b="1">
+              <a:rPr lang="en-US" sz="2100" b="1">
                 <a:solidFill>
                   <a:srgbClr val="20364A"/>
                 </a:solidFill>
                 <a:latin typeface="Aptos" panose="020B0004020202020204" pitchFamily="34" charset="0"/>
               </a:rPr>
-              <a:t>Retain frozen fusion as the primary study model.
-Confirm DINOv2 on new sources before a deployment decision.</a:t>
-            </a:r>
-            <a:endParaRPr lang="en-ZA" sz="2500" b="1">
+              <a:t>Provisionally recommend fine-tuned DINOv2 for classroom use
+with comparable renders; retain fusion as the predeclared study primary;
+independently confirm before broader deployment.</a:t>
+            </a:r>
+            <a:endParaRPr lang="en-ZA" sz="2100" b="1">
               <a:solidFill>
                 <a:srgbClr val="20364A"/>
               </a:solidFill>
@@ -7743,7 +7744,7 @@
           <p:cNvPr id="6" name="TextBox 5">
             <a:extLst>
               <a:ext uri="{FF2B5EF4-FFF2-40B4-BE49-F238E27FC236}">
-                <a16:creationId xmlns:a16="http://schemas.microsoft.com/office/drawing/2014/main" id="{DA9C1E73-708B-A714-F960-4A8EBB38D96E}"/>
+                <a16:creationId xmlns:a16="http://schemas.microsoft.com/office/drawing/2014/main" id="{34F36C0C-7BBD-4A4C-8CBE-D46A85B98AAA}"/>
               </a:ext>
             </a:extLst>
           </p:cNvPr>
@@ -7787,7 +7788,7 @@
     </p:spTree>
     <p:extLst>
       <p:ext uri="{BB962C8B-B14F-4D97-AF65-F5344CB8AC3E}">
-        <p14:creationId xmlns:p14="http://schemas.microsoft.com/office/powerpoint/2010/main" val="2573893906"/>
+        <p14:creationId xmlns:p14="http://schemas.microsoft.com/office/powerpoint/2010/main" val="3526886879"/>
       </p:ext>
     </p:extLst>
   </p:cSld>
@@ -7827,7 +7828,7 @@
           <p:cNvPr id="2" name="TextBox 1">
             <a:extLst>
               <a:ext uri="{FF2B5EF4-FFF2-40B4-BE49-F238E27FC236}">
-                <a16:creationId xmlns:a16="http://schemas.microsoft.com/office/drawing/2014/main" id="{D3E70F2E-EDCA-AA40-8507-0C55F41615AD}"/>
+                <a16:creationId xmlns:a16="http://schemas.microsoft.com/office/drawing/2014/main" id="{58C9BBB2-6BB9-F6EA-C5A7-6CB0DD818CE9}"/>
               </a:ext>
             </a:extLst>
           </p:cNvPr>
@@ -7872,7 +7873,7 @@
           <p:cNvPr id="3" name="TextBox 2">
             <a:extLst>
               <a:ext uri="{FF2B5EF4-FFF2-40B4-BE49-F238E27FC236}">
-                <a16:creationId xmlns:a16="http://schemas.microsoft.com/office/drawing/2014/main" id="{C781764A-B8A7-B575-0E8F-8670F5101FA4}"/>
+                <a16:creationId xmlns:a16="http://schemas.microsoft.com/office/drawing/2014/main" id="{64C84866-CB79-9DD0-5167-423B1569BB03}"/>
               </a:ext>
             </a:extLst>
           </p:cNvPr>
@@ -7917,7 +7918,7 @@
           <p:cNvPr id="4" name="TextBox 3">
             <a:extLst>
               <a:ext uri="{FF2B5EF4-FFF2-40B4-BE49-F238E27FC236}">
-                <a16:creationId xmlns:a16="http://schemas.microsoft.com/office/drawing/2014/main" id="{5EA71C04-51BD-A3BB-8DF3-CCD7EF5EBEE6}"/>
+                <a16:creationId xmlns:a16="http://schemas.microsoft.com/office/drawing/2014/main" id="{52480B3F-026C-5B35-3AA6-5A7D757AED4B}"/>
               </a:ext>
             </a:extLst>
           </p:cNvPr>
@@ -7962,7 +7963,7 @@
           <p:cNvPr id="5" name="TextBox 4">
             <a:extLst>
               <a:ext uri="{FF2B5EF4-FFF2-40B4-BE49-F238E27FC236}">
-                <a16:creationId xmlns:a16="http://schemas.microsoft.com/office/drawing/2014/main" id="{84FB355A-0C20-8407-588C-7F9FC452553A}"/>
+                <a16:creationId xmlns:a16="http://schemas.microsoft.com/office/drawing/2014/main" id="{1C507FFC-E4B0-53BF-CDDC-E64C3E6AE754}"/>
               </a:ext>
             </a:extLst>
           </p:cNvPr>
@@ -8015,7 +8016,7 @@
           <p:cNvPr id="6" name="TextBox 5">
             <a:extLst>
               <a:ext uri="{FF2B5EF4-FFF2-40B4-BE49-F238E27FC236}">
-                <a16:creationId xmlns:a16="http://schemas.microsoft.com/office/drawing/2014/main" id="{ACFB5D0E-8C4C-AE79-89C3-B9B151A5FF60}"/>
+                <a16:creationId xmlns:a16="http://schemas.microsoft.com/office/drawing/2014/main" id="{D09AB22C-0B5D-DAFB-41CF-F40E2C762887}"/>
               </a:ext>
             </a:extLst>
           </p:cNvPr>
@@ -8060,7 +8061,7 @@
           <p:cNvPr id="7" name="TextBox 6">
             <a:extLst>
               <a:ext uri="{FF2B5EF4-FFF2-40B4-BE49-F238E27FC236}">
-                <a16:creationId xmlns:a16="http://schemas.microsoft.com/office/drawing/2014/main" id="{FA4FAF90-1632-622E-2696-989E64CC55F2}"/>
+                <a16:creationId xmlns:a16="http://schemas.microsoft.com/office/drawing/2014/main" id="{7B29F127-5EA8-1BBC-87AF-3D7B5813DB6B}"/>
               </a:ext>
             </a:extLst>
           </p:cNvPr>
@@ -8113,7 +8114,7 @@
           <p:cNvPr id="8" name="TextBox 7">
             <a:extLst>
               <a:ext uri="{FF2B5EF4-FFF2-40B4-BE49-F238E27FC236}">
-                <a16:creationId xmlns:a16="http://schemas.microsoft.com/office/drawing/2014/main" id="{7F6A116F-77B9-07C3-EC8F-EC8442F04F90}"/>
+                <a16:creationId xmlns:a16="http://schemas.microsoft.com/office/drawing/2014/main" id="{334F19D1-8C5A-C098-450B-2225A6941EE2}"/>
               </a:ext>
             </a:extLst>
           </p:cNvPr>
@@ -8165,7 +8166,7 @@
           <p:cNvPr id="9" name="TextBox 8">
             <a:extLst>
               <a:ext uri="{FF2B5EF4-FFF2-40B4-BE49-F238E27FC236}">
-                <a16:creationId xmlns:a16="http://schemas.microsoft.com/office/drawing/2014/main" id="{93BBADED-4164-6BAD-EA22-71227D230F0F}"/>
+                <a16:creationId xmlns:a16="http://schemas.microsoft.com/office/drawing/2014/main" id="{16635277-8B02-F6D4-C901-6920CB211591}"/>
               </a:ext>
             </a:extLst>
           </p:cNvPr>
@@ -8214,7 +8215,7 @@
     </p:spTree>
     <p:extLst>
       <p:ext uri="{BB962C8B-B14F-4D97-AF65-F5344CB8AC3E}">
-        <p14:creationId xmlns:p14="http://schemas.microsoft.com/office/powerpoint/2010/main" val="1172129099"/>
+        <p14:creationId xmlns:p14="http://schemas.microsoft.com/office/powerpoint/2010/main" val="3781276397"/>
       </p:ext>
     </p:extLst>
   </p:cSld>
@@ -8254,7 +8255,7 @@
           <p:cNvPr id="2" name="TextBox 1">
             <a:extLst>
               <a:ext uri="{FF2B5EF4-FFF2-40B4-BE49-F238E27FC236}">
-                <a16:creationId xmlns:a16="http://schemas.microsoft.com/office/drawing/2014/main" id="{3B6CED88-1FD4-85B1-CE27-3CB889BCE743}"/>
+                <a16:creationId xmlns:a16="http://schemas.microsoft.com/office/drawing/2014/main" id="{105FAE22-DC02-ABB9-43FC-3737899C52FA}"/>
               </a:ext>
             </a:extLst>
           </p:cNvPr>
@@ -8299,7 +8300,7 @@
           <p:cNvPr id="3" name="TextBox 2">
             <a:extLst>
               <a:ext uri="{FF2B5EF4-FFF2-40B4-BE49-F238E27FC236}">
-                <a16:creationId xmlns:a16="http://schemas.microsoft.com/office/drawing/2014/main" id="{E1FAD77E-0F56-FB3A-F765-AB354E89D858}"/>
+                <a16:creationId xmlns:a16="http://schemas.microsoft.com/office/drawing/2014/main" id="{BFE54D0C-1DC9-7719-F128-B25C424D7311}"/>
               </a:ext>
             </a:extLst>
           </p:cNvPr>
@@ -8344,7 +8345,7 @@
           <p:cNvPr id="4" name="TextBox 3">
             <a:extLst>
               <a:ext uri="{FF2B5EF4-FFF2-40B4-BE49-F238E27FC236}">
-                <a16:creationId xmlns:a16="http://schemas.microsoft.com/office/drawing/2014/main" id="{A3D01386-9D8D-EDB9-5579-43190780E89F}"/>
+                <a16:creationId xmlns:a16="http://schemas.microsoft.com/office/drawing/2014/main" id="{58A176E5-8BB7-DBFC-3BD7-7C999167C5F5}"/>
               </a:ext>
             </a:extLst>
           </p:cNvPr>
@@ -8389,7 +8390,7 @@
           <p:cNvPr id="5" name="TextBox 4">
             <a:extLst>
               <a:ext uri="{FF2B5EF4-FFF2-40B4-BE49-F238E27FC236}">
-                <a16:creationId xmlns:a16="http://schemas.microsoft.com/office/drawing/2014/main" id="{5FD7EA3F-9E37-B876-F7CE-931C31CFC0AF}"/>
+                <a16:creationId xmlns:a16="http://schemas.microsoft.com/office/drawing/2014/main" id="{F872A7B3-C07C-45B2-6531-03BB92632973}"/>
               </a:ext>
             </a:extLst>
           </p:cNvPr>
@@ -8442,7 +8443,7 @@
           <p:cNvPr id="6" name="TextBox 5">
             <a:extLst>
               <a:ext uri="{FF2B5EF4-FFF2-40B4-BE49-F238E27FC236}">
-                <a16:creationId xmlns:a16="http://schemas.microsoft.com/office/drawing/2014/main" id="{B4C0AEAB-D92F-D7EE-FAC3-A2BE85922C77}"/>
+                <a16:creationId xmlns:a16="http://schemas.microsoft.com/office/drawing/2014/main" id="{B8125495-D57B-4E53-A93C-4E0814A8F405}"/>
               </a:ext>
             </a:extLst>
           </p:cNvPr>
@@ -8487,7 +8488,7 @@
           <p:cNvPr id="7" name="TextBox 6">
             <a:extLst>
               <a:ext uri="{FF2B5EF4-FFF2-40B4-BE49-F238E27FC236}">
-                <a16:creationId xmlns:a16="http://schemas.microsoft.com/office/drawing/2014/main" id="{6C1BC5A9-8CCD-CDF7-7029-F375589D46EF}"/>
+                <a16:creationId xmlns:a16="http://schemas.microsoft.com/office/drawing/2014/main" id="{4946A15A-89A1-8CD1-0B3B-81920D97CEAC}"/>
               </a:ext>
             </a:extLst>
           </p:cNvPr>
@@ -8540,7 +8541,7 @@
           <p:cNvPr id="8" name="TextBox 7">
             <a:extLst>
               <a:ext uri="{FF2B5EF4-FFF2-40B4-BE49-F238E27FC236}">
-                <a16:creationId xmlns:a16="http://schemas.microsoft.com/office/drawing/2014/main" id="{0F02B37F-2178-9B6C-064E-D4AD7666B40C}"/>
+                <a16:creationId xmlns:a16="http://schemas.microsoft.com/office/drawing/2014/main" id="{67C0BF7C-04D8-5E2D-4BF9-FA7E04A34E82}"/>
               </a:ext>
             </a:extLst>
           </p:cNvPr>
@@ -8585,7 +8586,7 @@
           <p:cNvPr id="9" name="TextBox 8">
             <a:extLst>
               <a:ext uri="{FF2B5EF4-FFF2-40B4-BE49-F238E27FC236}">
-                <a16:creationId xmlns:a16="http://schemas.microsoft.com/office/drawing/2014/main" id="{B26E8F8B-01A3-5474-12A0-C21927BF672A}"/>
+                <a16:creationId xmlns:a16="http://schemas.microsoft.com/office/drawing/2014/main" id="{8033E54E-F626-61EA-CA46-A0533BED3417}"/>
               </a:ext>
             </a:extLst>
           </p:cNvPr>
@@ -8638,7 +8639,7 @@
           <p:cNvPr id="10" name="TextBox 9">
             <a:extLst>
               <a:ext uri="{FF2B5EF4-FFF2-40B4-BE49-F238E27FC236}">
-                <a16:creationId xmlns:a16="http://schemas.microsoft.com/office/drawing/2014/main" id="{BB20ABD3-65B5-C9C5-6AA6-62D8FEAFD051}"/>
+                <a16:creationId xmlns:a16="http://schemas.microsoft.com/office/drawing/2014/main" id="{AD06EA9E-71DF-4036-D300-881663EA7358}"/>
               </a:ext>
             </a:extLst>
           </p:cNvPr>
@@ -8690,7 +8691,7 @@
           <p:cNvPr id="11" name="TextBox 10">
             <a:extLst>
               <a:ext uri="{FF2B5EF4-FFF2-40B4-BE49-F238E27FC236}">
-                <a16:creationId xmlns:a16="http://schemas.microsoft.com/office/drawing/2014/main" id="{D10852D7-8973-25B0-0B99-4D70B16B002D}"/>
+                <a16:creationId xmlns:a16="http://schemas.microsoft.com/office/drawing/2014/main" id="{322B9BAC-D19B-C8C4-F07C-BF9F73F4C707}"/>
               </a:ext>
             </a:extLst>
           </p:cNvPr>
@@ -8739,7 +8740,7 @@
     </p:spTree>
     <p:extLst>
       <p:ext uri="{BB962C8B-B14F-4D97-AF65-F5344CB8AC3E}">
-        <p14:creationId xmlns:p14="http://schemas.microsoft.com/office/powerpoint/2010/main" val="3218181911"/>
+        <p14:creationId xmlns:p14="http://schemas.microsoft.com/office/powerpoint/2010/main" val="2026363235"/>
       </p:ext>
     </p:extLst>
   </p:cSld>
@@ -8779,7 +8780,7 @@
           <p:cNvPr id="2" name="TextBox 1">
             <a:extLst>
               <a:ext uri="{FF2B5EF4-FFF2-40B4-BE49-F238E27FC236}">
-                <a16:creationId xmlns:a16="http://schemas.microsoft.com/office/drawing/2014/main" id="{F48866D4-1545-E212-C143-5A17202CE5FE}"/>
+                <a16:creationId xmlns:a16="http://schemas.microsoft.com/office/drawing/2014/main" id="{D3D95891-6279-B8EF-5D99-501A0CE15598}"/>
               </a:ext>
             </a:extLst>
           </p:cNvPr>
@@ -8824,7 +8825,7 @@
           <p:cNvPr id="3" name="TextBox 2">
             <a:extLst>
               <a:ext uri="{FF2B5EF4-FFF2-40B4-BE49-F238E27FC236}">
-                <a16:creationId xmlns:a16="http://schemas.microsoft.com/office/drawing/2014/main" id="{4B1821FA-55EF-4E7C-E215-2F90E34D9D00}"/>
+                <a16:creationId xmlns:a16="http://schemas.microsoft.com/office/drawing/2014/main" id="{ECC295BC-DD32-CC08-280F-4B3C867AA27A}"/>
               </a:ext>
             </a:extLst>
           </p:cNvPr>
@@ -8869,7 +8870,7 @@
           <p:cNvPr id="4" name="TextBox 3">
             <a:extLst>
               <a:ext uri="{FF2B5EF4-FFF2-40B4-BE49-F238E27FC236}">
-                <a16:creationId xmlns:a16="http://schemas.microsoft.com/office/drawing/2014/main" id="{D60880F0-2AA9-62CE-4330-87A3C8E5085B}"/>
+                <a16:creationId xmlns:a16="http://schemas.microsoft.com/office/drawing/2014/main" id="{76886ACD-BD81-521A-BC7E-7A197785D322}"/>
               </a:ext>
             </a:extLst>
           </p:cNvPr>
@@ -8920,7 +8921,7 @@
           <p:cNvPr id="5" name="TextBox 4">
             <a:extLst>
               <a:ext uri="{FF2B5EF4-FFF2-40B4-BE49-F238E27FC236}">
-                <a16:creationId xmlns:a16="http://schemas.microsoft.com/office/drawing/2014/main" id="{5C065F32-5413-D90D-471C-D7B9DAFE0BF2}"/>
+                <a16:creationId xmlns:a16="http://schemas.microsoft.com/office/drawing/2014/main" id="{19142413-A71E-5A8D-7C05-C45B9B44337B}"/>
               </a:ext>
             </a:extLst>
           </p:cNvPr>
@@ -8965,7 +8966,7 @@
           <p:cNvPr id="6" name="TextBox 5">
             <a:extLst>
               <a:ext uri="{FF2B5EF4-FFF2-40B4-BE49-F238E27FC236}">
-                <a16:creationId xmlns:a16="http://schemas.microsoft.com/office/drawing/2014/main" id="{9E164777-3BA7-2C39-0F4B-8A1C1CDF6C33}"/>
+                <a16:creationId xmlns:a16="http://schemas.microsoft.com/office/drawing/2014/main" id="{610F6464-8E2F-75FF-1A3C-0F67D02C71F9}"/>
               </a:ext>
             </a:extLst>
           </p:cNvPr>
@@ -9010,7 +9011,7 @@
           <p:cNvPr id="7" name="TextBox 6">
             <a:extLst>
               <a:ext uri="{FF2B5EF4-FFF2-40B4-BE49-F238E27FC236}">
-                <a16:creationId xmlns:a16="http://schemas.microsoft.com/office/drawing/2014/main" id="{07772DD0-95FD-4428-AB6E-A43B2A84E779}"/>
+                <a16:creationId xmlns:a16="http://schemas.microsoft.com/office/drawing/2014/main" id="{0F6BB773-4CF5-E40B-C3B3-371B43A9B11A}"/>
               </a:ext>
             </a:extLst>
           </p:cNvPr>
@@ -9055,7 +9056,7 @@
           <p:cNvPr id="8" name="TextBox 7">
             <a:extLst>
               <a:ext uri="{FF2B5EF4-FFF2-40B4-BE49-F238E27FC236}">
-                <a16:creationId xmlns:a16="http://schemas.microsoft.com/office/drawing/2014/main" id="{42E99831-582F-A7BD-A703-83024D414764}"/>
+                <a16:creationId xmlns:a16="http://schemas.microsoft.com/office/drawing/2014/main" id="{FD97C878-6F79-F621-502A-3B9276E5DA69}"/>
               </a:ext>
             </a:extLst>
           </p:cNvPr>
@@ -9106,7 +9107,7 @@
           <p:cNvPr id="9" name="TextBox 8">
             <a:extLst>
               <a:ext uri="{FF2B5EF4-FFF2-40B4-BE49-F238E27FC236}">
-                <a16:creationId xmlns:a16="http://schemas.microsoft.com/office/drawing/2014/main" id="{631142C7-96B4-404D-EB46-FCBD2FD6E9BE}"/>
+                <a16:creationId xmlns:a16="http://schemas.microsoft.com/office/drawing/2014/main" id="{CC0FFAE5-FAC6-2584-1019-321A5ED930C0}"/>
               </a:ext>
             </a:extLst>
           </p:cNvPr>
@@ -9151,7 +9152,7 @@
           <p:cNvPr id="10" name="TextBox 9">
             <a:extLst>
               <a:ext uri="{FF2B5EF4-FFF2-40B4-BE49-F238E27FC236}">
-                <a16:creationId xmlns:a16="http://schemas.microsoft.com/office/drawing/2014/main" id="{2EF2C7F6-6AB2-3540-BD63-12C600CEE6C6}"/>
+                <a16:creationId xmlns:a16="http://schemas.microsoft.com/office/drawing/2014/main" id="{BB1FBD92-1DD1-5D3A-84A5-7A26A50251CA}"/>
               </a:ext>
             </a:extLst>
           </p:cNvPr>
@@ -9202,7 +9203,7 @@
           <p:cNvPr id="11" name="TextBox 10">
             <a:extLst>
               <a:ext uri="{FF2B5EF4-FFF2-40B4-BE49-F238E27FC236}">
-                <a16:creationId xmlns:a16="http://schemas.microsoft.com/office/drawing/2014/main" id="{866F21C5-54ED-1E59-903B-6BD8D073ED42}"/>
+                <a16:creationId xmlns:a16="http://schemas.microsoft.com/office/drawing/2014/main" id="{18F4D895-1D1B-DA38-7F5C-30E86F70E0E5}"/>
               </a:ext>
             </a:extLst>
           </p:cNvPr>
@@ -9247,7 +9248,7 @@
           <p:cNvPr id="12" name="TextBox 11">
             <a:extLst>
               <a:ext uri="{FF2B5EF4-FFF2-40B4-BE49-F238E27FC236}">
-                <a16:creationId xmlns:a16="http://schemas.microsoft.com/office/drawing/2014/main" id="{231EC177-94CA-E6A1-3244-949668F9EC6F}"/>
+                <a16:creationId xmlns:a16="http://schemas.microsoft.com/office/drawing/2014/main" id="{D4AD8DEC-DAE2-0FAE-A868-A65AAEBF1040}"/>
               </a:ext>
             </a:extLst>
           </p:cNvPr>
@@ -9298,7 +9299,7 @@
           <p:cNvPr id="13" name="TextBox 12">
             <a:extLst>
               <a:ext uri="{FF2B5EF4-FFF2-40B4-BE49-F238E27FC236}">
-                <a16:creationId xmlns:a16="http://schemas.microsoft.com/office/drawing/2014/main" id="{AD8A0473-F4BF-70E9-2D99-C2FC5F94769D}"/>
+                <a16:creationId xmlns:a16="http://schemas.microsoft.com/office/drawing/2014/main" id="{F8AD5406-2F23-D6B4-18D7-DB5D38197CF9}"/>
               </a:ext>
             </a:extLst>
           </p:cNvPr>
@@ -9349,7 +9350,7 @@
           <p:cNvPr id="14" name="TextBox 13">
             <a:extLst>
               <a:ext uri="{FF2B5EF4-FFF2-40B4-BE49-F238E27FC236}">
-                <a16:creationId xmlns:a16="http://schemas.microsoft.com/office/drawing/2014/main" id="{2F746A54-44F5-FCA3-B630-5E6C6C98F4BB}"/>
+                <a16:creationId xmlns:a16="http://schemas.microsoft.com/office/drawing/2014/main" id="{FFB488D5-456E-28DA-1843-9097A303A547}"/>
               </a:ext>
             </a:extLst>
           </p:cNvPr>
@@ -9400,7 +9401,7 @@
           <p:cNvPr id="15" name="TextBox 14">
             <a:extLst>
               <a:ext uri="{FF2B5EF4-FFF2-40B4-BE49-F238E27FC236}">
-                <a16:creationId xmlns:a16="http://schemas.microsoft.com/office/drawing/2014/main" id="{355D3739-0784-45C8-FA0C-9ED199B9B4FB}"/>
+                <a16:creationId xmlns:a16="http://schemas.microsoft.com/office/drawing/2014/main" id="{AE9FC75F-0A49-9773-B0A2-AE63ED347CF6}"/>
               </a:ext>
             </a:extLst>
           </p:cNvPr>
@@ -9451,7 +9452,7 @@
           <p:cNvPr id="16" name="TextBox 15">
             <a:extLst>
               <a:ext uri="{FF2B5EF4-FFF2-40B4-BE49-F238E27FC236}">
-                <a16:creationId xmlns:a16="http://schemas.microsoft.com/office/drawing/2014/main" id="{4BDA3699-CB46-3F08-BD60-2C6476AD0BFF}"/>
+                <a16:creationId xmlns:a16="http://schemas.microsoft.com/office/drawing/2014/main" id="{A19260D9-7307-ABBA-BD53-2EA5E32EFF31}"/>
               </a:ext>
             </a:extLst>
           </p:cNvPr>
@@ -9501,7 +9502,7 @@
     </p:spTree>
     <p:extLst>
       <p:ext uri="{BB962C8B-B14F-4D97-AF65-F5344CB8AC3E}">
-        <p14:creationId xmlns:p14="http://schemas.microsoft.com/office/powerpoint/2010/main" val="3304066797"/>
+        <p14:creationId xmlns:p14="http://schemas.microsoft.com/office/powerpoint/2010/main" val="2740864315"/>
       </p:ext>
     </p:extLst>
   </p:cSld>
@@ -9541,7 +9542,7 @@
           <p:cNvPr id="2" name="TextBox 1">
             <a:extLst>
               <a:ext uri="{FF2B5EF4-FFF2-40B4-BE49-F238E27FC236}">
-                <a16:creationId xmlns:a16="http://schemas.microsoft.com/office/drawing/2014/main" id="{E9500261-FF66-61EE-02D9-EDFEFA7F9C63}"/>
+                <a16:creationId xmlns:a16="http://schemas.microsoft.com/office/drawing/2014/main" id="{EA6FF4F8-AE4C-E192-F9B6-C0B430E6F276}"/>
               </a:ext>
             </a:extLst>
           </p:cNvPr>
@@ -9592,7 +9593,7 @@
           <p:cNvPr id="3" name="TextBox 2">
             <a:extLst>
               <a:ext uri="{FF2B5EF4-FFF2-40B4-BE49-F238E27FC236}">
-                <a16:creationId xmlns:a16="http://schemas.microsoft.com/office/drawing/2014/main" id="{5E00A4C0-1054-76DB-A8A7-916D7BFCDF81}"/>
+                <a16:creationId xmlns:a16="http://schemas.microsoft.com/office/drawing/2014/main" id="{4723D837-FE25-D033-51E9-89C008B84F76}"/>
               </a:ext>
             </a:extLst>
           </p:cNvPr>
@@ -9637,7 +9638,7 @@
           <p:cNvPr id="4" name="TextBox 3">
             <a:extLst>
               <a:ext uri="{FF2B5EF4-FFF2-40B4-BE49-F238E27FC236}">
-                <a16:creationId xmlns:a16="http://schemas.microsoft.com/office/drawing/2014/main" id="{6B1D205A-5BBE-72B6-57FD-FAB3131CBEC8}"/>
+                <a16:creationId xmlns:a16="http://schemas.microsoft.com/office/drawing/2014/main" id="{FC97A30F-F941-43B1-CB8F-9C77993811C5}"/>
               </a:ext>
             </a:extLst>
           </p:cNvPr>
@@ -9688,7 +9689,7 @@
           <p:cNvPr id="6" name="Picture 5">
             <a:extLst>
               <a:ext uri="{FF2B5EF4-FFF2-40B4-BE49-F238E27FC236}">
-                <a16:creationId xmlns:a16="http://schemas.microsoft.com/office/drawing/2014/main" id="{AA0CB881-7AA6-74A5-F8FD-84530F954C06}"/>
+                <a16:creationId xmlns:a16="http://schemas.microsoft.com/office/drawing/2014/main" id="{57653C2D-12DD-A500-5D0F-A5F3E7589978}"/>
               </a:ext>
             </a:extLst>
           </p:cNvPr>
@@ -9724,7 +9725,7 @@
           <p:cNvPr id="7" name="TextBox 6">
             <a:extLst>
               <a:ext uri="{FF2B5EF4-FFF2-40B4-BE49-F238E27FC236}">
-                <a16:creationId xmlns:a16="http://schemas.microsoft.com/office/drawing/2014/main" id="{27CC06C3-C776-81B3-D584-82D0873D251A}"/>
+                <a16:creationId xmlns:a16="http://schemas.microsoft.com/office/drawing/2014/main" id="{1055D9AD-D8BB-EF4C-F214-8682277FCA5A}"/>
               </a:ext>
             </a:extLst>
           </p:cNvPr>
@@ -9769,7 +9770,7 @@
           <p:cNvPr id="9" name="Picture 8">
             <a:extLst>
               <a:ext uri="{FF2B5EF4-FFF2-40B4-BE49-F238E27FC236}">
-                <a16:creationId xmlns:a16="http://schemas.microsoft.com/office/drawing/2014/main" id="{317034C0-3A41-2E9E-2826-AD948753F7B6}"/>
+                <a16:creationId xmlns:a16="http://schemas.microsoft.com/office/drawing/2014/main" id="{619E765F-157B-5357-E4E3-F48DA570C3AA}"/>
               </a:ext>
             </a:extLst>
           </p:cNvPr>
@@ -9805,7 +9806,7 @@
           <p:cNvPr id="10" name="TextBox 9">
             <a:extLst>
               <a:ext uri="{FF2B5EF4-FFF2-40B4-BE49-F238E27FC236}">
-                <a16:creationId xmlns:a16="http://schemas.microsoft.com/office/drawing/2014/main" id="{501550ED-98FF-427B-F3FB-FB5CADDBE019}"/>
+                <a16:creationId xmlns:a16="http://schemas.microsoft.com/office/drawing/2014/main" id="{63B788C6-D40C-AC0A-4D59-FC586FF7D099}"/>
               </a:ext>
             </a:extLst>
           </p:cNvPr>
@@ -9850,7 +9851,7 @@
           <p:cNvPr id="12" name="Picture 11">
             <a:extLst>
               <a:ext uri="{FF2B5EF4-FFF2-40B4-BE49-F238E27FC236}">
-                <a16:creationId xmlns:a16="http://schemas.microsoft.com/office/drawing/2014/main" id="{EEEE3341-86ED-248E-F10F-79056FDD2D95}"/>
+                <a16:creationId xmlns:a16="http://schemas.microsoft.com/office/drawing/2014/main" id="{0DEB6EA4-A3C9-D709-31B3-C5C67315C5F4}"/>
               </a:ext>
             </a:extLst>
           </p:cNvPr>
@@ -9886,7 +9887,7 @@
           <p:cNvPr id="13" name="TextBox 12">
             <a:extLst>
               <a:ext uri="{FF2B5EF4-FFF2-40B4-BE49-F238E27FC236}">
-                <a16:creationId xmlns:a16="http://schemas.microsoft.com/office/drawing/2014/main" id="{65057267-DAD3-6775-24D9-E30B8FA639DA}"/>
+                <a16:creationId xmlns:a16="http://schemas.microsoft.com/office/drawing/2014/main" id="{6372246E-D2F2-8FEC-A7C4-02E9CDA7AB51}"/>
               </a:ext>
             </a:extLst>
           </p:cNvPr>
@@ -9931,7 +9932,7 @@
           <p:cNvPr id="15" name="Picture 14">
             <a:extLst>
               <a:ext uri="{FF2B5EF4-FFF2-40B4-BE49-F238E27FC236}">
-                <a16:creationId xmlns:a16="http://schemas.microsoft.com/office/drawing/2014/main" id="{75C82CA2-AF43-3B85-BDDD-4264573B5622}"/>
+                <a16:creationId xmlns:a16="http://schemas.microsoft.com/office/drawing/2014/main" id="{277A7B52-B47B-59F2-8EFA-C4E993B5EDD3}"/>
               </a:ext>
             </a:extLst>
           </p:cNvPr>
@@ -9967,7 +9968,7 @@
           <p:cNvPr id="16" name="TextBox 15">
             <a:extLst>
               <a:ext uri="{FF2B5EF4-FFF2-40B4-BE49-F238E27FC236}">
-                <a16:creationId xmlns:a16="http://schemas.microsoft.com/office/drawing/2014/main" id="{7E4650B7-BA8F-C222-B63B-EF0448157242}"/>
+                <a16:creationId xmlns:a16="http://schemas.microsoft.com/office/drawing/2014/main" id="{50C4CC9E-BE87-3DCC-50F7-9A97E349A24D}"/>
               </a:ext>
             </a:extLst>
           </p:cNvPr>
@@ -10012,7 +10013,7 @@
           <p:cNvPr id="18" name="Picture 17">
             <a:extLst>
               <a:ext uri="{FF2B5EF4-FFF2-40B4-BE49-F238E27FC236}">
-                <a16:creationId xmlns:a16="http://schemas.microsoft.com/office/drawing/2014/main" id="{C75DC710-7AFE-04AE-14A3-43E712A1F219}"/>
+                <a16:creationId xmlns:a16="http://schemas.microsoft.com/office/drawing/2014/main" id="{6F6672AB-8345-8FD7-B124-B2EAE8F5E2EB}"/>
               </a:ext>
             </a:extLst>
           </p:cNvPr>
@@ -10048,7 +10049,7 @@
           <p:cNvPr id="19" name="TextBox 18">
             <a:extLst>
               <a:ext uri="{FF2B5EF4-FFF2-40B4-BE49-F238E27FC236}">
-                <a16:creationId xmlns:a16="http://schemas.microsoft.com/office/drawing/2014/main" id="{63F28576-73AC-0A8B-FC28-B40645EA9BF3}"/>
+                <a16:creationId xmlns:a16="http://schemas.microsoft.com/office/drawing/2014/main" id="{8E2A61F3-8C1D-B649-7A7C-9E17760E2D93}"/>
               </a:ext>
             </a:extLst>
           </p:cNvPr>
@@ -10093,7 +10094,7 @@
           <p:cNvPr id="21" name="Picture 20">
             <a:extLst>
               <a:ext uri="{FF2B5EF4-FFF2-40B4-BE49-F238E27FC236}">
-                <a16:creationId xmlns:a16="http://schemas.microsoft.com/office/drawing/2014/main" id="{CCDB9C0D-B5A5-468F-F12F-D8E4170D49B2}"/>
+                <a16:creationId xmlns:a16="http://schemas.microsoft.com/office/drawing/2014/main" id="{E213FBFD-CA83-4364-CCE0-FCEE3F1362AA}"/>
               </a:ext>
             </a:extLst>
           </p:cNvPr>
@@ -10129,7 +10130,7 @@
           <p:cNvPr id="22" name="TextBox 21">
             <a:extLst>
               <a:ext uri="{FF2B5EF4-FFF2-40B4-BE49-F238E27FC236}">
-                <a16:creationId xmlns:a16="http://schemas.microsoft.com/office/drawing/2014/main" id="{D08BEBB3-4CE4-78AE-E045-9C4525FE690A}"/>
+                <a16:creationId xmlns:a16="http://schemas.microsoft.com/office/drawing/2014/main" id="{027257A9-0D2F-1144-4BC8-D90F2D2DA820}"/>
               </a:ext>
             </a:extLst>
           </p:cNvPr>
@@ -10174,7 +10175,7 @@
           <p:cNvPr id="24" name="Picture 23">
             <a:extLst>
               <a:ext uri="{FF2B5EF4-FFF2-40B4-BE49-F238E27FC236}">
-                <a16:creationId xmlns:a16="http://schemas.microsoft.com/office/drawing/2014/main" id="{9637CFB8-342F-A6A0-58A9-2EA4064A73CB}"/>
+                <a16:creationId xmlns:a16="http://schemas.microsoft.com/office/drawing/2014/main" id="{03A8F7D2-E2A4-BB99-8A7B-ED0FD88D3A87}"/>
               </a:ext>
             </a:extLst>
           </p:cNvPr>
@@ -10210,7 +10211,7 @@
           <p:cNvPr id="25" name="TextBox 24">
             <a:extLst>
               <a:ext uri="{FF2B5EF4-FFF2-40B4-BE49-F238E27FC236}">
-                <a16:creationId xmlns:a16="http://schemas.microsoft.com/office/drawing/2014/main" id="{6E2B8BF6-4AE7-26D1-3653-25805AAFFA11}"/>
+                <a16:creationId xmlns:a16="http://schemas.microsoft.com/office/drawing/2014/main" id="{94863AFF-AA80-E68F-F80A-3D7D8A0F6C8A}"/>
               </a:ext>
             </a:extLst>
           </p:cNvPr>
@@ -10255,7 +10256,7 @@
           <p:cNvPr id="26" name="TextBox 25">
             <a:extLst>
               <a:ext uri="{FF2B5EF4-FFF2-40B4-BE49-F238E27FC236}">
-                <a16:creationId xmlns:a16="http://schemas.microsoft.com/office/drawing/2014/main" id="{7AAE6282-304F-E9D6-EE48-1DD6353A81A8}"/>
+                <a16:creationId xmlns:a16="http://schemas.microsoft.com/office/drawing/2014/main" id="{63766BD0-B777-DBA1-D65A-82F3E6F99D90}"/>
               </a:ext>
             </a:extLst>
           </p:cNvPr>
@@ -10306,7 +10307,7 @@
           <p:cNvPr id="27" name="TextBox 26">
             <a:extLst>
               <a:ext uri="{FF2B5EF4-FFF2-40B4-BE49-F238E27FC236}">
-                <a16:creationId xmlns:a16="http://schemas.microsoft.com/office/drawing/2014/main" id="{EC2BF2DC-4ED5-95A4-7B97-FED1D9FB5002}"/>
+                <a16:creationId xmlns:a16="http://schemas.microsoft.com/office/drawing/2014/main" id="{53EBAF50-3D36-E1B7-BE37-57E7ADD1E6CA}"/>
               </a:ext>
             </a:extLst>
           </p:cNvPr>
@@ -10355,7 +10356,7 @@
     </p:spTree>
     <p:extLst>
       <p:ext uri="{BB962C8B-B14F-4D97-AF65-F5344CB8AC3E}">
-        <p14:creationId xmlns:p14="http://schemas.microsoft.com/office/powerpoint/2010/main" val="1921100112"/>
+        <p14:creationId xmlns:p14="http://schemas.microsoft.com/office/powerpoint/2010/main" val="2883514900"/>
       </p:ext>
     </p:extLst>
   </p:cSld>
@@ -10395,7 +10396,7 @@
           <p:cNvPr id="2" name="TextBox 1">
             <a:extLst>
               <a:ext uri="{FF2B5EF4-FFF2-40B4-BE49-F238E27FC236}">
-                <a16:creationId xmlns:a16="http://schemas.microsoft.com/office/drawing/2014/main" id="{657CBCB9-2930-C68E-BCCD-9E5F25F46F3D}"/>
+                <a16:creationId xmlns:a16="http://schemas.microsoft.com/office/drawing/2014/main" id="{27C976C1-F1C2-CC40-7195-20A0FAD236A4}"/>
               </a:ext>
             </a:extLst>
           </p:cNvPr>
@@ -10446,7 +10447,7 @@
           <p:cNvPr id="3" name="TextBox 2">
             <a:extLst>
               <a:ext uri="{FF2B5EF4-FFF2-40B4-BE49-F238E27FC236}">
-                <a16:creationId xmlns:a16="http://schemas.microsoft.com/office/drawing/2014/main" id="{EDA0D806-E25A-8E3F-49F4-7137015915F3}"/>
+                <a16:creationId xmlns:a16="http://schemas.microsoft.com/office/drawing/2014/main" id="{CDCD18D0-A239-907A-5752-ECCDE77014D7}"/>
               </a:ext>
             </a:extLst>
           </p:cNvPr>
@@ -10491,7 +10492,7 @@
           <p:cNvPr id="4" name="Table 3">
             <a:extLst>
               <a:ext uri="{FF2B5EF4-FFF2-40B4-BE49-F238E27FC236}">
-                <a16:creationId xmlns:a16="http://schemas.microsoft.com/office/drawing/2014/main" id="{C16C87A2-8BAE-A35C-9429-BB626A96E55C}"/>
+                <a16:creationId xmlns:a16="http://schemas.microsoft.com/office/drawing/2014/main" id="{4AA5F4F6-3E23-9CB1-030C-BB63A45586C7}"/>
               </a:ext>
             </a:extLst>
           </p:cNvPr>
@@ -10501,7 +10502,7 @@
           <p:nvPr>
             <p:extLst>
               <p:ext uri="{D42A27DB-BD31-4B8C-83A1-F6EECF244321}">
-                <p14:modId xmlns:p14="http://schemas.microsoft.com/office/powerpoint/2010/main" val="1211325495"/>
+                <p14:modId xmlns:p14="http://schemas.microsoft.com/office/powerpoint/2010/main" val="4205653320"/>
               </p:ext>
             </p:extLst>
           </p:nvPr>
@@ -10520,28 +10521,28 @@
                 <a:gridCol w="3621024">
                   <a:extLst>
                     <a:ext uri="{9D8B030D-6E8A-4147-A177-3AD203B41FA5}">
-                      <a16:colId xmlns:a16="http://schemas.microsoft.com/office/drawing/2014/main" val="3846579449"/>
+                      <a16:colId xmlns:a16="http://schemas.microsoft.com/office/drawing/2014/main" val="3593156543"/>
                     </a:ext>
                   </a:extLst>
                 </a:gridCol>
                 <a:gridCol w="2194560">
                   <a:extLst>
                     <a:ext uri="{9D8B030D-6E8A-4147-A177-3AD203B41FA5}">
-                      <a16:colId xmlns:a16="http://schemas.microsoft.com/office/drawing/2014/main" val="4182173560"/>
+                      <a16:colId xmlns:a16="http://schemas.microsoft.com/office/drawing/2014/main" val="3781838685"/>
                     </a:ext>
                   </a:extLst>
                 </a:gridCol>
                 <a:gridCol w="2523744">
                   <a:extLst>
                     <a:ext uri="{9D8B030D-6E8A-4147-A177-3AD203B41FA5}">
-                      <a16:colId xmlns:a16="http://schemas.microsoft.com/office/drawing/2014/main" val="551980424"/>
+                      <a16:colId xmlns:a16="http://schemas.microsoft.com/office/drawing/2014/main" val="2537274318"/>
                     </a:ext>
                   </a:extLst>
                 </a:gridCol>
                 <a:gridCol w="2633472">
                   <a:extLst>
                     <a:ext uri="{9D8B030D-6E8A-4147-A177-3AD203B41FA5}">
-                      <a16:colId xmlns:a16="http://schemas.microsoft.com/office/drawing/2014/main" val="1683335761"/>
+                      <a16:colId xmlns:a16="http://schemas.microsoft.com/office/drawing/2014/main" val="2052293164"/>
                     </a:ext>
                   </a:extLst>
                 </a:gridCol>
@@ -10637,7 +10638,7 @@
                 </a:tc>
                 <a:extLst>
                   <a:ext uri="{0D108BD9-81ED-4DB2-BD59-A6C34878D82A}">
-                    <a16:rowId xmlns:a16="http://schemas.microsoft.com/office/drawing/2014/main" val="3973940144"/>
+                    <a16:rowId xmlns:a16="http://schemas.microsoft.com/office/drawing/2014/main" val="1956378578"/>
                   </a:ext>
                 </a:extLst>
               </a:tr>
@@ -10732,7 +10733,7 @@
                 </a:tc>
                 <a:extLst>
                   <a:ext uri="{0D108BD9-81ED-4DB2-BD59-A6C34878D82A}">
-                    <a16:rowId xmlns:a16="http://schemas.microsoft.com/office/drawing/2014/main" val="2501695843"/>
+                    <a16:rowId xmlns:a16="http://schemas.microsoft.com/office/drawing/2014/main" val="1891603612"/>
                   </a:ext>
                 </a:extLst>
               </a:tr>
@@ -10827,7 +10828,7 @@
                 </a:tc>
                 <a:extLst>
                   <a:ext uri="{0D108BD9-81ED-4DB2-BD59-A6C34878D82A}">
-                    <a16:rowId xmlns:a16="http://schemas.microsoft.com/office/drawing/2014/main" val="333871220"/>
+                    <a16:rowId xmlns:a16="http://schemas.microsoft.com/office/drawing/2014/main" val="862552334"/>
                   </a:ext>
                 </a:extLst>
               </a:tr>
@@ -10840,7 +10841,7 @@
           <p:cNvPr id="5" name="TextBox 4">
             <a:extLst>
               <a:ext uri="{FF2B5EF4-FFF2-40B4-BE49-F238E27FC236}">
-                <a16:creationId xmlns:a16="http://schemas.microsoft.com/office/drawing/2014/main" id="{FA4423C0-30D3-6B9C-9332-F965BAFC0A2B}"/>
+                <a16:creationId xmlns:a16="http://schemas.microsoft.com/office/drawing/2014/main" id="{2414AEAA-84B1-BB20-A649-C654AC832A01}"/>
               </a:ext>
             </a:extLst>
           </p:cNvPr>
@@ -10891,7 +10892,7 @@
           <p:cNvPr id="6" name="TextBox 5">
             <a:extLst>
               <a:ext uri="{FF2B5EF4-FFF2-40B4-BE49-F238E27FC236}">
-                <a16:creationId xmlns:a16="http://schemas.microsoft.com/office/drawing/2014/main" id="{E5840FDF-9EF2-1AA5-60A5-2AB8EBCBB93A}"/>
+                <a16:creationId xmlns:a16="http://schemas.microsoft.com/office/drawing/2014/main" id="{331D381F-0529-16DD-2F60-5713E3B600CF}"/>
               </a:ext>
             </a:extLst>
           </p:cNvPr>
@@ -10943,7 +10944,7 @@
           <p:cNvPr id="7" name="TextBox 6">
             <a:extLst>
               <a:ext uri="{FF2B5EF4-FFF2-40B4-BE49-F238E27FC236}">
-                <a16:creationId xmlns:a16="http://schemas.microsoft.com/office/drawing/2014/main" id="{D98C234F-B0E1-FC73-E98C-0593DDBDDB0C}"/>
+                <a16:creationId xmlns:a16="http://schemas.microsoft.com/office/drawing/2014/main" id="{FD69F2FD-F611-B02F-B272-834AD2AABCDC}"/>
               </a:ext>
             </a:extLst>
           </p:cNvPr>
@@ -10992,7 +10993,7 @@
     </p:spTree>
     <p:extLst>
       <p:ext uri="{BB962C8B-B14F-4D97-AF65-F5344CB8AC3E}">
-        <p14:creationId xmlns:p14="http://schemas.microsoft.com/office/powerpoint/2010/main" val="2341606433"/>
+        <p14:creationId xmlns:p14="http://schemas.microsoft.com/office/powerpoint/2010/main" val="4234476797"/>
       </p:ext>
     </p:extLst>
   </p:cSld>
@@ -11032,7 +11033,7 @@
           <p:cNvPr id="2" name="TextBox 1">
             <a:extLst>
               <a:ext uri="{FF2B5EF4-FFF2-40B4-BE49-F238E27FC236}">
-                <a16:creationId xmlns:a16="http://schemas.microsoft.com/office/drawing/2014/main" id="{97E68961-13E9-2DC3-7544-E427A667BAF9}"/>
+                <a16:creationId xmlns:a16="http://schemas.microsoft.com/office/drawing/2014/main" id="{CA113191-55DF-5827-EBAB-94E9558E9B67}"/>
               </a:ext>
             </a:extLst>
           </p:cNvPr>
@@ -11083,7 +11084,7 @@
           <p:cNvPr id="3" name="TextBox 2">
             <a:extLst>
               <a:ext uri="{FF2B5EF4-FFF2-40B4-BE49-F238E27FC236}">
-                <a16:creationId xmlns:a16="http://schemas.microsoft.com/office/drawing/2014/main" id="{AF7F3ECA-E912-71C1-4376-68724EE3FF82}"/>
+                <a16:creationId xmlns:a16="http://schemas.microsoft.com/office/drawing/2014/main" id="{E4EE517F-CA76-6C21-CD1A-681E4A0FBDC0}"/>
               </a:ext>
             </a:extLst>
           </p:cNvPr>
@@ -11128,7 +11129,7 @@
           <p:cNvPr id="4" name="Table 3">
             <a:extLst>
               <a:ext uri="{FF2B5EF4-FFF2-40B4-BE49-F238E27FC236}">
-                <a16:creationId xmlns:a16="http://schemas.microsoft.com/office/drawing/2014/main" id="{4D148959-FDAE-ADC2-D78E-6677DF7D2D45}"/>
+                <a16:creationId xmlns:a16="http://schemas.microsoft.com/office/drawing/2014/main" id="{F4232AC3-961C-29BE-DDF8-B71D158A194E}"/>
               </a:ext>
             </a:extLst>
           </p:cNvPr>
@@ -11138,7 +11139,7 @@
           <p:nvPr>
             <p:extLst>
               <p:ext uri="{D42A27DB-BD31-4B8C-83A1-F6EECF244321}">
-                <p14:modId xmlns:p14="http://schemas.microsoft.com/office/powerpoint/2010/main" val="337765738"/>
+                <p14:modId xmlns:p14="http://schemas.microsoft.com/office/powerpoint/2010/main" val="1870780537"/>
               </p:ext>
             </p:extLst>
           </p:nvPr>
@@ -11157,21 +11158,21 @@
                 <a:gridCol w="3072384">
                   <a:extLst>
                     <a:ext uri="{9D8B030D-6E8A-4147-A177-3AD203B41FA5}">
-                      <a16:colId xmlns:a16="http://schemas.microsoft.com/office/drawing/2014/main" val="2547495909"/>
+                      <a16:colId xmlns:a16="http://schemas.microsoft.com/office/drawing/2014/main" val="1601587634"/>
                     </a:ext>
                   </a:extLst>
                 </a:gridCol>
                 <a:gridCol w="5925312">
                   <a:extLst>
                     <a:ext uri="{9D8B030D-6E8A-4147-A177-3AD203B41FA5}">
-                      <a16:colId xmlns:a16="http://schemas.microsoft.com/office/drawing/2014/main" val="2064767823"/>
+                      <a16:colId xmlns:a16="http://schemas.microsoft.com/office/drawing/2014/main" val="3935080969"/>
                     </a:ext>
                   </a:extLst>
                 </a:gridCol>
                 <a:gridCol w="1975104">
                   <a:extLst>
                     <a:ext uri="{9D8B030D-6E8A-4147-A177-3AD203B41FA5}">
-                      <a16:colId xmlns:a16="http://schemas.microsoft.com/office/drawing/2014/main" val="2610223097"/>
+                      <a16:colId xmlns:a16="http://schemas.microsoft.com/office/drawing/2014/main" val="3584971336"/>
                     </a:ext>
                   </a:extLst>
                 </a:gridCol>
@@ -11245,7 +11246,7 @@
                 </a:tc>
                 <a:extLst>
                   <a:ext uri="{0D108BD9-81ED-4DB2-BD59-A6C34878D82A}">
-                    <a16:rowId xmlns:a16="http://schemas.microsoft.com/office/drawing/2014/main" val="3875839009"/>
+                    <a16:rowId xmlns:a16="http://schemas.microsoft.com/office/drawing/2014/main" val="1822077649"/>
                   </a:ext>
                 </a:extLst>
               </a:tr>
@@ -11325,7 +11326,7 @@
                 </a:tc>
                 <a:extLst>
                   <a:ext uri="{0D108BD9-81ED-4DB2-BD59-A6C34878D82A}">
-                    <a16:rowId xmlns:a16="http://schemas.microsoft.com/office/drawing/2014/main" val="3238143045"/>
+                    <a16:rowId xmlns:a16="http://schemas.microsoft.com/office/drawing/2014/main" val="69633147"/>
                   </a:ext>
                 </a:extLst>
               </a:tr>
@@ -11399,7 +11400,7 @@
                 </a:tc>
                 <a:extLst>
                   <a:ext uri="{0D108BD9-81ED-4DB2-BD59-A6C34878D82A}">
-                    <a16:rowId xmlns:a16="http://schemas.microsoft.com/office/drawing/2014/main" val="655676025"/>
+                    <a16:rowId xmlns:a16="http://schemas.microsoft.com/office/drawing/2014/main" val="4019643982"/>
                   </a:ext>
                 </a:extLst>
               </a:tr>
@@ -11479,7 +11480,7 @@
                 </a:tc>
                 <a:extLst>
                   <a:ext uri="{0D108BD9-81ED-4DB2-BD59-A6C34878D82A}">
-                    <a16:rowId xmlns:a16="http://schemas.microsoft.com/office/drawing/2014/main" val="2090721114"/>
+                    <a16:rowId xmlns:a16="http://schemas.microsoft.com/office/drawing/2014/main" val="2330357477"/>
                   </a:ext>
                 </a:extLst>
               </a:tr>
@@ -11559,7 +11560,7 @@
                 </a:tc>
                 <a:extLst>
                   <a:ext uri="{0D108BD9-81ED-4DB2-BD59-A6C34878D82A}">
-                    <a16:rowId xmlns:a16="http://schemas.microsoft.com/office/drawing/2014/main" val="1945834661"/>
+                    <a16:rowId xmlns:a16="http://schemas.microsoft.com/office/drawing/2014/main" val="2483170892"/>
                   </a:ext>
                 </a:extLst>
               </a:tr>
@@ -11572,7 +11573,7 @@
           <p:cNvPr id="5" name="TextBox 4">
             <a:extLst>
               <a:ext uri="{FF2B5EF4-FFF2-40B4-BE49-F238E27FC236}">
-                <a16:creationId xmlns:a16="http://schemas.microsoft.com/office/drawing/2014/main" id="{1C91A43A-8FE2-63A2-E97F-C46C81A25D7B}"/>
+                <a16:creationId xmlns:a16="http://schemas.microsoft.com/office/drawing/2014/main" id="{DCC72B1F-FEDC-31C0-9FCD-44B5D42DBFE3}"/>
               </a:ext>
             </a:extLst>
           </p:cNvPr>
@@ -11621,7 +11622,7 @@
     </p:spTree>
     <p:extLst>
       <p:ext uri="{BB962C8B-B14F-4D97-AF65-F5344CB8AC3E}">
-        <p14:creationId xmlns:p14="http://schemas.microsoft.com/office/powerpoint/2010/main" val="1929900990"/>
+        <p14:creationId xmlns:p14="http://schemas.microsoft.com/office/powerpoint/2010/main" val="2859900055"/>
       </p:ext>
     </p:extLst>
   </p:cSld>
@@ -11661,7 +11662,7 @@
           <p:cNvPr id="2" name="TextBox 1">
             <a:extLst>
               <a:ext uri="{FF2B5EF4-FFF2-40B4-BE49-F238E27FC236}">
-                <a16:creationId xmlns:a16="http://schemas.microsoft.com/office/drawing/2014/main" id="{F506FB14-047B-D073-8F92-635876D2DCB8}"/>
+                <a16:creationId xmlns:a16="http://schemas.microsoft.com/office/drawing/2014/main" id="{07C51494-2FFB-E74B-9678-77831AEC3668}"/>
               </a:ext>
             </a:extLst>
           </p:cNvPr>
@@ -11706,7 +11707,7 @@
           <p:cNvPr id="3" name="TextBox 2">
             <a:extLst>
               <a:ext uri="{FF2B5EF4-FFF2-40B4-BE49-F238E27FC236}">
-                <a16:creationId xmlns:a16="http://schemas.microsoft.com/office/drawing/2014/main" id="{2DAA46FA-4F9C-81AE-0E98-B7D987688D9C}"/>
+                <a16:creationId xmlns:a16="http://schemas.microsoft.com/office/drawing/2014/main" id="{8E3A65B4-3BCC-FD16-5C72-3964C57FB99A}"/>
               </a:ext>
             </a:extLst>
           </p:cNvPr>
@@ -11751,7 +11752,7 @@
           <p:cNvPr id="4" name="TextBox 3">
             <a:extLst>
               <a:ext uri="{FF2B5EF4-FFF2-40B4-BE49-F238E27FC236}">
-                <a16:creationId xmlns:a16="http://schemas.microsoft.com/office/drawing/2014/main" id="{9628585E-4A5D-9670-4FE2-4B57681F26F4}"/>
+                <a16:creationId xmlns:a16="http://schemas.microsoft.com/office/drawing/2014/main" id="{1CF80559-7CAC-57BB-691A-D1E3E5A65CFB}"/>
               </a:ext>
             </a:extLst>
           </p:cNvPr>
@@ -11796,7 +11797,7 @@
           <p:cNvPr id="5" name="TextBox 4">
             <a:extLst>
               <a:ext uri="{FF2B5EF4-FFF2-40B4-BE49-F238E27FC236}">
-                <a16:creationId xmlns:a16="http://schemas.microsoft.com/office/drawing/2014/main" id="{0EDFB18C-4E21-2608-9263-68C115976AD9}"/>
+                <a16:creationId xmlns:a16="http://schemas.microsoft.com/office/drawing/2014/main" id="{919ACB6C-7088-57D6-ADDA-503FC81BE5D5}"/>
               </a:ext>
             </a:extLst>
           </p:cNvPr>
@@ -11850,7 +11851,7 @@
           <p:cNvPr id="6" name="TextBox 5">
             <a:extLst>
               <a:ext uri="{FF2B5EF4-FFF2-40B4-BE49-F238E27FC236}">
-                <a16:creationId xmlns:a16="http://schemas.microsoft.com/office/drawing/2014/main" id="{7735AF2B-8AFF-080C-87B9-875AD3D77B9A}"/>
+                <a16:creationId xmlns:a16="http://schemas.microsoft.com/office/drawing/2014/main" id="{3C39627A-C4E0-816B-3C88-EFF85929C010}"/>
               </a:ext>
             </a:extLst>
           </p:cNvPr>
@@ -11895,7 +11896,7 @@
           <p:cNvPr id="7" name="TextBox 6">
             <a:extLst>
               <a:ext uri="{FF2B5EF4-FFF2-40B4-BE49-F238E27FC236}">
-                <a16:creationId xmlns:a16="http://schemas.microsoft.com/office/drawing/2014/main" id="{E0475EEA-6E02-BE5A-BCD9-9DF764348B45}"/>
+                <a16:creationId xmlns:a16="http://schemas.microsoft.com/office/drawing/2014/main" id="{D9F88D5D-AF6B-4BC7-4507-5850BB6FC428}"/>
               </a:ext>
             </a:extLst>
           </p:cNvPr>
@@ -11943,7 +11944,7 @@
           <p:cNvPr id="8" name="TextBox 7">
             <a:extLst>
               <a:ext uri="{FF2B5EF4-FFF2-40B4-BE49-F238E27FC236}">
-                <a16:creationId xmlns:a16="http://schemas.microsoft.com/office/drawing/2014/main" id="{9DA95F94-CD9A-3487-16E0-A130D3C27203}"/>
+                <a16:creationId xmlns:a16="http://schemas.microsoft.com/office/drawing/2014/main" id="{7BF3CBCB-1BB2-D66F-52A5-E3B6776C45A4}"/>
               </a:ext>
             </a:extLst>
           </p:cNvPr>
@@ -11994,7 +11995,7 @@
           <p:cNvPr id="9" name="TextBox 8">
             <a:extLst>
               <a:ext uri="{FF2B5EF4-FFF2-40B4-BE49-F238E27FC236}">
-                <a16:creationId xmlns:a16="http://schemas.microsoft.com/office/drawing/2014/main" id="{FF2CBC90-4DFF-0ADA-D92B-DADCE57FBC53}"/>
+                <a16:creationId xmlns:a16="http://schemas.microsoft.com/office/drawing/2014/main" id="{C6AA4A77-BA71-E315-86EE-747EDD78F5E7}"/>
               </a:ext>
             </a:extLst>
           </p:cNvPr>
@@ -12043,7 +12044,7 @@
     </p:spTree>
     <p:extLst>
       <p:ext uri="{BB962C8B-B14F-4D97-AF65-F5344CB8AC3E}">
-        <p14:creationId xmlns:p14="http://schemas.microsoft.com/office/powerpoint/2010/main" val="4215054191"/>
+        <p14:creationId xmlns:p14="http://schemas.microsoft.com/office/powerpoint/2010/main" val="2734396025"/>
       </p:ext>
     </p:extLst>
   </p:cSld>
@@ -12083,7 +12084,7 @@
           <p:cNvPr id="2" name="TextBox 1">
             <a:extLst>
               <a:ext uri="{FF2B5EF4-FFF2-40B4-BE49-F238E27FC236}">
-                <a16:creationId xmlns:a16="http://schemas.microsoft.com/office/drawing/2014/main" id="{3822CA9B-6A3D-321A-2800-B482541CBA4C}"/>
+                <a16:creationId xmlns:a16="http://schemas.microsoft.com/office/drawing/2014/main" id="{94688DC3-FD5D-957F-161D-88F9E459E531}"/>
               </a:ext>
             </a:extLst>
           </p:cNvPr>
@@ -12128,7 +12129,7 @@
           <p:cNvPr id="3" name="TextBox 2">
             <a:extLst>
               <a:ext uri="{FF2B5EF4-FFF2-40B4-BE49-F238E27FC236}">
-                <a16:creationId xmlns:a16="http://schemas.microsoft.com/office/drawing/2014/main" id="{8450DF0F-DC69-1379-45EE-F8F8491EA206}"/>
+                <a16:creationId xmlns:a16="http://schemas.microsoft.com/office/drawing/2014/main" id="{E6DBC099-8538-2ABF-E809-F44E975EE6E2}"/>
               </a:ext>
             </a:extLst>
           </p:cNvPr>
@@ -12173,7 +12174,7 @@
           <p:cNvPr id="4" name="TextBox 3">
             <a:extLst>
               <a:ext uri="{FF2B5EF4-FFF2-40B4-BE49-F238E27FC236}">
-                <a16:creationId xmlns:a16="http://schemas.microsoft.com/office/drawing/2014/main" id="{BA8ECE17-B687-BB8A-18C3-66CEB69D1914}"/>
+                <a16:creationId xmlns:a16="http://schemas.microsoft.com/office/drawing/2014/main" id="{E87CD1DF-1589-1416-577F-CD16CA877528}"/>
               </a:ext>
             </a:extLst>
           </p:cNvPr>
@@ -12224,7 +12225,7 @@
           <p:cNvPr id="5" name="TextBox 4">
             <a:extLst>
               <a:ext uri="{FF2B5EF4-FFF2-40B4-BE49-F238E27FC236}">
-                <a16:creationId xmlns:a16="http://schemas.microsoft.com/office/drawing/2014/main" id="{8A90530E-E202-61B4-FBFD-DB082B040555}"/>
+                <a16:creationId xmlns:a16="http://schemas.microsoft.com/office/drawing/2014/main" id="{CB03047E-9D90-8E80-5923-B99A74188FF5}"/>
               </a:ext>
             </a:extLst>
           </p:cNvPr>
@@ -12305,7 +12306,7 @@
     </p:spTree>
     <p:extLst>
       <p:ext uri="{BB962C8B-B14F-4D97-AF65-F5344CB8AC3E}">
-        <p14:creationId xmlns:p14="http://schemas.microsoft.com/office/powerpoint/2010/main" val="4227507845"/>
+        <p14:creationId xmlns:p14="http://schemas.microsoft.com/office/powerpoint/2010/main" val="692365576"/>
       </p:ext>
     </p:extLst>
   </p:cSld>
@@ -12345,7 +12346,7 @@
           <p:cNvPr id="2" name="TextBox 1">
             <a:extLst>
               <a:ext uri="{FF2B5EF4-FFF2-40B4-BE49-F238E27FC236}">
-                <a16:creationId xmlns:a16="http://schemas.microsoft.com/office/drawing/2014/main" id="{2075205A-A393-A3F8-434C-EA010637F106}"/>
+                <a16:creationId xmlns:a16="http://schemas.microsoft.com/office/drawing/2014/main" id="{5280DB42-057B-93A0-5A85-4D6700AFC5D2}"/>
               </a:ext>
             </a:extLst>
           </p:cNvPr>
@@ -12396,7 +12397,7 @@
           <p:cNvPr id="3" name="TextBox 2">
             <a:extLst>
               <a:ext uri="{FF2B5EF4-FFF2-40B4-BE49-F238E27FC236}">
-                <a16:creationId xmlns:a16="http://schemas.microsoft.com/office/drawing/2014/main" id="{C8466A73-5984-573B-E652-6CCE7C623749}"/>
+                <a16:creationId xmlns:a16="http://schemas.microsoft.com/office/drawing/2014/main" id="{C200138E-0E95-2D66-4509-85436BE4EEF7}"/>
               </a:ext>
             </a:extLst>
           </p:cNvPr>
@@ -12441,7 +12442,7 @@
           <p:cNvPr id="4" name="Table 3">
             <a:extLst>
               <a:ext uri="{FF2B5EF4-FFF2-40B4-BE49-F238E27FC236}">
-                <a16:creationId xmlns:a16="http://schemas.microsoft.com/office/drawing/2014/main" id="{4474FE18-B159-4370-2A90-735ECC0CEEF6}"/>
+                <a16:creationId xmlns:a16="http://schemas.microsoft.com/office/drawing/2014/main" id="{5B88A107-42FA-8904-282C-4B27808CD1F1}"/>
               </a:ext>
             </a:extLst>
           </p:cNvPr>
@@ -12451,7 +12452,7 @@
           <p:nvPr>
             <p:extLst>
               <p:ext uri="{D42A27DB-BD31-4B8C-83A1-F6EECF244321}">
-                <p14:modId xmlns:p14="http://schemas.microsoft.com/office/powerpoint/2010/main" val="3434079976"/>
+                <p14:modId xmlns:p14="http://schemas.microsoft.com/office/powerpoint/2010/main" val="2160004769"/>
               </p:ext>
             </p:extLst>
           </p:nvPr>
@@ -12470,35 +12471,35 @@
                 <a:gridCol w="3950208">
                   <a:extLst>
                     <a:ext uri="{9D8B030D-6E8A-4147-A177-3AD203B41FA5}">
-                      <a16:colId xmlns:a16="http://schemas.microsoft.com/office/drawing/2014/main" val="1290556609"/>
+                      <a16:colId xmlns:a16="http://schemas.microsoft.com/office/drawing/2014/main" val="1287645323"/>
                     </a:ext>
                   </a:extLst>
                 </a:gridCol>
                 <a:gridCol w="1755648">
                   <a:extLst>
                     <a:ext uri="{9D8B030D-6E8A-4147-A177-3AD203B41FA5}">
-                      <a16:colId xmlns:a16="http://schemas.microsoft.com/office/drawing/2014/main" val="1801984866"/>
+                      <a16:colId xmlns:a16="http://schemas.microsoft.com/office/drawing/2014/main" val="1801595789"/>
                     </a:ext>
                   </a:extLst>
                 </a:gridCol>
                 <a:gridCol w="1755648">
                   <a:extLst>
                     <a:ext uri="{9D8B030D-6E8A-4147-A177-3AD203B41FA5}">
-                      <a16:colId xmlns:a16="http://schemas.microsoft.com/office/drawing/2014/main" val="199699295"/>
+                      <a16:colId xmlns:a16="http://schemas.microsoft.com/office/drawing/2014/main" val="2206968401"/>
                     </a:ext>
                   </a:extLst>
                 </a:gridCol>
                 <a:gridCol w="1755648">
                   <a:extLst>
                     <a:ext uri="{9D8B030D-6E8A-4147-A177-3AD203B41FA5}">
-                      <a16:colId xmlns:a16="http://schemas.microsoft.com/office/drawing/2014/main" val="2989179951"/>
+                      <a16:colId xmlns:a16="http://schemas.microsoft.com/office/drawing/2014/main" val="265117453"/>
                     </a:ext>
                   </a:extLst>
                 </a:gridCol>
                 <a:gridCol w="1755648">
                   <a:extLst>
                     <a:ext uri="{9D8B030D-6E8A-4147-A177-3AD203B41FA5}">
-                      <a16:colId xmlns:a16="http://schemas.microsoft.com/office/drawing/2014/main" val="2323927631"/>
+                      <a16:colId xmlns:a16="http://schemas.microsoft.com/office/drawing/2014/main" val="1210121552"/>
                     </a:ext>
                   </a:extLst>
                 </a:gridCol>
@@ -12616,7 +12617,7 @@
                 </a:tc>
                 <a:extLst>
                   <a:ext uri="{0D108BD9-81ED-4DB2-BD59-A6C34878D82A}">
-                    <a16:rowId xmlns:a16="http://schemas.microsoft.com/office/drawing/2014/main" val="3816381949"/>
+                    <a16:rowId xmlns:a16="http://schemas.microsoft.com/office/drawing/2014/main" val="2965938223"/>
                   </a:ext>
                 </a:extLst>
               </a:tr>
@@ -12733,7 +12734,7 @@
                 </a:tc>
                 <a:extLst>
                   <a:ext uri="{0D108BD9-81ED-4DB2-BD59-A6C34878D82A}">
-                    <a16:rowId xmlns:a16="http://schemas.microsoft.com/office/drawing/2014/main" val="3783470590"/>
+                    <a16:rowId xmlns:a16="http://schemas.microsoft.com/office/drawing/2014/main" val="3680230307"/>
                   </a:ext>
                 </a:extLst>
               </a:tr>
@@ -12850,7 +12851,7 @@
                 </a:tc>
                 <a:extLst>
                   <a:ext uri="{0D108BD9-81ED-4DB2-BD59-A6C34878D82A}">
-                    <a16:rowId xmlns:a16="http://schemas.microsoft.com/office/drawing/2014/main" val="2843888954"/>
+                    <a16:rowId xmlns:a16="http://schemas.microsoft.com/office/drawing/2014/main" val="2063857680"/>
                   </a:ext>
                 </a:extLst>
               </a:tr>
@@ -12967,7 +12968,7 @@
                 </a:tc>
                 <a:extLst>
                   <a:ext uri="{0D108BD9-81ED-4DB2-BD59-A6C34878D82A}">
-                    <a16:rowId xmlns:a16="http://schemas.microsoft.com/office/drawing/2014/main" val="468794718"/>
+                    <a16:rowId xmlns:a16="http://schemas.microsoft.com/office/drawing/2014/main" val="2581080820"/>
                   </a:ext>
                 </a:extLst>
               </a:tr>
@@ -13084,7 +13085,7 @@
                 </a:tc>
                 <a:extLst>
                   <a:ext uri="{0D108BD9-81ED-4DB2-BD59-A6C34878D82A}">
-                    <a16:rowId xmlns:a16="http://schemas.microsoft.com/office/drawing/2014/main" val="1705439022"/>
+                    <a16:rowId xmlns:a16="http://schemas.microsoft.com/office/drawing/2014/main" val="798114905"/>
                   </a:ext>
                 </a:extLst>
               </a:tr>
@@ -13097,7 +13098,7 @@
           <p:cNvPr id="5" name="TextBox 4">
             <a:extLst>
               <a:ext uri="{FF2B5EF4-FFF2-40B4-BE49-F238E27FC236}">
-                <a16:creationId xmlns:a16="http://schemas.microsoft.com/office/drawing/2014/main" id="{5F9D89D6-4317-962B-BD94-6FAAE80E6E9E}"/>
+                <a16:creationId xmlns:a16="http://schemas.microsoft.com/office/drawing/2014/main" id="{036012E2-CD42-32BA-A7E9-BF7DDFDAB200}"/>
               </a:ext>
             </a:extLst>
           </p:cNvPr>
@@ -13142,7 +13143,7 @@
           <p:cNvPr id="6" name="TextBox 5">
             <a:extLst>
               <a:ext uri="{FF2B5EF4-FFF2-40B4-BE49-F238E27FC236}">
-                <a16:creationId xmlns:a16="http://schemas.microsoft.com/office/drawing/2014/main" id="{39389813-FEDD-FFFE-96C5-B38EA7258E56}"/>
+                <a16:creationId xmlns:a16="http://schemas.microsoft.com/office/drawing/2014/main" id="{FF028D2D-0CEC-9CDE-3DA7-8E19828E9216}"/>
               </a:ext>
             </a:extLst>
           </p:cNvPr>
@@ -13193,7 +13194,7 @@
           <p:cNvPr id="7" name="TextBox 6">
             <a:extLst>
               <a:ext uri="{FF2B5EF4-FFF2-40B4-BE49-F238E27FC236}">
-                <a16:creationId xmlns:a16="http://schemas.microsoft.com/office/drawing/2014/main" id="{290902C6-B5F6-FE0B-8ED7-B92E834BE7FF}"/>
+                <a16:creationId xmlns:a16="http://schemas.microsoft.com/office/drawing/2014/main" id="{F94D37D9-F118-846A-25A9-974A1F11984E}"/>
               </a:ext>
             </a:extLst>
           </p:cNvPr>
@@ -13243,7 +13244,7 @@
     </p:spTree>
     <p:extLst>
       <p:ext uri="{BB962C8B-B14F-4D97-AF65-F5344CB8AC3E}">
-        <p14:creationId xmlns:p14="http://schemas.microsoft.com/office/powerpoint/2010/main" val="2055483416"/>
+        <p14:creationId xmlns:p14="http://schemas.microsoft.com/office/powerpoint/2010/main" val="3122438516"/>
       </p:ext>
     </p:extLst>
   </p:cSld>
@@ -13283,7 +13284,7 @@
           <p:cNvPr id="2" name="TextBox 1">
             <a:extLst>
               <a:ext uri="{FF2B5EF4-FFF2-40B4-BE49-F238E27FC236}">
-                <a16:creationId xmlns:a16="http://schemas.microsoft.com/office/drawing/2014/main" id="{D2AED3A3-2C8A-4175-0DA1-DDB1DCCC286D}"/>
+                <a16:creationId xmlns:a16="http://schemas.microsoft.com/office/drawing/2014/main" id="{2F9F70F2-1658-0701-A6E4-7AAF9E51C8B3}"/>
               </a:ext>
             </a:extLst>
           </p:cNvPr>
@@ -13334,7 +13335,7 @@
           <p:cNvPr id="3" name="TextBox 2">
             <a:extLst>
               <a:ext uri="{FF2B5EF4-FFF2-40B4-BE49-F238E27FC236}">
-                <a16:creationId xmlns:a16="http://schemas.microsoft.com/office/drawing/2014/main" id="{064E76EA-488B-7FBA-3153-50779C6E1288}"/>
+                <a16:creationId xmlns:a16="http://schemas.microsoft.com/office/drawing/2014/main" id="{BCBAF8E4-DAE8-E1D5-BB63-1927D857E3B8}"/>
               </a:ext>
             </a:extLst>
           </p:cNvPr>
@@ -13379,7 +13380,7 @@
           <p:cNvPr id="4" name="Table 3">
             <a:extLst>
               <a:ext uri="{FF2B5EF4-FFF2-40B4-BE49-F238E27FC236}">
-                <a16:creationId xmlns:a16="http://schemas.microsoft.com/office/drawing/2014/main" id="{60654EC5-4731-218F-2B67-C44746120F47}"/>
+                <a16:creationId xmlns:a16="http://schemas.microsoft.com/office/drawing/2014/main" id="{94E83E3F-A893-C10E-0FA8-2AE749464F9E}"/>
               </a:ext>
             </a:extLst>
           </p:cNvPr>
@@ -13389,7 +13390,7 @@
           <p:nvPr>
             <p:extLst>
               <p:ext uri="{D42A27DB-BD31-4B8C-83A1-F6EECF244321}">
-                <p14:modId xmlns:p14="http://schemas.microsoft.com/office/powerpoint/2010/main" val="2697983253"/>
+                <p14:modId xmlns:p14="http://schemas.microsoft.com/office/powerpoint/2010/main" val="1327209385"/>
               </p:ext>
             </p:extLst>
           </p:nvPr>
@@ -13408,56 +13409,56 @@
                 <a:gridCol w="1584960">
                   <a:extLst>
                     <a:ext uri="{9D8B030D-6E8A-4147-A177-3AD203B41FA5}">
-                      <a16:colId xmlns:a16="http://schemas.microsoft.com/office/drawing/2014/main" val="3676588254"/>
+                      <a16:colId xmlns:a16="http://schemas.microsoft.com/office/drawing/2014/main" val="2715082950"/>
                     </a:ext>
                   </a:extLst>
                 </a:gridCol>
                 <a:gridCol w="717006">
                   <a:extLst>
                     <a:ext uri="{9D8B030D-6E8A-4147-A177-3AD203B41FA5}">
-                      <a16:colId xmlns:a16="http://schemas.microsoft.com/office/drawing/2014/main" val="2381816534"/>
+                      <a16:colId xmlns:a16="http://schemas.microsoft.com/office/drawing/2014/main" val="3407961996"/>
                     </a:ext>
                   </a:extLst>
                 </a:gridCol>
                 <a:gridCol w="717006">
                   <a:extLst>
                     <a:ext uri="{9D8B030D-6E8A-4147-A177-3AD203B41FA5}">
-                      <a16:colId xmlns:a16="http://schemas.microsoft.com/office/drawing/2014/main" val="2036266306"/>
+                      <a16:colId xmlns:a16="http://schemas.microsoft.com/office/drawing/2014/main" val="4261590597"/>
                     </a:ext>
                   </a:extLst>
                 </a:gridCol>
                 <a:gridCol w="717006">
                   <a:extLst>
                     <a:ext uri="{9D8B030D-6E8A-4147-A177-3AD203B41FA5}">
-                      <a16:colId xmlns:a16="http://schemas.microsoft.com/office/drawing/2014/main" val="3313808240"/>
+                      <a16:colId xmlns:a16="http://schemas.microsoft.com/office/drawing/2014/main" val="3958344650"/>
                     </a:ext>
                   </a:extLst>
                 </a:gridCol>
                 <a:gridCol w="717006">
                   <a:extLst>
                     <a:ext uri="{9D8B030D-6E8A-4147-A177-3AD203B41FA5}">
-                      <a16:colId xmlns:a16="http://schemas.microsoft.com/office/drawing/2014/main" val="3874645636"/>
+                      <a16:colId xmlns:a16="http://schemas.microsoft.com/office/drawing/2014/main" val="99529858"/>
                     </a:ext>
                   </a:extLst>
                 </a:gridCol>
                 <a:gridCol w="717006">
                   <a:extLst>
                     <a:ext uri="{9D8B030D-6E8A-4147-A177-3AD203B41FA5}">
-                      <a16:colId xmlns:a16="http://schemas.microsoft.com/office/drawing/2014/main" val="1567682226"/>
+                      <a16:colId xmlns:a16="http://schemas.microsoft.com/office/drawing/2014/main" val="1691453584"/>
                     </a:ext>
                   </a:extLst>
                 </a:gridCol>
                 <a:gridCol w="717006">
                   <a:extLst>
                     <a:ext uri="{9D8B030D-6E8A-4147-A177-3AD203B41FA5}">
-                      <a16:colId xmlns:a16="http://schemas.microsoft.com/office/drawing/2014/main" val="4054207484"/>
+                      <a16:colId xmlns:a16="http://schemas.microsoft.com/office/drawing/2014/main" val="342602242"/>
                     </a:ext>
                   </a:extLst>
                 </a:gridCol>
                 <a:gridCol w="717006">
                   <a:extLst>
                     <a:ext uri="{9D8B030D-6E8A-4147-A177-3AD203B41FA5}">
-                      <a16:colId xmlns:a16="http://schemas.microsoft.com/office/drawing/2014/main" val="4179526110"/>
+                      <a16:colId xmlns:a16="http://schemas.microsoft.com/office/drawing/2014/main" val="42534539"/>
                     </a:ext>
                   </a:extLst>
                 </a:gridCol>
@@ -13641,7 +13642,7 @@
                 </a:tc>
                 <a:extLst>
                   <a:ext uri="{0D108BD9-81ED-4DB2-BD59-A6C34878D82A}">
-                    <a16:rowId xmlns:a16="http://schemas.microsoft.com/office/drawing/2014/main" val="477541352"/>
+                    <a16:rowId xmlns:a16="http://schemas.microsoft.com/office/drawing/2014/main" val="2636982203"/>
                   </a:ext>
                 </a:extLst>
               </a:tr>
@@ -13831,7 +13832,7 @@
                 </a:tc>
                 <a:extLst>
                   <a:ext uri="{0D108BD9-81ED-4DB2-BD59-A6C34878D82A}">
-                    <a16:rowId xmlns:a16="http://schemas.microsoft.com/office/drawing/2014/main" val="2669326598"/>
+                    <a16:rowId xmlns:a16="http://schemas.microsoft.com/office/drawing/2014/main" val="1924165171"/>
                   </a:ext>
                 </a:extLst>
               </a:tr>
@@ -14021,7 +14022,7 @@
                 </a:tc>
                 <a:extLst>
                   <a:ext uri="{0D108BD9-81ED-4DB2-BD59-A6C34878D82A}">
-                    <a16:rowId xmlns:a16="http://schemas.microsoft.com/office/drawing/2014/main" val="383369576"/>
+                    <a16:rowId xmlns:a16="http://schemas.microsoft.com/office/drawing/2014/main" val="2002559535"/>
                   </a:ext>
                 </a:extLst>
               </a:tr>
@@ -14211,7 +14212,7 @@
                 </a:tc>
                 <a:extLst>
                   <a:ext uri="{0D108BD9-81ED-4DB2-BD59-A6C34878D82A}">
-                    <a16:rowId xmlns:a16="http://schemas.microsoft.com/office/drawing/2014/main" val="2035880456"/>
+                    <a16:rowId xmlns:a16="http://schemas.microsoft.com/office/drawing/2014/main" val="4148453169"/>
                   </a:ext>
                 </a:extLst>
               </a:tr>
@@ -14401,7 +14402,7 @@
                 </a:tc>
                 <a:extLst>
                   <a:ext uri="{0D108BD9-81ED-4DB2-BD59-A6C34878D82A}">
-                    <a16:rowId xmlns:a16="http://schemas.microsoft.com/office/drawing/2014/main" val="2991384473"/>
+                    <a16:rowId xmlns:a16="http://schemas.microsoft.com/office/drawing/2014/main" val="438379334"/>
                   </a:ext>
                 </a:extLst>
               </a:tr>
@@ -14591,7 +14592,7 @@
                 </a:tc>
                 <a:extLst>
                   <a:ext uri="{0D108BD9-81ED-4DB2-BD59-A6C34878D82A}">
-                    <a16:rowId xmlns:a16="http://schemas.microsoft.com/office/drawing/2014/main" val="2833948688"/>
+                    <a16:rowId xmlns:a16="http://schemas.microsoft.com/office/drawing/2014/main" val="1476248934"/>
                   </a:ext>
                 </a:extLst>
               </a:tr>
@@ -14781,7 +14782,7 @@
                 </a:tc>
                 <a:extLst>
                   <a:ext uri="{0D108BD9-81ED-4DB2-BD59-A6C34878D82A}">
-                    <a16:rowId xmlns:a16="http://schemas.microsoft.com/office/drawing/2014/main" val="1689298898"/>
+                    <a16:rowId xmlns:a16="http://schemas.microsoft.com/office/drawing/2014/main" val="2067993597"/>
                   </a:ext>
                 </a:extLst>
               </a:tr>
@@ -14971,7 +14972,7 @@
                 </a:tc>
                 <a:extLst>
                   <a:ext uri="{0D108BD9-81ED-4DB2-BD59-A6C34878D82A}">
-                    <a16:rowId xmlns:a16="http://schemas.microsoft.com/office/drawing/2014/main" val="855883750"/>
+                    <a16:rowId xmlns:a16="http://schemas.microsoft.com/office/drawing/2014/main" val="3275935473"/>
                   </a:ext>
                 </a:extLst>
               </a:tr>
@@ -14984,7 +14985,7 @@
           <p:cNvPr id="5" name="Table 4">
             <a:extLst>
               <a:ext uri="{FF2B5EF4-FFF2-40B4-BE49-F238E27FC236}">
-                <a16:creationId xmlns:a16="http://schemas.microsoft.com/office/drawing/2014/main" id="{FB55E799-5B6E-0924-6698-267133E353C9}"/>
+                <a16:creationId xmlns:a16="http://schemas.microsoft.com/office/drawing/2014/main" id="{5960BAFD-928D-9FEB-84E6-1E2DBCCD4FF2}"/>
               </a:ext>
             </a:extLst>
           </p:cNvPr>
@@ -14994,7 +14995,7 @@
           <p:nvPr>
             <p:extLst>
               <p:ext uri="{D42A27DB-BD31-4B8C-83A1-F6EECF244321}">
-                <p14:modId xmlns:p14="http://schemas.microsoft.com/office/powerpoint/2010/main" val="552751212"/>
+                <p14:modId xmlns:p14="http://schemas.microsoft.com/office/powerpoint/2010/main" val="3949053906"/>
               </p:ext>
             </p:extLst>
           </p:nvPr>
@@ -15013,28 +15014,28 @@
                 <a:gridCol w="1437894">
                   <a:extLst>
                     <a:ext uri="{9D8B030D-6E8A-4147-A177-3AD203B41FA5}">
-                      <a16:colId xmlns:a16="http://schemas.microsoft.com/office/drawing/2014/main" val="2363631602"/>
+                      <a16:colId xmlns:a16="http://schemas.microsoft.com/office/drawing/2014/main" val="2454835610"/>
                     </a:ext>
                   </a:extLst>
                 </a:gridCol>
                 <a:gridCol w="930402">
                   <a:extLst>
                     <a:ext uri="{9D8B030D-6E8A-4147-A177-3AD203B41FA5}">
-                      <a16:colId xmlns:a16="http://schemas.microsoft.com/office/drawing/2014/main" val="2824778313"/>
+                      <a16:colId xmlns:a16="http://schemas.microsoft.com/office/drawing/2014/main" val="1312591844"/>
                     </a:ext>
                   </a:extLst>
                 </a:gridCol>
                 <a:gridCol w="930402">
                   <a:extLst>
                     <a:ext uri="{9D8B030D-6E8A-4147-A177-3AD203B41FA5}">
-                      <a16:colId xmlns:a16="http://schemas.microsoft.com/office/drawing/2014/main" val="2853301450"/>
+                      <a16:colId xmlns:a16="http://schemas.microsoft.com/office/drawing/2014/main" val="166808978"/>
                     </a:ext>
                   </a:extLst>
                 </a:gridCol>
                 <a:gridCol w="930402">
                   <a:extLst>
                     <a:ext uri="{9D8B030D-6E8A-4147-A177-3AD203B41FA5}">
-                      <a16:colId xmlns:a16="http://schemas.microsoft.com/office/drawing/2014/main" val="1950217699"/>
+                      <a16:colId xmlns:a16="http://schemas.microsoft.com/office/drawing/2014/main" val="3557439775"/>
                     </a:ext>
                   </a:extLst>
                 </a:gridCol>
@@ -15130,7 +15131,7 @@
                 </a:tc>
                 <a:extLst>
                   <a:ext uri="{0D108BD9-81ED-4DB2-BD59-A6C34878D82A}">
-                    <a16:rowId xmlns:a16="http://schemas.microsoft.com/office/drawing/2014/main" val="1167996303"/>
+                    <a16:rowId xmlns:a16="http://schemas.microsoft.com/office/drawing/2014/main" val="1923036738"/>
                   </a:ext>
                 </a:extLst>
               </a:tr>
@@ -15225,7 +15226,7 @@
                 </a:tc>
                 <a:extLst>
                   <a:ext uri="{0D108BD9-81ED-4DB2-BD59-A6C34878D82A}">
-                    <a16:rowId xmlns:a16="http://schemas.microsoft.com/office/drawing/2014/main" val="3446691103"/>
+                    <a16:rowId xmlns:a16="http://schemas.microsoft.com/office/drawing/2014/main" val="1291286459"/>
                   </a:ext>
                 </a:extLst>
               </a:tr>
@@ -15320,7 +15321,7 @@
                 </a:tc>
                 <a:extLst>
                   <a:ext uri="{0D108BD9-81ED-4DB2-BD59-A6C34878D82A}">
-                    <a16:rowId xmlns:a16="http://schemas.microsoft.com/office/drawing/2014/main" val="2790614013"/>
+                    <a16:rowId xmlns:a16="http://schemas.microsoft.com/office/drawing/2014/main" val="1898136898"/>
                   </a:ext>
                 </a:extLst>
               </a:tr>
@@ -15415,7 +15416,7 @@
                 </a:tc>
                 <a:extLst>
                   <a:ext uri="{0D108BD9-81ED-4DB2-BD59-A6C34878D82A}">
-                    <a16:rowId xmlns:a16="http://schemas.microsoft.com/office/drawing/2014/main" val="2324948581"/>
+                    <a16:rowId xmlns:a16="http://schemas.microsoft.com/office/drawing/2014/main" val="1898726619"/>
                   </a:ext>
                 </a:extLst>
               </a:tr>
@@ -15510,7 +15511,7 @@
                 </a:tc>
                 <a:extLst>
                   <a:ext uri="{0D108BD9-81ED-4DB2-BD59-A6C34878D82A}">
-                    <a16:rowId xmlns:a16="http://schemas.microsoft.com/office/drawing/2014/main" val="2896232946"/>
+                    <a16:rowId xmlns:a16="http://schemas.microsoft.com/office/drawing/2014/main" val="729248688"/>
                   </a:ext>
                 </a:extLst>
               </a:tr>
@@ -15605,7 +15606,7 @@
                 </a:tc>
                 <a:extLst>
                   <a:ext uri="{0D108BD9-81ED-4DB2-BD59-A6C34878D82A}">
-                    <a16:rowId xmlns:a16="http://schemas.microsoft.com/office/drawing/2014/main" val="898323232"/>
+                    <a16:rowId xmlns:a16="http://schemas.microsoft.com/office/drawing/2014/main" val="3894173314"/>
                   </a:ext>
                 </a:extLst>
               </a:tr>
@@ -15700,7 +15701,7 @@
                 </a:tc>
                 <a:extLst>
                   <a:ext uri="{0D108BD9-81ED-4DB2-BD59-A6C34878D82A}">
-                    <a16:rowId xmlns:a16="http://schemas.microsoft.com/office/drawing/2014/main" val="621301602"/>
+                    <a16:rowId xmlns:a16="http://schemas.microsoft.com/office/drawing/2014/main" val="2580529309"/>
                   </a:ext>
                 </a:extLst>
               </a:tr>
@@ -15795,7 +15796,7 @@
                 </a:tc>
                 <a:extLst>
                   <a:ext uri="{0D108BD9-81ED-4DB2-BD59-A6C34878D82A}">
-                    <a16:rowId xmlns:a16="http://schemas.microsoft.com/office/drawing/2014/main" val="2655245906"/>
+                    <a16:rowId xmlns:a16="http://schemas.microsoft.com/office/drawing/2014/main" val="2774581049"/>
                   </a:ext>
                 </a:extLst>
               </a:tr>
@@ -15808,7 +15809,7 @@
           <p:cNvPr id="6" name="TextBox 5">
             <a:extLst>
               <a:ext uri="{FF2B5EF4-FFF2-40B4-BE49-F238E27FC236}">
-                <a16:creationId xmlns:a16="http://schemas.microsoft.com/office/drawing/2014/main" id="{0E9D7AF0-F91E-548E-FF6F-477715A3E875}"/>
+                <a16:creationId xmlns:a16="http://schemas.microsoft.com/office/drawing/2014/main" id="{A4BC7B67-2277-6C15-43EC-3E43258C00F7}"/>
               </a:ext>
             </a:extLst>
           </p:cNvPr>
@@ -15859,7 +15860,7 @@
           <p:cNvPr id="7" name="TextBox 6">
             <a:extLst>
               <a:ext uri="{FF2B5EF4-FFF2-40B4-BE49-F238E27FC236}">
-                <a16:creationId xmlns:a16="http://schemas.microsoft.com/office/drawing/2014/main" id="{BD3E5B77-A7B6-5F21-37F0-85F9049D2E4C}"/>
+                <a16:creationId xmlns:a16="http://schemas.microsoft.com/office/drawing/2014/main" id="{C20D33A3-1F03-2EBC-6C9A-BDED4A577D35}"/>
               </a:ext>
             </a:extLst>
           </p:cNvPr>
@@ -15904,7 +15905,7 @@
           <p:cNvPr id="8" name="TextBox 7">
             <a:extLst>
               <a:ext uri="{FF2B5EF4-FFF2-40B4-BE49-F238E27FC236}">
-                <a16:creationId xmlns:a16="http://schemas.microsoft.com/office/drawing/2014/main" id="{B231E5C6-2B54-84C2-16EF-E7F948314899}"/>
+                <a16:creationId xmlns:a16="http://schemas.microsoft.com/office/drawing/2014/main" id="{36FB96D1-D2DF-E964-1AA3-7FE2DC569685}"/>
               </a:ext>
             </a:extLst>
           </p:cNvPr>
@@ -15955,7 +15956,7 @@
           <p:cNvPr id="9" name="TextBox 8">
             <a:extLst>
               <a:ext uri="{FF2B5EF4-FFF2-40B4-BE49-F238E27FC236}">
-                <a16:creationId xmlns:a16="http://schemas.microsoft.com/office/drawing/2014/main" id="{A9C5A1E4-8993-BB7C-7F55-C830C50CBF69}"/>
+                <a16:creationId xmlns:a16="http://schemas.microsoft.com/office/drawing/2014/main" id="{509C9231-3729-3319-67E7-52770A201A65}"/>
               </a:ext>
             </a:extLst>
           </p:cNvPr>
@@ -16004,7 +16005,7 @@
     </p:spTree>
     <p:extLst>
       <p:ext uri="{BB962C8B-B14F-4D97-AF65-F5344CB8AC3E}">
-        <p14:creationId xmlns:p14="http://schemas.microsoft.com/office/powerpoint/2010/main" val="1999937116"/>
+        <p14:creationId xmlns:p14="http://schemas.microsoft.com/office/powerpoint/2010/main" val="306408192"/>
       </p:ext>
     </p:extLst>
   </p:cSld>
@@ -16044,7 +16045,7 @@
           <p:cNvPr id="2" name="TextBox 1">
             <a:extLst>
               <a:ext uri="{FF2B5EF4-FFF2-40B4-BE49-F238E27FC236}">
-                <a16:creationId xmlns:a16="http://schemas.microsoft.com/office/drawing/2014/main" id="{E922DE64-7BED-56C5-1796-0ED83B419B69}"/>
+                <a16:creationId xmlns:a16="http://schemas.microsoft.com/office/drawing/2014/main" id="{2795A164-9597-8CD5-E296-55503A658442}"/>
               </a:ext>
             </a:extLst>
           </p:cNvPr>
@@ -16089,7 +16090,7 @@
           <p:cNvPr id="3" name="TextBox 2">
             <a:extLst>
               <a:ext uri="{FF2B5EF4-FFF2-40B4-BE49-F238E27FC236}">
-                <a16:creationId xmlns:a16="http://schemas.microsoft.com/office/drawing/2014/main" id="{13DE3DA7-878F-744E-4EAD-D795A76CF555}"/>
+                <a16:creationId xmlns:a16="http://schemas.microsoft.com/office/drawing/2014/main" id="{133AA931-10EB-ADA7-09B9-CC4D8D0E9D58}"/>
               </a:ext>
             </a:extLst>
           </p:cNvPr>
@@ -16134,7 +16135,7 @@
           <p:cNvPr id="5" name="Picture 4">
             <a:extLst>
               <a:ext uri="{FF2B5EF4-FFF2-40B4-BE49-F238E27FC236}">
-                <a16:creationId xmlns:a16="http://schemas.microsoft.com/office/drawing/2014/main" id="{0D026D68-9D98-7965-E563-8DA9C7B4821E}"/>
+                <a16:creationId xmlns:a16="http://schemas.microsoft.com/office/drawing/2014/main" id="{304D09C4-C7D7-FAEB-C5C5-F5647920A440}"/>
               </a:ext>
             </a:extLst>
           </p:cNvPr>
@@ -16170,7 +16171,7 @@
           <p:cNvPr id="6" name="TextBox 5">
             <a:extLst>
               <a:ext uri="{FF2B5EF4-FFF2-40B4-BE49-F238E27FC236}">
-                <a16:creationId xmlns:a16="http://schemas.microsoft.com/office/drawing/2014/main" id="{AC84D651-8BF9-A070-FB69-5CFC7C3FABFD}"/>
+                <a16:creationId xmlns:a16="http://schemas.microsoft.com/office/drawing/2014/main" id="{BF663FCF-57B3-9154-3CD4-DAFE33931493}"/>
               </a:ext>
             </a:extLst>
           </p:cNvPr>
@@ -16215,7 +16216,7 @@
           <p:cNvPr id="7" name="TextBox 6">
             <a:extLst>
               <a:ext uri="{FF2B5EF4-FFF2-40B4-BE49-F238E27FC236}">
-                <a16:creationId xmlns:a16="http://schemas.microsoft.com/office/drawing/2014/main" id="{492B7BAF-E535-E179-B256-648BDDA1E728}"/>
+                <a16:creationId xmlns:a16="http://schemas.microsoft.com/office/drawing/2014/main" id="{1879A0DE-8BA3-2AD2-3855-FA533420659E}"/>
               </a:ext>
             </a:extLst>
           </p:cNvPr>
@@ -16260,7 +16261,7 @@
           <p:cNvPr id="8" name="TextBox 7">
             <a:extLst>
               <a:ext uri="{FF2B5EF4-FFF2-40B4-BE49-F238E27FC236}">
-                <a16:creationId xmlns:a16="http://schemas.microsoft.com/office/drawing/2014/main" id="{6A845553-D67B-88CC-1E11-678E167C6895}"/>
+                <a16:creationId xmlns:a16="http://schemas.microsoft.com/office/drawing/2014/main" id="{3F8D7B92-3C61-819B-A494-5E2ECCB23D8A}"/>
               </a:ext>
             </a:extLst>
           </p:cNvPr>
@@ -16305,7 +16306,7 @@
           <p:cNvPr id="10" name="Picture 9">
             <a:extLst>
               <a:ext uri="{FF2B5EF4-FFF2-40B4-BE49-F238E27FC236}">
-                <a16:creationId xmlns:a16="http://schemas.microsoft.com/office/drawing/2014/main" id="{71FDADAB-8981-3006-D805-01224944FAAC}"/>
+                <a16:creationId xmlns:a16="http://schemas.microsoft.com/office/drawing/2014/main" id="{63D4F075-24D3-6DFD-FCDF-22378D2F6EA5}"/>
               </a:ext>
             </a:extLst>
           </p:cNvPr>
@@ -16341,7 +16342,7 @@
           <p:cNvPr id="11" name="TextBox 10">
             <a:extLst>
               <a:ext uri="{FF2B5EF4-FFF2-40B4-BE49-F238E27FC236}">
-                <a16:creationId xmlns:a16="http://schemas.microsoft.com/office/drawing/2014/main" id="{F1678ADF-173C-33CE-C31D-0014302CE266}"/>
+                <a16:creationId xmlns:a16="http://schemas.microsoft.com/office/drawing/2014/main" id="{5C6AE7D8-C2CD-41F6-4314-ED6BF88292AE}"/>
               </a:ext>
             </a:extLst>
           </p:cNvPr>
@@ -16386,7 +16387,7 @@
           <p:cNvPr id="12" name="TextBox 11">
             <a:extLst>
               <a:ext uri="{FF2B5EF4-FFF2-40B4-BE49-F238E27FC236}">
-                <a16:creationId xmlns:a16="http://schemas.microsoft.com/office/drawing/2014/main" id="{AC1C2764-BE72-DDA7-D738-D9723734C2CF}"/>
+                <a16:creationId xmlns:a16="http://schemas.microsoft.com/office/drawing/2014/main" id="{B34EFB1B-E6E6-EDF7-D66A-07EBAA77CF7D}"/>
               </a:ext>
             </a:extLst>
           </p:cNvPr>
@@ -16431,7 +16432,7 @@
           <p:cNvPr id="13" name="TextBox 12">
             <a:extLst>
               <a:ext uri="{FF2B5EF4-FFF2-40B4-BE49-F238E27FC236}">
-                <a16:creationId xmlns:a16="http://schemas.microsoft.com/office/drawing/2014/main" id="{957BA3A0-8982-DABF-E133-C4852D06FDBB}"/>
+                <a16:creationId xmlns:a16="http://schemas.microsoft.com/office/drawing/2014/main" id="{B6211425-3BB0-DB9A-2553-416FC3347E09}"/>
               </a:ext>
             </a:extLst>
           </p:cNvPr>
@@ -16476,7 +16477,7 @@
           <p:cNvPr id="15" name="Picture 14">
             <a:extLst>
               <a:ext uri="{FF2B5EF4-FFF2-40B4-BE49-F238E27FC236}">
-                <a16:creationId xmlns:a16="http://schemas.microsoft.com/office/drawing/2014/main" id="{7A77F322-6769-B7EF-A9CF-10C2121B6235}"/>
+                <a16:creationId xmlns:a16="http://schemas.microsoft.com/office/drawing/2014/main" id="{646378AE-BFED-1067-76E1-0D4716817926}"/>
               </a:ext>
             </a:extLst>
           </p:cNvPr>
@@ -16512,7 +16513,7 @@
           <p:cNvPr id="16" name="TextBox 15">
             <a:extLst>
               <a:ext uri="{FF2B5EF4-FFF2-40B4-BE49-F238E27FC236}">
-                <a16:creationId xmlns:a16="http://schemas.microsoft.com/office/drawing/2014/main" id="{8B8E2E34-ECD1-7DF3-1B20-B01137249611}"/>
+                <a16:creationId xmlns:a16="http://schemas.microsoft.com/office/drawing/2014/main" id="{87FB62BB-7FC8-DDB6-DB13-3F4F40A1CDA2}"/>
               </a:ext>
             </a:extLst>
           </p:cNvPr>
@@ -16557,7 +16558,7 @@
           <p:cNvPr id="17" name="TextBox 16">
             <a:extLst>
               <a:ext uri="{FF2B5EF4-FFF2-40B4-BE49-F238E27FC236}">
-                <a16:creationId xmlns:a16="http://schemas.microsoft.com/office/drawing/2014/main" id="{B34AAB70-22F2-AE8F-E01A-83AD97A00F20}"/>
+                <a16:creationId xmlns:a16="http://schemas.microsoft.com/office/drawing/2014/main" id="{14BA968D-0F81-34A0-9CAC-B2136E3D2FC0}"/>
               </a:ext>
             </a:extLst>
           </p:cNvPr>
@@ -16602,7 +16603,7 @@
           <p:cNvPr id="18" name="TextBox 17">
             <a:extLst>
               <a:ext uri="{FF2B5EF4-FFF2-40B4-BE49-F238E27FC236}">
-                <a16:creationId xmlns:a16="http://schemas.microsoft.com/office/drawing/2014/main" id="{6441BC5D-D8F3-1861-C24B-3E71E07F2394}"/>
+                <a16:creationId xmlns:a16="http://schemas.microsoft.com/office/drawing/2014/main" id="{397D0F80-7A41-18FF-1BB5-7374899F9421}"/>
               </a:ext>
             </a:extLst>
           </p:cNvPr>
@@ -16647,7 +16648,7 @@
           <p:cNvPr id="20" name="Picture 19">
             <a:extLst>
               <a:ext uri="{FF2B5EF4-FFF2-40B4-BE49-F238E27FC236}">
-                <a16:creationId xmlns:a16="http://schemas.microsoft.com/office/drawing/2014/main" id="{00282FAF-B20F-AAAD-1276-2D6BE6B60F8C}"/>
+                <a16:creationId xmlns:a16="http://schemas.microsoft.com/office/drawing/2014/main" id="{5D9E540E-5201-6006-A1EB-D046CA119051}"/>
               </a:ext>
             </a:extLst>
           </p:cNvPr>
@@ -16683,7 +16684,7 @@
           <p:cNvPr id="21" name="TextBox 20">
             <a:extLst>
               <a:ext uri="{FF2B5EF4-FFF2-40B4-BE49-F238E27FC236}">
-                <a16:creationId xmlns:a16="http://schemas.microsoft.com/office/drawing/2014/main" id="{D4B88461-B8F4-A373-6D0C-24E0765E2825}"/>
+                <a16:creationId xmlns:a16="http://schemas.microsoft.com/office/drawing/2014/main" id="{88EE9EF4-D7D0-1985-BBF4-E63EE288440B}"/>
               </a:ext>
             </a:extLst>
           </p:cNvPr>
@@ -16728,7 +16729,7 @@
           <p:cNvPr id="22" name="TextBox 21">
             <a:extLst>
               <a:ext uri="{FF2B5EF4-FFF2-40B4-BE49-F238E27FC236}">
-                <a16:creationId xmlns:a16="http://schemas.microsoft.com/office/drawing/2014/main" id="{6CB967D2-66C3-1B63-4534-6F98B03BB106}"/>
+                <a16:creationId xmlns:a16="http://schemas.microsoft.com/office/drawing/2014/main" id="{962BF3A0-C520-B5BD-7012-241153384CD6}"/>
               </a:ext>
             </a:extLst>
           </p:cNvPr>
@@ -16773,7 +16774,7 @@
           <p:cNvPr id="23" name="TextBox 22">
             <a:extLst>
               <a:ext uri="{FF2B5EF4-FFF2-40B4-BE49-F238E27FC236}">
-                <a16:creationId xmlns:a16="http://schemas.microsoft.com/office/drawing/2014/main" id="{8497C7B3-F316-35A9-9557-1F689621815C}"/>
+                <a16:creationId xmlns:a16="http://schemas.microsoft.com/office/drawing/2014/main" id="{275E4A08-A544-3650-BD29-849C5D3021A4}"/>
               </a:ext>
             </a:extLst>
           </p:cNvPr>
@@ -16818,7 +16819,7 @@
           <p:cNvPr id="24" name="TextBox 23">
             <a:extLst>
               <a:ext uri="{FF2B5EF4-FFF2-40B4-BE49-F238E27FC236}">
-                <a16:creationId xmlns:a16="http://schemas.microsoft.com/office/drawing/2014/main" id="{DE90793F-A760-FF6A-4411-A720A00EE969}"/>
+                <a16:creationId xmlns:a16="http://schemas.microsoft.com/office/drawing/2014/main" id="{54B217D8-6FB9-4F5C-2688-079262B8C3DB}"/>
               </a:ext>
             </a:extLst>
           </p:cNvPr>
@@ -16867,7 +16868,7 @@
     </p:spTree>
     <p:extLst>
       <p:ext uri="{BB962C8B-B14F-4D97-AF65-F5344CB8AC3E}">
-        <p14:creationId xmlns:p14="http://schemas.microsoft.com/office/powerpoint/2010/main" val="2992462741"/>
+        <p14:creationId xmlns:p14="http://schemas.microsoft.com/office/powerpoint/2010/main" val="2860621262"/>
       </p:ext>
     </p:extLst>
   </p:cSld>

</xml_diff>

<commit_message>
Align classroom demo with minimal Material Studio navigation
</commit_message>
<xml_diff>
--- a/reports/presentation/material_classification.pptx
+++ b/reports/presentation/material_classification.pptx
@@ -1790,7 +1790,7 @@
             </a:lvl1pPr>
           </a:lstStyle>
           <a:p>
-            <a:fld id="{2316FD41-E0BC-48A7-B3A2-4D36D74FA440}" type="datetimeFigureOut">
+            <a:fld id="{0EC3AC47-FE24-45D2-A6C3-F58E108875C4}" type="datetimeFigureOut">
               <a:rPr lang="en-ZA" smtClean="0"/>
               <a:t>2026/10/27</a:t>
             </a:fld>
@@ -1949,7 +1949,7 @@
             </a:lvl1pPr>
           </a:lstStyle>
           <a:p>
-            <a:fld id="{E1BAD130-31BD-445B-9E2A-3B0017C46E9F}" type="slidenum">
+            <a:fld id="{856328EC-B0AC-4F93-B5FB-351936BA95BE}" type="slidenum">
               <a:rPr lang="en-ZA" smtClean="0"/>
               <a:t>‹#›</a:t>
             </a:fld>
@@ -1960,7 +1960,7 @@
     </p:spTree>
     <p:extLst>
       <p:ext uri="{BB962C8B-B14F-4D97-AF65-F5344CB8AC3E}">
-        <p14:creationId xmlns:p14="http://schemas.microsoft.com/office/powerpoint/2010/main" val="982316689"/>
+        <p14:creationId xmlns:p14="http://schemas.microsoft.com/office/powerpoint/2010/main" val="3185409790"/>
       </p:ext>
     </p:extLst>
   </p:cSld>
@@ -2130,7 +2130,7 @@
           <a:bodyPr/>
           <a:lstStyle/>
           <a:p>
-            <a:fld id="{E1BAD130-31BD-445B-9E2A-3B0017C46E9F}" type="slidenum">
+            <a:fld id="{856328EC-B0AC-4F93-B5FB-351936BA95BE}" type="slidenum">
               <a:rPr lang="en-ZA" smtClean="0"/>
               <a:t>1</a:t>
             </a:fld>
@@ -2141,7 +2141,7 @@
     </p:spTree>
     <p:extLst>
       <p:ext uri="{BB962C8B-B14F-4D97-AF65-F5344CB8AC3E}">
-        <p14:creationId xmlns:p14="http://schemas.microsoft.com/office/powerpoint/2010/main" val="1780643376"/>
+        <p14:creationId xmlns:p14="http://schemas.microsoft.com/office/powerpoint/2010/main" val="497128931"/>
       </p:ext>
     </p:extLst>
   </p:cSld>
@@ -2222,7 +2222,7 @@
           <a:bodyPr/>
           <a:lstStyle/>
           <a:p>
-            <a:fld id="{E1BAD130-31BD-445B-9E2A-3B0017C46E9F}" type="slidenum">
+            <a:fld id="{856328EC-B0AC-4F93-B5FB-351936BA95BE}" type="slidenum">
               <a:rPr lang="en-ZA" smtClean="0"/>
               <a:t>10</a:t>
             </a:fld>
@@ -2233,7 +2233,7 @@
     </p:spTree>
     <p:extLst>
       <p:ext uri="{BB962C8B-B14F-4D97-AF65-F5344CB8AC3E}">
-        <p14:creationId xmlns:p14="http://schemas.microsoft.com/office/powerpoint/2010/main" val="3953955489"/>
+        <p14:creationId xmlns:p14="http://schemas.microsoft.com/office/powerpoint/2010/main" val="3848560492"/>
       </p:ext>
     </p:extLst>
   </p:cSld>
@@ -2315,7 +2315,7 @@
           <a:bodyPr/>
           <a:lstStyle/>
           <a:p>
-            <a:fld id="{E1BAD130-31BD-445B-9E2A-3B0017C46E9F}" type="slidenum">
+            <a:fld id="{856328EC-B0AC-4F93-B5FB-351936BA95BE}" type="slidenum">
               <a:rPr lang="en-ZA" smtClean="0"/>
               <a:t>11</a:t>
             </a:fld>
@@ -2326,7 +2326,7 @@
     </p:spTree>
     <p:extLst>
       <p:ext uri="{BB962C8B-B14F-4D97-AF65-F5344CB8AC3E}">
-        <p14:creationId xmlns:p14="http://schemas.microsoft.com/office/powerpoint/2010/main" val="2678602747"/>
+        <p14:creationId xmlns:p14="http://schemas.microsoft.com/office/powerpoint/2010/main" val="285755986"/>
       </p:ext>
     </p:extLst>
   </p:cSld>
@@ -2406,7 +2406,7 @@
           <a:bodyPr/>
           <a:lstStyle/>
           <a:p>
-            <a:fld id="{E1BAD130-31BD-445B-9E2A-3B0017C46E9F}" type="slidenum">
+            <a:fld id="{856328EC-B0AC-4F93-B5FB-351936BA95BE}" type="slidenum">
               <a:rPr lang="en-ZA" smtClean="0"/>
               <a:t>12</a:t>
             </a:fld>
@@ -2417,7 +2417,7 @@
     </p:spTree>
     <p:extLst>
       <p:ext uri="{BB962C8B-B14F-4D97-AF65-F5344CB8AC3E}">
-        <p14:creationId xmlns:p14="http://schemas.microsoft.com/office/powerpoint/2010/main" val="175005412"/>
+        <p14:creationId xmlns:p14="http://schemas.microsoft.com/office/powerpoint/2010/main" val="1662103839"/>
       </p:ext>
     </p:extLst>
   </p:cSld>
@@ -2473,7 +2473,7 @@
           <a:p>
             <a:r>
               <a:rPr lang="en-US"/>
-              <a:t>Use the separate classroom guide. The expected app sequence is Classify, Results, then Dataset. Select an image or built-in sample and model, start a prediction, let the loading state complete, and inspect probabilities. Only call this a live prediction after the actual runtime has completed inference for that input. In Results, compare stored model metrics and confusions, then inspect the class gallery in Dataset. The app is under parallel integration and this workflow is not yet verified here. If runtime inference is unavailable, explicitly announce the offline fallback and use stored results or slide 9 examples. Conclude that source-aware evaluation supports the primary point target, but uncertainty and compression weakness limit broad claims.
+              <a:t>Use the separate classroom guide. Navigation is Classify, Study, Samples and About. Classify shows one image with a compact bottom toolbar: Open image, Samples, the model menu and Classify. Choose an image or sample and model, start classification, and let the loading state complete. Explain the concise class and confidence result, then open Details for the full probability distribution. Only call this a live prediction after the actual runtime has completed inference for that input. In Study, compare stored model metrics and confusions, then browse the class gallery in Samples. About is available in navigation. The redesigned minimal app has not yet been visually verified here. If runtime inference is unavailable, explicitly announce the offline fallback and use stored results or slide 9 examples. Conclude that source-aware evaluation supports the primary point target, but uncertainty and compression weakness limit broad claims.
 Sources:
 docs/CLASSROOM_DEMO.md
 reports/results/v3/fresh/frozen_selected/evaluation.json</a:t>
@@ -2497,7 +2497,7 @@
           <a:bodyPr/>
           <a:lstStyle/>
           <a:p>
-            <a:fld id="{E1BAD130-31BD-445B-9E2A-3B0017C46E9F}" type="slidenum">
+            <a:fld id="{856328EC-B0AC-4F93-B5FB-351936BA95BE}" type="slidenum">
               <a:rPr lang="en-ZA" smtClean="0"/>
               <a:t>13</a:t>
             </a:fld>
@@ -2508,7 +2508,7 @@
     </p:spTree>
     <p:extLst>
       <p:ext uri="{BB962C8B-B14F-4D97-AF65-F5344CB8AC3E}">
-        <p14:creationId xmlns:p14="http://schemas.microsoft.com/office/powerpoint/2010/main" val="3351955254"/>
+        <p14:creationId xmlns:p14="http://schemas.microsoft.com/office/powerpoint/2010/main" val="1915119635"/>
       </p:ext>
     </p:extLst>
   </p:cSld>
@@ -2588,7 +2588,7 @@
           <a:bodyPr/>
           <a:lstStyle/>
           <a:p>
-            <a:fld id="{E1BAD130-31BD-445B-9E2A-3B0017C46E9F}" type="slidenum">
+            <a:fld id="{856328EC-B0AC-4F93-B5FB-351936BA95BE}" type="slidenum">
               <a:rPr lang="en-ZA" smtClean="0"/>
               <a:t>14</a:t>
             </a:fld>
@@ -2599,7 +2599,7 @@
     </p:spTree>
     <p:extLst>
       <p:ext uri="{BB962C8B-B14F-4D97-AF65-F5344CB8AC3E}">
-        <p14:creationId xmlns:p14="http://schemas.microsoft.com/office/powerpoint/2010/main" val="3410265068"/>
+        <p14:creationId xmlns:p14="http://schemas.microsoft.com/office/powerpoint/2010/main" val="1825269484"/>
       </p:ext>
     </p:extLst>
   </p:cSld>
@@ -2679,7 +2679,7 @@
           <a:bodyPr/>
           <a:lstStyle/>
           <a:p>
-            <a:fld id="{E1BAD130-31BD-445B-9E2A-3B0017C46E9F}" type="slidenum">
+            <a:fld id="{856328EC-B0AC-4F93-B5FB-351936BA95BE}" type="slidenum">
               <a:rPr lang="en-ZA" smtClean="0"/>
               <a:t>2</a:t>
             </a:fld>
@@ -2690,7 +2690,7 @@
     </p:spTree>
     <p:extLst>
       <p:ext uri="{BB962C8B-B14F-4D97-AF65-F5344CB8AC3E}">
-        <p14:creationId xmlns:p14="http://schemas.microsoft.com/office/powerpoint/2010/main" val="2047262979"/>
+        <p14:creationId xmlns:p14="http://schemas.microsoft.com/office/powerpoint/2010/main" val="33644997"/>
       </p:ext>
     </p:extLst>
   </p:cSld>
@@ -2773,7 +2773,7 @@
           <a:bodyPr/>
           <a:lstStyle/>
           <a:p>
-            <a:fld id="{E1BAD130-31BD-445B-9E2A-3B0017C46E9F}" type="slidenum">
+            <a:fld id="{856328EC-B0AC-4F93-B5FB-351936BA95BE}" type="slidenum">
               <a:rPr lang="en-ZA" smtClean="0"/>
               <a:t>3</a:t>
             </a:fld>
@@ -2784,7 +2784,7 @@
     </p:spTree>
     <p:extLst>
       <p:ext uri="{BB962C8B-B14F-4D97-AF65-F5344CB8AC3E}">
-        <p14:creationId xmlns:p14="http://schemas.microsoft.com/office/powerpoint/2010/main" val="2512518647"/>
+        <p14:creationId xmlns:p14="http://schemas.microsoft.com/office/powerpoint/2010/main" val="1777440868"/>
       </p:ext>
     </p:extLst>
   </p:cSld>
@@ -2869,7 +2869,7 @@
           <a:bodyPr/>
           <a:lstStyle/>
           <a:p>
-            <a:fld id="{E1BAD130-31BD-445B-9E2A-3B0017C46E9F}" type="slidenum">
+            <a:fld id="{856328EC-B0AC-4F93-B5FB-351936BA95BE}" type="slidenum">
               <a:rPr lang="en-ZA" smtClean="0"/>
               <a:t>4</a:t>
             </a:fld>
@@ -2880,7 +2880,7 @@
     </p:spTree>
     <p:extLst>
       <p:ext uri="{BB962C8B-B14F-4D97-AF65-F5344CB8AC3E}">
-        <p14:creationId xmlns:p14="http://schemas.microsoft.com/office/powerpoint/2010/main" val="1555926778"/>
+        <p14:creationId xmlns:p14="http://schemas.microsoft.com/office/powerpoint/2010/main" val="129803084"/>
       </p:ext>
     </p:extLst>
   </p:cSld>
@@ -2963,7 +2963,7 @@
           <a:bodyPr/>
           <a:lstStyle/>
           <a:p>
-            <a:fld id="{E1BAD130-31BD-445B-9E2A-3B0017C46E9F}" type="slidenum">
+            <a:fld id="{856328EC-B0AC-4F93-B5FB-351936BA95BE}" type="slidenum">
               <a:rPr lang="en-ZA" smtClean="0"/>
               <a:t>5</a:t>
             </a:fld>
@@ -2974,7 +2974,7 @@
     </p:spTree>
     <p:extLst>
       <p:ext uri="{BB962C8B-B14F-4D97-AF65-F5344CB8AC3E}">
-        <p14:creationId xmlns:p14="http://schemas.microsoft.com/office/powerpoint/2010/main" val="388580393"/>
+        <p14:creationId xmlns:p14="http://schemas.microsoft.com/office/powerpoint/2010/main" val="654390449"/>
       </p:ext>
     </p:extLst>
   </p:cSld>
@@ -3057,7 +3057,7 @@
           <a:bodyPr/>
           <a:lstStyle/>
           <a:p>
-            <a:fld id="{E1BAD130-31BD-445B-9E2A-3B0017C46E9F}" type="slidenum">
+            <a:fld id="{856328EC-B0AC-4F93-B5FB-351936BA95BE}" type="slidenum">
               <a:rPr lang="en-ZA" smtClean="0"/>
               <a:t>6</a:t>
             </a:fld>
@@ -3068,7 +3068,7 @@
     </p:spTree>
     <p:extLst>
       <p:ext uri="{BB962C8B-B14F-4D97-AF65-F5344CB8AC3E}">
-        <p14:creationId xmlns:p14="http://schemas.microsoft.com/office/powerpoint/2010/main" val="2096959774"/>
+        <p14:creationId xmlns:p14="http://schemas.microsoft.com/office/powerpoint/2010/main" val="3145453628"/>
       </p:ext>
     </p:extLst>
   </p:cSld>
@@ -3151,7 +3151,7 @@
           <a:bodyPr/>
           <a:lstStyle/>
           <a:p>
-            <a:fld id="{E1BAD130-31BD-445B-9E2A-3B0017C46E9F}" type="slidenum">
+            <a:fld id="{856328EC-B0AC-4F93-B5FB-351936BA95BE}" type="slidenum">
               <a:rPr lang="en-ZA" smtClean="0"/>
               <a:t>7</a:t>
             </a:fld>
@@ -3162,7 +3162,7 @@
     </p:spTree>
     <p:extLst>
       <p:ext uri="{BB962C8B-B14F-4D97-AF65-F5344CB8AC3E}">
-        <p14:creationId xmlns:p14="http://schemas.microsoft.com/office/powerpoint/2010/main" val="677590259"/>
+        <p14:creationId xmlns:p14="http://schemas.microsoft.com/office/powerpoint/2010/main" val="1519523194"/>
       </p:ext>
     </p:extLst>
   </p:cSld>
@@ -3242,7 +3242,7 @@
           <a:bodyPr/>
           <a:lstStyle/>
           <a:p>
-            <a:fld id="{E1BAD130-31BD-445B-9E2A-3B0017C46E9F}" type="slidenum">
+            <a:fld id="{856328EC-B0AC-4F93-B5FB-351936BA95BE}" type="slidenum">
               <a:rPr lang="en-ZA" smtClean="0"/>
               <a:t>8</a:t>
             </a:fld>
@@ -3253,7 +3253,7 @@
     </p:spTree>
     <p:extLst>
       <p:ext uri="{BB962C8B-B14F-4D97-AF65-F5344CB8AC3E}">
-        <p14:creationId xmlns:p14="http://schemas.microsoft.com/office/powerpoint/2010/main" val="2481147158"/>
+        <p14:creationId xmlns:p14="http://schemas.microsoft.com/office/powerpoint/2010/main" val="592776580"/>
       </p:ext>
     </p:extLst>
   </p:cSld>
@@ -3333,7 +3333,7 @@
           <a:bodyPr/>
           <a:lstStyle/>
           <a:p>
-            <a:fld id="{E1BAD130-31BD-445B-9E2A-3B0017C46E9F}" type="slidenum">
+            <a:fld id="{856328EC-B0AC-4F93-B5FB-351936BA95BE}" type="slidenum">
               <a:rPr lang="en-ZA" smtClean="0"/>
               <a:t>9</a:t>
             </a:fld>
@@ -3344,7 +3344,7 @@
     </p:spTree>
     <p:extLst>
       <p:ext uri="{BB962C8B-B14F-4D97-AF65-F5344CB8AC3E}">
-        <p14:creationId xmlns:p14="http://schemas.microsoft.com/office/powerpoint/2010/main" val="284482326"/>
+        <p14:creationId xmlns:p14="http://schemas.microsoft.com/office/powerpoint/2010/main" val="3639448359"/>
       </p:ext>
     </p:extLst>
   </p:cSld>
@@ -3376,7 +3376,7 @@
           <p:cNvPr id="2" name="Title 1">
             <a:extLst>
               <a:ext uri="{FF2B5EF4-FFF2-40B4-BE49-F238E27FC236}">
-                <a16:creationId xmlns:a16="http://schemas.microsoft.com/office/drawing/2014/main" id="{D75F3056-F4A4-DB53-185F-F1DE08038E4F}"/>
+                <a16:creationId xmlns:a16="http://schemas.microsoft.com/office/drawing/2014/main" id="{FEF8F977-9855-5C00-4043-426524267CFD}"/>
               </a:ext>
             </a:extLst>
           </p:cNvPr>
@@ -3414,7 +3414,7 @@
           <p:cNvPr id="3" name="Subtitle 2">
             <a:extLst>
               <a:ext uri="{FF2B5EF4-FFF2-40B4-BE49-F238E27FC236}">
-                <a16:creationId xmlns:a16="http://schemas.microsoft.com/office/drawing/2014/main" id="{CD620FE6-45EE-3657-0FE6-277A94F9E2C2}"/>
+                <a16:creationId xmlns:a16="http://schemas.microsoft.com/office/drawing/2014/main" id="{65980C87-A212-725B-16A0-28E8E24C02FC}"/>
               </a:ext>
             </a:extLst>
           </p:cNvPr>
@@ -3485,7 +3485,7 @@
           <p:cNvPr id="4" name="Date Placeholder 3">
             <a:extLst>
               <a:ext uri="{FF2B5EF4-FFF2-40B4-BE49-F238E27FC236}">
-                <a16:creationId xmlns:a16="http://schemas.microsoft.com/office/drawing/2014/main" id="{F6DAF359-75D8-13B7-5953-BE597A7EFC74}"/>
+                <a16:creationId xmlns:a16="http://schemas.microsoft.com/office/drawing/2014/main" id="{5A14B967-A9DE-9832-48D6-EA10212B3816}"/>
               </a:ext>
             </a:extLst>
           </p:cNvPr>
@@ -3501,7 +3501,7 @@
           <a:bodyPr/>
           <a:lstStyle/>
           <a:p>
-            <a:fld id="{68AB6C0A-96D3-480E-84E1-5AAAF379C7DC}" type="datetimeFigureOut">
+            <a:fld id="{8153C6BC-5116-40AF-9DCC-0B33639BC89C}" type="datetimeFigureOut">
               <a:rPr lang="en-ZA" smtClean="0"/>
               <a:t>2026/10/27</a:t>
             </a:fld>
@@ -3514,7 +3514,7 @@
           <p:cNvPr id="5" name="Footer Placeholder 4">
             <a:extLst>
               <a:ext uri="{FF2B5EF4-FFF2-40B4-BE49-F238E27FC236}">
-                <a16:creationId xmlns:a16="http://schemas.microsoft.com/office/drawing/2014/main" id="{34169A32-88CC-A007-6F47-64D16DCD79E3}"/>
+                <a16:creationId xmlns:a16="http://schemas.microsoft.com/office/drawing/2014/main" id="{FE259818-9307-C1D9-2827-85273BA941EC}"/>
               </a:ext>
             </a:extLst>
           </p:cNvPr>
@@ -3539,7 +3539,7 @@
           <p:cNvPr id="6" name="Slide Number Placeholder 5">
             <a:extLst>
               <a:ext uri="{FF2B5EF4-FFF2-40B4-BE49-F238E27FC236}">
-                <a16:creationId xmlns:a16="http://schemas.microsoft.com/office/drawing/2014/main" id="{30A5EF19-41CC-E38F-D23E-AE0A68A33340}"/>
+                <a16:creationId xmlns:a16="http://schemas.microsoft.com/office/drawing/2014/main" id="{E77C9536-423B-C4A5-5CC8-6F1B1ED9FDA4}"/>
               </a:ext>
             </a:extLst>
           </p:cNvPr>
@@ -3555,7 +3555,7 @@
           <a:bodyPr/>
           <a:lstStyle/>
           <a:p>
-            <a:fld id="{1D551152-66F7-4AC9-B92F-B6D6C08E8FCF}" type="slidenum">
+            <a:fld id="{DE9666F0-EC1E-4F49-9C01-524E517EA2EF}" type="slidenum">
               <a:rPr lang="en-ZA" smtClean="0"/>
               <a:t>‹#›</a:t>
             </a:fld>
@@ -3566,7 +3566,7 @@
     </p:spTree>
     <p:extLst>
       <p:ext uri="{BB962C8B-B14F-4D97-AF65-F5344CB8AC3E}">
-        <p14:creationId xmlns:p14="http://schemas.microsoft.com/office/powerpoint/2010/main" val="3474054869"/>
+        <p14:creationId xmlns:p14="http://schemas.microsoft.com/office/powerpoint/2010/main" val="4198162697"/>
       </p:ext>
     </p:extLst>
   </p:cSld>
@@ -3598,7 +3598,7 @@
           <p:cNvPr id="2" name="Title 1">
             <a:extLst>
               <a:ext uri="{FF2B5EF4-FFF2-40B4-BE49-F238E27FC236}">
-                <a16:creationId xmlns:a16="http://schemas.microsoft.com/office/drawing/2014/main" id="{BFB8A844-2235-424B-E6DA-3CCE1411A84E}"/>
+                <a16:creationId xmlns:a16="http://schemas.microsoft.com/office/drawing/2014/main" id="{1D9F8DF1-EAE5-A3AB-A50B-D5EF5C680122}"/>
               </a:ext>
             </a:extLst>
           </p:cNvPr>
@@ -3627,7 +3627,7 @@
           <p:cNvPr id="3" name="Vertical Text Placeholder 2">
             <a:extLst>
               <a:ext uri="{FF2B5EF4-FFF2-40B4-BE49-F238E27FC236}">
-                <a16:creationId xmlns:a16="http://schemas.microsoft.com/office/drawing/2014/main" id="{1B6DC0C4-EBBE-0A1D-9D30-B72AF7040BA8}"/>
+                <a16:creationId xmlns:a16="http://schemas.microsoft.com/office/drawing/2014/main" id="{D97447E0-BC96-E221-6A5B-DD043305E0BD}"/>
               </a:ext>
             </a:extLst>
           </p:cNvPr>
@@ -3685,7 +3685,7 @@
           <p:cNvPr id="4" name="Date Placeholder 3">
             <a:extLst>
               <a:ext uri="{FF2B5EF4-FFF2-40B4-BE49-F238E27FC236}">
-                <a16:creationId xmlns:a16="http://schemas.microsoft.com/office/drawing/2014/main" id="{2FA9D137-6F23-6197-545D-B83D992CDC15}"/>
+                <a16:creationId xmlns:a16="http://schemas.microsoft.com/office/drawing/2014/main" id="{FA48A156-05A8-EEA2-20A8-C801BA51A827}"/>
               </a:ext>
             </a:extLst>
           </p:cNvPr>
@@ -3701,7 +3701,7 @@
           <a:bodyPr/>
           <a:lstStyle/>
           <a:p>
-            <a:fld id="{68AB6C0A-96D3-480E-84E1-5AAAF379C7DC}" type="datetimeFigureOut">
+            <a:fld id="{8153C6BC-5116-40AF-9DCC-0B33639BC89C}" type="datetimeFigureOut">
               <a:rPr lang="en-ZA" smtClean="0"/>
               <a:t>2026/10/27</a:t>
             </a:fld>
@@ -3714,7 +3714,7 @@
           <p:cNvPr id="5" name="Footer Placeholder 4">
             <a:extLst>
               <a:ext uri="{FF2B5EF4-FFF2-40B4-BE49-F238E27FC236}">
-                <a16:creationId xmlns:a16="http://schemas.microsoft.com/office/drawing/2014/main" id="{3FAB85B4-DC87-3B22-1936-DC3FE3964BEB}"/>
+                <a16:creationId xmlns:a16="http://schemas.microsoft.com/office/drawing/2014/main" id="{B9E002AB-11C9-8152-E16F-23AA98BDF8CF}"/>
               </a:ext>
             </a:extLst>
           </p:cNvPr>
@@ -3739,7 +3739,7 @@
           <p:cNvPr id="6" name="Slide Number Placeholder 5">
             <a:extLst>
               <a:ext uri="{FF2B5EF4-FFF2-40B4-BE49-F238E27FC236}">
-                <a16:creationId xmlns:a16="http://schemas.microsoft.com/office/drawing/2014/main" id="{22FD260A-B235-A4F8-60E9-F82D432938C5}"/>
+                <a16:creationId xmlns:a16="http://schemas.microsoft.com/office/drawing/2014/main" id="{D54CCF08-CCCA-81CE-8DAA-C07D47CB0970}"/>
               </a:ext>
             </a:extLst>
           </p:cNvPr>
@@ -3755,7 +3755,7 @@
           <a:bodyPr/>
           <a:lstStyle/>
           <a:p>
-            <a:fld id="{1D551152-66F7-4AC9-B92F-B6D6C08E8FCF}" type="slidenum">
+            <a:fld id="{DE9666F0-EC1E-4F49-9C01-524E517EA2EF}" type="slidenum">
               <a:rPr lang="en-ZA" smtClean="0"/>
               <a:t>‹#›</a:t>
             </a:fld>
@@ -3766,7 +3766,7 @@
     </p:spTree>
     <p:extLst>
       <p:ext uri="{BB962C8B-B14F-4D97-AF65-F5344CB8AC3E}">
-        <p14:creationId xmlns:p14="http://schemas.microsoft.com/office/powerpoint/2010/main" val="2000092271"/>
+        <p14:creationId xmlns:p14="http://schemas.microsoft.com/office/powerpoint/2010/main" val="3865574982"/>
       </p:ext>
     </p:extLst>
   </p:cSld>
@@ -3798,7 +3798,7 @@
           <p:cNvPr id="2" name="Vertical Title 1">
             <a:extLst>
               <a:ext uri="{FF2B5EF4-FFF2-40B4-BE49-F238E27FC236}">
-                <a16:creationId xmlns:a16="http://schemas.microsoft.com/office/drawing/2014/main" id="{858EC38A-6778-2249-9FEC-974ACC54868C}"/>
+                <a16:creationId xmlns:a16="http://schemas.microsoft.com/office/drawing/2014/main" id="{6D5E0DA1-AF1C-8AB6-A80D-F0C4E347BB5F}"/>
               </a:ext>
             </a:extLst>
           </p:cNvPr>
@@ -3832,7 +3832,7 @@
           <p:cNvPr id="3" name="Vertical Text Placeholder 2">
             <a:extLst>
               <a:ext uri="{FF2B5EF4-FFF2-40B4-BE49-F238E27FC236}">
-                <a16:creationId xmlns:a16="http://schemas.microsoft.com/office/drawing/2014/main" id="{B346C353-F14A-0CE4-0A77-BBF4D41F5472}"/>
+                <a16:creationId xmlns:a16="http://schemas.microsoft.com/office/drawing/2014/main" id="{A43DC5FD-2BD7-EE7C-6AD4-CE9B9C831CB9}"/>
               </a:ext>
             </a:extLst>
           </p:cNvPr>
@@ -3895,7 +3895,7 @@
           <p:cNvPr id="4" name="Date Placeholder 3">
             <a:extLst>
               <a:ext uri="{FF2B5EF4-FFF2-40B4-BE49-F238E27FC236}">
-                <a16:creationId xmlns:a16="http://schemas.microsoft.com/office/drawing/2014/main" id="{417B5813-6E40-D93B-D46E-C9FE3317E926}"/>
+                <a16:creationId xmlns:a16="http://schemas.microsoft.com/office/drawing/2014/main" id="{629CD298-BE93-20B5-B165-F677FC3C431D}"/>
               </a:ext>
             </a:extLst>
           </p:cNvPr>
@@ -3911,7 +3911,7 @@
           <a:bodyPr/>
           <a:lstStyle/>
           <a:p>
-            <a:fld id="{68AB6C0A-96D3-480E-84E1-5AAAF379C7DC}" type="datetimeFigureOut">
+            <a:fld id="{8153C6BC-5116-40AF-9DCC-0B33639BC89C}" type="datetimeFigureOut">
               <a:rPr lang="en-ZA" smtClean="0"/>
               <a:t>2026/10/27</a:t>
             </a:fld>
@@ -3924,7 +3924,7 @@
           <p:cNvPr id="5" name="Footer Placeholder 4">
             <a:extLst>
               <a:ext uri="{FF2B5EF4-FFF2-40B4-BE49-F238E27FC236}">
-                <a16:creationId xmlns:a16="http://schemas.microsoft.com/office/drawing/2014/main" id="{83642CBA-74E2-5BA1-832A-0132A1C00331}"/>
+                <a16:creationId xmlns:a16="http://schemas.microsoft.com/office/drawing/2014/main" id="{DB089361-870A-F9B9-E257-161A08CFCD54}"/>
               </a:ext>
             </a:extLst>
           </p:cNvPr>
@@ -3949,7 +3949,7 @@
           <p:cNvPr id="6" name="Slide Number Placeholder 5">
             <a:extLst>
               <a:ext uri="{FF2B5EF4-FFF2-40B4-BE49-F238E27FC236}">
-                <a16:creationId xmlns:a16="http://schemas.microsoft.com/office/drawing/2014/main" id="{E6396422-E55B-C80B-F614-FFE54A0E2A46}"/>
+                <a16:creationId xmlns:a16="http://schemas.microsoft.com/office/drawing/2014/main" id="{3C4A75C4-E5F2-D8AD-FF8C-5C6EBE35B72E}"/>
               </a:ext>
             </a:extLst>
           </p:cNvPr>
@@ -3965,7 +3965,7 @@
           <a:bodyPr/>
           <a:lstStyle/>
           <a:p>
-            <a:fld id="{1D551152-66F7-4AC9-B92F-B6D6C08E8FCF}" type="slidenum">
+            <a:fld id="{DE9666F0-EC1E-4F49-9C01-524E517EA2EF}" type="slidenum">
               <a:rPr lang="en-ZA" smtClean="0"/>
               <a:t>‹#›</a:t>
             </a:fld>
@@ -3976,7 +3976,7 @@
     </p:spTree>
     <p:extLst>
       <p:ext uri="{BB962C8B-B14F-4D97-AF65-F5344CB8AC3E}">
-        <p14:creationId xmlns:p14="http://schemas.microsoft.com/office/powerpoint/2010/main" val="3597231963"/>
+        <p14:creationId xmlns:p14="http://schemas.microsoft.com/office/powerpoint/2010/main" val="3087013539"/>
       </p:ext>
     </p:extLst>
   </p:cSld>
@@ -4008,7 +4008,7 @@
           <p:cNvPr id="2" name="Title 1">
             <a:extLst>
               <a:ext uri="{FF2B5EF4-FFF2-40B4-BE49-F238E27FC236}">
-                <a16:creationId xmlns:a16="http://schemas.microsoft.com/office/drawing/2014/main" id="{12FA3AA5-A1EC-CF8F-6D6D-CD5C30074565}"/>
+                <a16:creationId xmlns:a16="http://schemas.microsoft.com/office/drawing/2014/main" id="{DD86649F-5D3F-5724-2A89-6BAEC97D4369}"/>
               </a:ext>
             </a:extLst>
           </p:cNvPr>
@@ -4037,7 +4037,7 @@
           <p:cNvPr id="3" name="Content Placeholder 2">
             <a:extLst>
               <a:ext uri="{FF2B5EF4-FFF2-40B4-BE49-F238E27FC236}">
-                <a16:creationId xmlns:a16="http://schemas.microsoft.com/office/drawing/2014/main" id="{865D8BF7-3C4C-AEF0-FB93-4DE9DE398A01}"/>
+                <a16:creationId xmlns:a16="http://schemas.microsoft.com/office/drawing/2014/main" id="{AF71DADA-8A3E-4B07-DC73-3411DA0C7F30}"/>
               </a:ext>
             </a:extLst>
           </p:cNvPr>
@@ -4095,7 +4095,7 @@
           <p:cNvPr id="4" name="Date Placeholder 3">
             <a:extLst>
               <a:ext uri="{FF2B5EF4-FFF2-40B4-BE49-F238E27FC236}">
-                <a16:creationId xmlns:a16="http://schemas.microsoft.com/office/drawing/2014/main" id="{BD74F1C1-A8F5-BD3A-4690-E0158A2693D0}"/>
+                <a16:creationId xmlns:a16="http://schemas.microsoft.com/office/drawing/2014/main" id="{F5845042-84D4-DD02-F50C-2D7E0EDA1005}"/>
               </a:ext>
             </a:extLst>
           </p:cNvPr>
@@ -4111,7 +4111,7 @@
           <a:bodyPr/>
           <a:lstStyle/>
           <a:p>
-            <a:fld id="{68AB6C0A-96D3-480E-84E1-5AAAF379C7DC}" type="datetimeFigureOut">
+            <a:fld id="{8153C6BC-5116-40AF-9DCC-0B33639BC89C}" type="datetimeFigureOut">
               <a:rPr lang="en-ZA" smtClean="0"/>
               <a:t>2026/10/27</a:t>
             </a:fld>
@@ -4124,7 +4124,7 @@
           <p:cNvPr id="5" name="Footer Placeholder 4">
             <a:extLst>
               <a:ext uri="{FF2B5EF4-FFF2-40B4-BE49-F238E27FC236}">
-                <a16:creationId xmlns:a16="http://schemas.microsoft.com/office/drawing/2014/main" id="{293CA3A2-4C69-32A5-F73C-E54D4583E45C}"/>
+                <a16:creationId xmlns:a16="http://schemas.microsoft.com/office/drawing/2014/main" id="{985A6C4F-F347-1E9C-C483-F58B50C0DCEE}"/>
               </a:ext>
             </a:extLst>
           </p:cNvPr>
@@ -4149,7 +4149,7 @@
           <p:cNvPr id="6" name="Slide Number Placeholder 5">
             <a:extLst>
               <a:ext uri="{FF2B5EF4-FFF2-40B4-BE49-F238E27FC236}">
-                <a16:creationId xmlns:a16="http://schemas.microsoft.com/office/drawing/2014/main" id="{D3BD2188-A724-6BAC-3950-B32BA293A73C}"/>
+                <a16:creationId xmlns:a16="http://schemas.microsoft.com/office/drawing/2014/main" id="{64353B9B-E0A7-0E88-4306-48C222CEED24}"/>
               </a:ext>
             </a:extLst>
           </p:cNvPr>
@@ -4165,7 +4165,7 @@
           <a:bodyPr/>
           <a:lstStyle/>
           <a:p>
-            <a:fld id="{1D551152-66F7-4AC9-B92F-B6D6C08E8FCF}" type="slidenum">
+            <a:fld id="{DE9666F0-EC1E-4F49-9C01-524E517EA2EF}" type="slidenum">
               <a:rPr lang="en-ZA" smtClean="0"/>
               <a:t>‹#›</a:t>
             </a:fld>
@@ -4176,7 +4176,7 @@
     </p:spTree>
     <p:extLst>
       <p:ext uri="{BB962C8B-B14F-4D97-AF65-F5344CB8AC3E}">
-        <p14:creationId xmlns:p14="http://schemas.microsoft.com/office/powerpoint/2010/main" val="1450797302"/>
+        <p14:creationId xmlns:p14="http://schemas.microsoft.com/office/powerpoint/2010/main" val="1784490404"/>
       </p:ext>
     </p:extLst>
   </p:cSld>
@@ -4208,7 +4208,7 @@
           <p:cNvPr id="2" name="Title 1">
             <a:extLst>
               <a:ext uri="{FF2B5EF4-FFF2-40B4-BE49-F238E27FC236}">
-                <a16:creationId xmlns:a16="http://schemas.microsoft.com/office/drawing/2014/main" id="{64E618DE-FF5D-D0EF-ACD8-2B2EBBA8E166}"/>
+                <a16:creationId xmlns:a16="http://schemas.microsoft.com/office/drawing/2014/main" id="{BAF4973C-52E6-E200-EB58-D285138FEEFA}"/>
               </a:ext>
             </a:extLst>
           </p:cNvPr>
@@ -4246,7 +4246,7 @@
           <p:cNvPr id="3" name="Text Placeholder 2">
             <a:extLst>
               <a:ext uri="{FF2B5EF4-FFF2-40B4-BE49-F238E27FC236}">
-                <a16:creationId xmlns:a16="http://schemas.microsoft.com/office/drawing/2014/main" id="{F973E2BE-F6F4-D8B0-D451-34BC116C4631}"/>
+                <a16:creationId xmlns:a16="http://schemas.microsoft.com/office/drawing/2014/main" id="{48A6DC84-EE80-2877-4BD7-B4077D3157B0}"/>
               </a:ext>
             </a:extLst>
           </p:cNvPr>
@@ -4371,7 +4371,7 @@
           <p:cNvPr id="4" name="Date Placeholder 3">
             <a:extLst>
               <a:ext uri="{FF2B5EF4-FFF2-40B4-BE49-F238E27FC236}">
-                <a16:creationId xmlns:a16="http://schemas.microsoft.com/office/drawing/2014/main" id="{BE334837-01E8-EDAC-2BFB-7188BBAFCC36}"/>
+                <a16:creationId xmlns:a16="http://schemas.microsoft.com/office/drawing/2014/main" id="{EFD0FF4E-8032-61B1-1D27-BA009C5EB231}"/>
               </a:ext>
             </a:extLst>
           </p:cNvPr>
@@ -4387,7 +4387,7 @@
           <a:bodyPr/>
           <a:lstStyle/>
           <a:p>
-            <a:fld id="{68AB6C0A-96D3-480E-84E1-5AAAF379C7DC}" type="datetimeFigureOut">
+            <a:fld id="{8153C6BC-5116-40AF-9DCC-0B33639BC89C}" type="datetimeFigureOut">
               <a:rPr lang="en-ZA" smtClean="0"/>
               <a:t>2026/10/27</a:t>
             </a:fld>
@@ -4400,7 +4400,7 @@
           <p:cNvPr id="5" name="Footer Placeholder 4">
             <a:extLst>
               <a:ext uri="{FF2B5EF4-FFF2-40B4-BE49-F238E27FC236}">
-                <a16:creationId xmlns:a16="http://schemas.microsoft.com/office/drawing/2014/main" id="{7E6F3287-789F-4B43-431A-204E45D28F71}"/>
+                <a16:creationId xmlns:a16="http://schemas.microsoft.com/office/drawing/2014/main" id="{AE188FBE-EE69-8301-F9F2-695E5D7A3202}"/>
               </a:ext>
             </a:extLst>
           </p:cNvPr>
@@ -4425,7 +4425,7 @@
           <p:cNvPr id="6" name="Slide Number Placeholder 5">
             <a:extLst>
               <a:ext uri="{FF2B5EF4-FFF2-40B4-BE49-F238E27FC236}">
-                <a16:creationId xmlns:a16="http://schemas.microsoft.com/office/drawing/2014/main" id="{A6F4A678-A10A-F3E9-77B3-AD3AA14D27CF}"/>
+                <a16:creationId xmlns:a16="http://schemas.microsoft.com/office/drawing/2014/main" id="{4186E60E-572E-3A1F-26EC-7EF32903E63E}"/>
               </a:ext>
             </a:extLst>
           </p:cNvPr>
@@ -4441,7 +4441,7 @@
           <a:bodyPr/>
           <a:lstStyle/>
           <a:p>
-            <a:fld id="{1D551152-66F7-4AC9-B92F-B6D6C08E8FCF}" type="slidenum">
+            <a:fld id="{DE9666F0-EC1E-4F49-9C01-524E517EA2EF}" type="slidenum">
               <a:rPr lang="en-ZA" smtClean="0"/>
               <a:t>‹#›</a:t>
             </a:fld>
@@ -4452,7 +4452,7 @@
     </p:spTree>
     <p:extLst>
       <p:ext uri="{BB962C8B-B14F-4D97-AF65-F5344CB8AC3E}">
-        <p14:creationId xmlns:p14="http://schemas.microsoft.com/office/powerpoint/2010/main" val="3279947146"/>
+        <p14:creationId xmlns:p14="http://schemas.microsoft.com/office/powerpoint/2010/main" val="1919028098"/>
       </p:ext>
     </p:extLst>
   </p:cSld>
@@ -4484,7 +4484,7 @@
           <p:cNvPr id="2" name="Title 1">
             <a:extLst>
               <a:ext uri="{FF2B5EF4-FFF2-40B4-BE49-F238E27FC236}">
-                <a16:creationId xmlns:a16="http://schemas.microsoft.com/office/drawing/2014/main" id="{14B78311-1A50-9722-E173-8ED83B249C71}"/>
+                <a16:creationId xmlns:a16="http://schemas.microsoft.com/office/drawing/2014/main" id="{C9378364-D344-B49C-0C2E-FF186C6D6E65}"/>
               </a:ext>
             </a:extLst>
           </p:cNvPr>
@@ -4513,7 +4513,7 @@
           <p:cNvPr id="3" name="Content Placeholder 2">
             <a:extLst>
               <a:ext uri="{FF2B5EF4-FFF2-40B4-BE49-F238E27FC236}">
-                <a16:creationId xmlns:a16="http://schemas.microsoft.com/office/drawing/2014/main" id="{99E3C7C0-423E-784C-0F65-6B48EA796144}"/>
+                <a16:creationId xmlns:a16="http://schemas.microsoft.com/office/drawing/2014/main" id="{514587C8-F460-D1B7-9AA7-8BF77D266DFC}"/>
               </a:ext>
             </a:extLst>
           </p:cNvPr>
@@ -4576,7 +4576,7 @@
           <p:cNvPr id="4" name="Content Placeholder 3">
             <a:extLst>
               <a:ext uri="{FF2B5EF4-FFF2-40B4-BE49-F238E27FC236}">
-                <a16:creationId xmlns:a16="http://schemas.microsoft.com/office/drawing/2014/main" id="{5572068E-25BA-4CB9-506F-EF57527799E8}"/>
+                <a16:creationId xmlns:a16="http://schemas.microsoft.com/office/drawing/2014/main" id="{6A8FD9D4-80D3-FE86-7D16-2B9DD85168BF}"/>
               </a:ext>
             </a:extLst>
           </p:cNvPr>
@@ -4639,7 +4639,7 @@
           <p:cNvPr id="5" name="Date Placeholder 4">
             <a:extLst>
               <a:ext uri="{FF2B5EF4-FFF2-40B4-BE49-F238E27FC236}">
-                <a16:creationId xmlns:a16="http://schemas.microsoft.com/office/drawing/2014/main" id="{AC5AB47B-D862-546F-8314-F9FC928DD657}"/>
+                <a16:creationId xmlns:a16="http://schemas.microsoft.com/office/drawing/2014/main" id="{8DAF629B-8269-50F7-51C5-7449870B1578}"/>
               </a:ext>
             </a:extLst>
           </p:cNvPr>
@@ -4655,7 +4655,7 @@
           <a:bodyPr/>
           <a:lstStyle/>
           <a:p>
-            <a:fld id="{68AB6C0A-96D3-480E-84E1-5AAAF379C7DC}" type="datetimeFigureOut">
+            <a:fld id="{8153C6BC-5116-40AF-9DCC-0B33639BC89C}" type="datetimeFigureOut">
               <a:rPr lang="en-ZA" smtClean="0"/>
               <a:t>2026/10/27</a:t>
             </a:fld>
@@ -4668,7 +4668,7 @@
           <p:cNvPr id="6" name="Footer Placeholder 5">
             <a:extLst>
               <a:ext uri="{FF2B5EF4-FFF2-40B4-BE49-F238E27FC236}">
-                <a16:creationId xmlns:a16="http://schemas.microsoft.com/office/drawing/2014/main" id="{C2A729C2-421E-AF18-ED15-1CA573D3116A}"/>
+                <a16:creationId xmlns:a16="http://schemas.microsoft.com/office/drawing/2014/main" id="{5D2B8F33-EE5A-F56F-E643-D474F6E9FCF6}"/>
               </a:ext>
             </a:extLst>
           </p:cNvPr>
@@ -4693,7 +4693,7 @@
           <p:cNvPr id="7" name="Slide Number Placeholder 6">
             <a:extLst>
               <a:ext uri="{FF2B5EF4-FFF2-40B4-BE49-F238E27FC236}">
-                <a16:creationId xmlns:a16="http://schemas.microsoft.com/office/drawing/2014/main" id="{D4FCE812-EAC9-A708-51DE-1915BD497E76}"/>
+                <a16:creationId xmlns:a16="http://schemas.microsoft.com/office/drawing/2014/main" id="{76179AE4-4CF7-C1B0-5809-BB2EC4199D83}"/>
               </a:ext>
             </a:extLst>
           </p:cNvPr>
@@ -4709,7 +4709,7 @@
           <a:bodyPr/>
           <a:lstStyle/>
           <a:p>
-            <a:fld id="{1D551152-66F7-4AC9-B92F-B6D6C08E8FCF}" type="slidenum">
+            <a:fld id="{DE9666F0-EC1E-4F49-9C01-524E517EA2EF}" type="slidenum">
               <a:rPr lang="en-ZA" smtClean="0"/>
               <a:t>‹#›</a:t>
             </a:fld>
@@ -4720,7 +4720,7 @@
     </p:spTree>
     <p:extLst>
       <p:ext uri="{BB962C8B-B14F-4D97-AF65-F5344CB8AC3E}">
-        <p14:creationId xmlns:p14="http://schemas.microsoft.com/office/powerpoint/2010/main" val="2865919120"/>
+        <p14:creationId xmlns:p14="http://schemas.microsoft.com/office/powerpoint/2010/main" val="3044393780"/>
       </p:ext>
     </p:extLst>
   </p:cSld>
@@ -4752,7 +4752,7 @@
           <p:cNvPr id="2" name="Title 1">
             <a:extLst>
               <a:ext uri="{FF2B5EF4-FFF2-40B4-BE49-F238E27FC236}">
-                <a16:creationId xmlns:a16="http://schemas.microsoft.com/office/drawing/2014/main" id="{AB381AB7-3555-7638-7DCE-88F7DB9BD9B1}"/>
+                <a16:creationId xmlns:a16="http://schemas.microsoft.com/office/drawing/2014/main" id="{BFE33A2A-A95F-2D5F-2BF1-D44C64C3479E}"/>
               </a:ext>
             </a:extLst>
           </p:cNvPr>
@@ -4786,7 +4786,7 @@
           <p:cNvPr id="3" name="Text Placeholder 2">
             <a:extLst>
               <a:ext uri="{FF2B5EF4-FFF2-40B4-BE49-F238E27FC236}">
-                <a16:creationId xmlns:a16="http://schemas.microsoft.com/office/drawing/2014/main" id="{62889A6B-A7F2-C793-4216-5C80998D8F90}"/>
+                <a16:creationId xmlns:a16="http://schemas.microsoft.com/office/drawing/2014/main" id="{62E04963-C817-BC93-C8DC-F83C5B423CE3}"/>
               </a:ext>
             </a:extLst>
           </p:cNvPr>
@@ -4857,7 +4857,7 @@
           <p:cNvPr id="4" name="Content Placeholder 3">
             <a:extLst>
               <a:ext uri="{FF2B5EF4-FFF2-40B4-BE49-F238E27FC236}">
-                <a16:creationId xmlns:a16="http://schemas.microsoft.com/office/drawing/2014/main" id="{66395E01-00F3-B666-ACCC-601E69D7710D}"/>
+                <a16:creationId xmlns:a16="http://schemas.microsoft.com/office/drawing/2014/main" id="{792E0138-9B82-60AE-5EAF-625DACB1298A}"/>
               </a:ext>
             </a:extLst>
           </p:cNvPr>
@@ -4920,7 +4920,7 @@
           <p:cNvPr id="5" name="Text Placeholder 4">
             <a:extLst>
               <a:ext uri="{FF2B5EF4-FFF2-40B4-BE49-F238E27FC236}">
-                <a16:creationId xmlns:a16="http://schemas.microsoft.com/office/drawing/2014/main" id="{0ABD584D-0983-E007-7E2C-BD51FE9C7A9A}"/>
+                <a16:creationId xmlns:a16="http://schemas.microsoft.com/office/drawing/2014/main" id="{DA402FE6-C126-35E5-247E-69C44BA2E34D}"/>
               </a:ext>
             </a:extLst>
           </p:cNvPr>
@@ -4991,7 +4991,7 @@
           <p:cNvPr id="6" name="Content Placeholder 5">
             <a:extLst>
               <a:ext uri="{FF2B5EF4-FFF2-40B4-BE49-F238E27FC236}">
-                <a16:creationId xmlns:a16="http://schemas.microsoft.com/office/drawing/2014/main" id="{163A633E-AB3B-3095-DB46-D10C9EFF91CF}"/>
+                <a16:creationId xmlns:a16="http://schemas.microsoft.com/office/drawing/2014/main" id="{9B807392-D64C-C30E-3CB8-130FBC96DB41}"/>
               </a:ext>
             </a:extLst>
           </p:cNvPr>
@@ -5054,7 +5054,7 @@
           <p:cNvPr id="7" name="Date Placeholder 6">
             <a:extLst>
               <a:ext uri="{FF2B5EF4-FFF2-40B4-BE49-F238E27FC236}">
-                <a16:creationId xmlns:a16="http://schemas.microsoft.com/office/drawing/2014/main" id="{297F173B-CDCF-1DA7-A8E8-92A71860F27C}"/>
+                <a16:creationId xmlns:a16="http://schemas.microsoft.com/office/drawing/2014/main" id="{84B3EDB7-7FFA-6399-72AD-B596D0478773}"/>
               </a:ext>
             </a:extLst>
           </p:cNvPr>
@@ -5070,7 +5070,7 @@
           <a:bodyPr/>
           <a:lstStyle/>
           <a:p>
-            <a:fld id="{68AB6C0A-96D3-480E-84E1-5AAAF379C7DC}" type="datetimeFigureOut">
+            <a:fld id="{8153C6BC-5116-40AF-9DCC-0B33639BC89C}" type="datetimeFigureOut">
               <a:rPr lang="en-ZA" smtClean="0"/>
               <a:t>2026/10/27</a:t>
             </a:fld>
@@ -5083,7 +5083,7 @@
           <p:cNvPr id="8" name="Footer Placeholder 7">
             <a:extLst>
               <a:ext uri="{FF2B5EF4-FFF2-40B4-BE49-F238E27FC236}">
-                <a16:creationId xmlns:a16="http://schemas.microsoft.com/office/drawing/2014/main" id="{C4B5F6EE-CF19-D567-B901-563705CCC2AF}"/>
+                <a16:creationId xmlns:a16="http://schemas.microsoft.com/office/drawing/2014/main" id="{1F20EE8F-985D-49B5-B712-0109537CCE2C}"/>
               </a:ext>
             </a:extLst>
           </p:cNvPr>
@@ -5108,7 +5108,7 @@
           <p:cNvPr id="9" name="Slide Number Placeholder 8">
             <a:extLst>
               <a:ext uri="{FF2B5EF4-FFF2-40B4-BE49-F238E27FC236}">
-                <a16:creationId xmlns:a16="http://schemas.microsoft.com/office/drawing/2014/main" id="{7760181F-038E-7DE2-C5CC-2104888B1DBC}"/>
+                <a16:creationId xmlns:a16="http://schemas.microsoft.com/office/drawing/2014/main" id="{BF1945E8-CB3F-42A6-A916-6D0ED4BECE3E}"/>
               </a:ext>
             </a:extLst>
           </p:cNvPr>
@@ -5124,7 +5124,7 @@
           <a:bodyPr/>
           <a:lstStyle/>
           <a:p>
-            <a:fld id="{1D551152-66F7-4AC9-B92F-B6D6C08E8FCF}" type="slidenum">
+            <a:fld id="{DE9666F0-EC1E-4F49-9C01-524E517EA2EF}" type="slidenum">
               <a:rPr lang="en-ZA" smtClean="0"/>
               <a:t>‹#›</a:t>
             </a:fld>
@@ -5135,7 +5135,7 @@
     </p:spTree>
     <p:extLst>
       <p:ext uri="{BB962C8B-B14F-4D97-AF65-F5344CB8AC3E}">
-        <p14:creationId xmlns:p14="http://schemas.microsoft.com/office/powerpoint/2010/main" val="2917367000"/>
+        <p14:creationId xmlns:p14="http://schemas.microsoft.com/office/powerpoint/2010/main" val="3728396074"/>
       </p:ext>
     </p:extLst>
   </p:cSld>
@@ -5167,7 +5167,7 @@
           <p:cNvPr id="2" name="Title 1">
             <a:extLst>
               <a:ext uri="{FF2B5EF4-FFF2-40B4-BE49-F238E27FC236}">
-                <a16:creationId xmlns:a16="http://schemas.microsoft.com/office/drawing/2014/main" id="{A9672D4D-92B6-C929-75AE-2675810B6B96}"/>
+                <a16:creationId xmlns:a16="http://schemas.microsoft.com/office/drawing/2014/main" id="{05A164CB-54C0-E4B5-6B3C-8D7DFB09BF59}"/>
               </a:ext>
             </a:extLst>
           </p:cNvPr>
@@ -5196,7 +5196,7 @@
           <p:cNvPr id="3" name="Date Placeholder 2">
             <a:extLst>
               <a:ext uri="{FF2B5EF4-FFF2-40B4-BE49-F238E27FC236}">
-                <a16:creationId xmlns:a16="http://schemas.microsoft.com/office/drawing/2014/main" id="{144B200C-0621-CE0B-46E4-8086112AACD2}"/>
+                <a16:creationId xmlns:a16="http://schemas.microsoft.com/office/drawing/2014/main" id="{9B243DBC-B35F-3045-D24E-3EE89EE324CF}"/>
               </a:ext>
             </a:extLst>
           </p:cNvPr>
@@ -5212,7 +5212,7 @@
           <a:bodyPr/>
           <a:lstStyle/>
           <a:p>
-            <a:fld id="{68AB6C0A-96D3-480E-84E1-5AAAF379C7DC}" type="datetimeFigureOut">
+            <a:fld id="{8153C6BC-5116-40AF-9DCC-0B33639BC89C}" type="datetimeFigureOut">
               <a:rPr lang="en-ZA" smtClean="0"/>
               <a:t>2026/10/27</a:t>
             </a:fld>
@@ -5225,7 +5225,7 @@
           <p:cNvPr id="4" name="Footer Placeholder 3">
             <a:extLst>
               <a:ext uri="{FF2B5EF4-FFF2-40B4-BE49-F238E27FC236}">
-                <a16:creationId xmlns:a16="http://schemas.microsoft.com/office/drawing/2014/main" id="{3AC47599-C5EA-7528-ACF4-BFC7E5832784}"/>
+                <a16:creationId xmlns:a16="http://schemas.microsoft.com/office/drawing/2014/main" id="{1EF36436-8BC2-6556-29C3-6990A2191357}"/>
               </a:ext>
             </a:extLst>
           </p:cNvPr>
@@ -5250,7 +5250,7 @@
           <p:cNvPr id="5" name="Slide Number Placeholder 4">
             <a:extLst>
               <a:ext uri="{FF2B5EF4-FFF2-40B4-BE49-F238E27FC236}">
-                <a16:creationId xmlns:a16="http://schemas.microsoft.com/office/drawing/2014/main" id="{E2080010-A243-7E34-0C7D-33CB62083B74}"/>
+                <a16:creationId xmlns:a16="http://schemas.microsoft.com/office/drawing/2014/main" id="{77126A48-D223-A368-B2C2-B55DE72C5B02}"/>
               </a:ext>
             </a:extLst>
           </p:cNvPr>
@@ -5266,7 +5266,7 @@
           <a:bodyPr/>
           <a:lstStyle/>
           <a:p>
-            <a:fld id="{1D551152-66F7-4AC9-B92F-B6D6C08E8FCF}" type="slidenum">
+            <a:fld id="{DE9666F0-EC1E-4F49-9C01-524E517EA2EF}" type="slidenum">
               <a:rPr lang="en-ZA" smtClean="0"/>
               <a:t>‹#›</a:t>
             </a:fld>
@@ -5277,7 +5277,7 @@
     </p:spTree>
     <p:extLst>
       <p:ext uri="{BB962C8B-B14F-4D97-AF65-F5344CB8AC3E}">
-        <p14:creationId xmlns:p14="http://schemas.microsoft.com/office/powerpoint/2010/main" val="3233671003"/>
+        <p14:creationId xmlns:p14="http://schemas.microsoft.com/office/powerpoint/2010/main" val="3742461651"/>
       </p:ext>
     </p:extLst>
   </p:cSld>
@@ -5309,7 +5309,7 @@
           <p:cNvPr id="2" name="Date Placeholder 1">
             <a:extLst>
               <a:ext uri="{FF2B5EF4-FFF2-40B4-BE49-F238E27FC236}">
-                <a16:creationId xmlns:a16="http://schemas.microsoft.com/office/drawing/2014/main" id="{4E644F86-29F5-2449-1FEE-0566E3904503}"/>
+                <a16:creationId xmlns:a16="http://schemas.microsoft.com/office/drawing/2014/main" id="{1418CAFE-3D5E-8461-4668-9E10AB45DCF9}"/>
               </a:ext>
             </a:extLst>
           </p:cNvPr>
@@ -5325,7 +5325,7 @@
           <a:bodyPr/>
           <a:lstStyle/>
           <a:p>
-            <a:fld id="{68AB6C0A-96D3-480E-84E1-5AAAF379C7DC}" type="datetimeFigureOut">
+            <a:fld id="{8153C6BC-5116-40AF-9DCC-0B33639BC89C}" type="datetimeFigureOut">
               <a:rPr lang="en-ZA" smtClean="0"/>
               <a:t>2026/10/27</a:t>
             </a:fld>
@@ -5338,7 +5338,7 @@
           <p:cNvPr id="3" name="Footer Placeholder 2">
             <a:extLst>
               <a:ext uri="{FF2B5EF4-FFF2-40B4-BE49-F238E27FC236}">
-                <a16:creationId xmlns:a16="http://schemas.microsoft.com/office/drawing/2014/main" id="{BA054175-B3AC-AC76-44FE-3DBC04174134}"/>
+                <a16:creationId xmlns:a16="http://schemas.microsoft.com/office/drawing/2014/main" id="{1D3D4F5F-B0DD-668A-C121-A31114C84A67}"/>
               </a:ext>
             </a:extLst>
           </p:cNvPr>
@@ -5363,7 +5363,7 @@
           <p:cNvPr id="4" name="Slide Number Placeholder 3">
             <a:extLst>
               <a:ext uri="{FF2B5EF4-FFF2-40B4-BE49-F238E27FC236}">
-                <a16:creationId xmlns:a16="http://schemas.microsoft.com/office/drawing/2014/main" id="{BF0A67E2-F0CC-5FC7-0243-ED9977E7362C}"/>
+                <a16:creationId xmlns:a16="http://schemas.microsoft.com/office/drawing/2014/main" id="{33332F12-5DB8-800E-EFC2-5159F0B0E71D}"/>
               </a:ext>
             </a:extLst>
           </p:cNvPr>
@@ -5379,7 +5379,7 @@
           <a:bodyPr/>
           <a:lstStyle/>
           <a:p>
-            <a:fld id="{1D551152-66F7-4AC9-B92F-B6D6C08E8FCF}" type="slidenum">
+            <a:fld id="{DE9666F0-EC1E-4F49-9C01-524E517EA2EF}" type="slidenum">
               <a:rPr lang="en-ZA" smtClean="0"/>
               <a:t>‹#›</a:t>
             </a:fld>
@@ -5390,7 +5390,7 @@
     </p:spTree>
     <p:extLst>
       <p:ext uri="{BB962C8B-B14F-4D97-AF65-F5344CB8AC3E}">
-        <p14:creationId xmlns:p14="http://schemas.microsoft.com/office/powerpoint/2010/main" val="869938615"/>
+        <p14:creationId xmlns:p14="http://schemas.microsoft.com/office/powerpoint/2010/main" val="129472530"/>
       </p:ext>
     </p:extLst>
   </p:cSld>
@@ -5422,7 +5422,7 @@
           <p:cNvPr id="2" name="Title 1">
             <a:extLst>
               <a:ext uri="{FF2B5EF4-FFF2-40B4-BE49-F238E27FC236}">
-                <a16:creationId xmlns:a16="http://schemas.microsoft.com/office/drawing/2014/main" id="{BCF101B2-CD39-D71D-243F-33EE4CD40611}"/>
+                <a16:creationId xmlns:a16="http://schemas.microsoft.com/office/drawing/2014/main" id="{092A7151-2BFD-F48F-93DD-6AE39E75A5D7}"/>
               </a:ext>
             </a:extLst>
           </p:cNvPr>
@@ -5460,7 +5460,7 @@
           <p:cNvPr id="3" name="Content Placeholder 2">
             <a:extLst>
               <a:ext uri="{FF2B5EF4-FFF2-40B4-BE49-F238E27FC236}">
-                <a16:creationId xmlns:a16="http://schemas.microsoft.com/office/drawing/2014/main" id="{88DB60B7-C466-D025-5FFE-4AF8F0CB4B83}"/>
+                <a16:creationId xmlns:a16="http://schemas.microsoft.com/office/drawing/2014/main" id="{FFF30D9D-E032-9AB9-9CBE-6998B603502F}"/>
               </a:ext>
             </a:extLst>
           </p:cNvPr>
@@ -5551,7 +5551,7 @@
           <p:cNvPr id="4" name="Text Placeholder 3">
             <a:extLst>
               <a:ext uri="{FF2B5EF4-FFF2-40B4-BE49-F238E27FC236}">
-                <a16:creationId xmlns:a16="http://schemas.microsoft.com/office/drawing/2014/main" id="{E58A5449-4B0D-355B-3C6B-6A0D16535B3E}"/>
+                <a16:creationId xmlns:a16="http://schemas.microsoft.com/office/drawing/2014/main" id="{260D2348-6C27-7B44-6226-7C8CCB189A37}"/>
               </a:ext>
             </a:extLst>
           </p:cNvPr>
@@ -5622,7 +5622,7 @@
           <p:cNvPr id="5" name="Date Placeholder 4">
             <a:extLst>
               <a:ext uri="{FF2B5EF4-FFF2-40B4-BE49-F238E27FC236}">
-                <a16:creationId xmlns:a16="http://schemas.microsoft.com/office/drawing/2014/main" id="{A8441685-7EDA-BD90-756D-A59CE3A0C9FD}"/>
+                <a16:creationId xmlns:a16="http://schemas.microsoft.com/office/drawing/2014/main" id="{E217C81F-9D5D-7628-7F58-8BC866F1F882}"/>
               </a:ext>
             </a:extLst>
           </p:cNvPr>
@@ -5638,7 +5638,7 @@
           <a:bodyPr/>
           <a:lstStyle/>
           <a:p>
-            <a:fld id="{68AB6C0A-96D3-480E-84E1-5AAAF379C7DC}" type="datetimeFigureOut">
+            <a:fld id="{8153C6BC-5116-40AF-9DCC-0B33639BC89C}" type="datetimeFigureOut">
               <a:rPr lang="en-ZA" smtClean="0"/>
               <a:t>2026/10/27</a:t>
             </a:fld>
@@ -5651,7 +5651,7 @@
           <p:cNvPr id="6" name="Footer Placeholder 5">
             <a:extLst>
               <a:ext uri="{FF2B5EF4-FFF2-40B4-BE49-F238E27FC236}">
-                <a16:creationId xmlns:a16="http://schemas.microsoft.com/office/drawing/2014/main" id="{E103EC61-E12C-3B69-908E-C50700A90B4E}"/>
+                <a16:creationId xmlns:a16="http://schemas.microsoft.com/office/drawing/2014/main" id="{C4D65681-6C28-5768-8052-9E485E01D642}"/>
               </a:ext>
             </a:extLst>
           </p:cNvPr>
@@ -5676,7 +5676,7 @@
           <p:cNvPr id="7" name="Slide Number Placeholder 6">
             <a:extLst>
               <a:ext uri="{FF2B5EF4-FFF2-40B4-BE49-F238E27FC236}">
-                <a16:creationId xmlns:a16="http://schemas.microsoft.com/office/drawing/2014/main" id="{5ABB757C-012F-3D1B-D82A-5565A7E6D3E1}"/>
+                <a16:creationId xmlns:a16="http://schemas.microsoft.com/office/drawing/2014/main" id="{CBE70345-BAFB-8340-557C-2A9E8C522963}"/>
               </a:ext>
             </a:extLst>
           </p:cNvPr>
@@ -5692,7 +5692,7 @@
           <a:bodyPr/>
           <a:lstStyle/>
           <a:p>
-            <a:fld id="{1D551152-66F7-4AC9-B92F-B6D6C08E8FCF}" type="slidenum">
+            <a:fld id="{DE9666F0-EC1E-4F49-9C01-524E517EA2EF}" type="slidenum">
               <a:rPr lang="en-ZA" smtClean="0"/>
               <a:t>‹#›</a:t>
             </a:fld>
@@ -5703,7 +5703,7 @@
     </p:spTree>
     <p:extLst>
       <p:ext uri="{BB962C8B-B14F-4D97-AF65-F5344CB8AC3E}">
-        <p14:creationId xmlns:p14="http://schemas.microsoft.com/office/powerpoint/2010/main" val="3315283771"/>
+        <p14:creationId xmlns:p14="http://schemas.microsoft.com/office/powerpoint/2010/main" val="1086486403"/>
       </p:ext>
     </p:extLst>
   </p:cSld>
@@ -5735,7 +5735,7 @@
           <p:cNvPr id="2" name="Title 1">
             <a:extLst>
               <a:ext uri="{FF2B5EF4-FFF2-40B4-BE49-F238E27FC236}">
-                <a16:creationId xmlns:a16="http://schemas.microsoft.com/office/drawing/2014/main" id="{DE32F532-368F-9D36-D8B5-C3FDEF90D75E}"/>
+                <a16:creationId xmlns:a16="http://schemas.microsoft.com/office/drawing/2014/main" id="{9DF082D0-28FD-92AB-9583-4CD00F62CBE1}"/>
               </a:ext>
             </a:extLst>
           </p:cNvPr>
@@ -5773,7 +5773,7 @@
           <p:cNvPr id="3" name="Picture Placeholder 2">
             <a:extLst>
               <a:ext uri="{FF2B5EF4-FFF2-40B4-BE49-F238E27FC236}">
-                <a16:creationId xmlns:a16="http://schemas.microsoft.com/office/drawing/2014/main" id="{289EC226-DEC8-5118-20D2-EF63975C71B2}"/>
+                <a16:creationId xmlns:a16="http://schemas.microsoft.com/office/drawing/2014/main" id="{E02A03D3-E7A0-8B46-BD2D-B6ADB6A63100}"/>
               </a:ext>
             </a:extLst>
           </p:cNvPr>
@@ -5840,7 +5840,7 @@
           <p:cNvPr id="4" name="Text Placeholder 3">
             <a:extLst>
               <a:ext uri="{FF2B5EF4-FFF2-40B4-BE49-F238E27FC236}">
-                <a16:creationId xmlns:a16="http://schemas.microsoft.com/office/drawing/2014/main" id="{C2D393DC-EE9B-3F21-9494-258D8C17905A}"/>
+                <a16:creationId xmlns:a16="http://schemas.microsoft.com/office/drawing/2014/main" id="{F20D4322-576C-C110-4217-0528B93471D5}"/>
               </a:ext>
             </a:extLst>
           </p:cNvPr>
@@ -5911,7 +5911,7 @@
           <p:cNvPr id="5" name="Date Placeholder 4">
             <a:extLst>
               <a:ext uri="{FF2B5EF4-FFF2-40B4-BE49-F238E27FC236}">
-                <a16:creationId xmlns:a16="http://schemas.microsoft.com/office/drawing/2014/main" id="{178745D8-9A22-F7A3-0CF0-4668273C99EB}"/>
+                <a16:creationId xmlns:a16="http://schemas.microsoft.com/office/drawing/2014/main" id="{A46BF2E1-B6F7-9AAF-A40D-84ADDD18C1AB}"/>
               </a:ext>
             </a:extLst>
           </p:cNvPr>
@@ -5927,7 +5927,7 @@
           <a:bodyPr/>
           <a:lstStyle/>
           <a:p>
-            <a:fld id="{68AB6C0A-96D3-480E-84E1-5AAAF379C7DC}" type="datetimeFigureOut">
+            <a:fld id="{8153C6BC-5116-40AF-9DCC-0B33639BC89C}" type="datetimeFigureOut">
               <a:rPr lang="en-ZA" smtClean="0"/>
               <a:t>2026/10/27</a:t>
             </a:fld>
@@ -5940,7 +5940,7 @@
           <p:cNvPr id="6" name="Footer Placeholder 5">
             <a:extLst>
               <a:ext uri="{FF2B5EF4-FFF2-40B4-BE49-F238E27FC236}">
-                <a16:creationId xmlns:a16="http://schemas.microsoft.com/office/drawing/2014/main" id="{BF6BEB9D-83EE-6ADB-BA3C-D9F8754ECFAF}"/>
+                <a16:creationId xmlns:a16="http://schemas.microsoft.com/office/drawing/2014/main" id="{041E9590-0771-883C-66F8-0A9F0006D073}"/>
               </a:ext>
             </a:extLst>
           </p:cNvPr>
@@ -5965,7 +5965,7 @@
           <p:cNvPr id="7" name="Slide Number Placeholder 6">
             <a:extLst>
               <a:ext uri="{FF2B5EF4-FFF2-40B4-BE49-F238E27FC236}">
-                <a16:creationId xmlns:a16="http://schemas.microsoft.com/office/drawing/2014/main" id="{789F7AFF-AC23-27C8-9B12-79E83142B659}"/>
+                <a16:creationId xmlns:a16="http://schemas.microsoft.com/office/drawing/2014/main" id="{ABF8FB99-DA71-B926-3694-332872CC8F3F}"/>
               </a:ext>
             </a:extLst>
           </p:cNvPr>
@@ -5981,7 +5981,7 @@
           <a:bodyPr/>
           <a:lstStyle/>
           <a:p>
-            <a:fld id="{1D551152-66F7-4AC9-B92F-B6D6C08E8FCF}" type="slidenum">
+            <a:fld id="{DE9666F0-EC1E-4F49-9C01-524E517EA2EF}" type="slidenum">
               <a:rPr lang="en-ZA" smtClean="0"/>
               <a:t>‹#›</a:t>
             </a:fld>
@@ -5992,7 +5992,7 @@
     </p:spTree>
     <p:extLst>
       <p:ext uri="{BB962C8B-B14F-4D97-AF65-F5344CB8AC3E}">
-        <p14:creationId xmlns:p14="http://schemas.microsoft.com/office/powerpoint/2010/main" val="964561940"/>
+        <p14:creationId xmlns:p14="http://schemas.microsoft.com/office/powerpoint/2010/main" val="1100614333"/>
       </p:ext>
     </p:extLst>
   </p:cSld>
@@ -6029,7 +6029,7 @@
           <p:cNvPr id="2" name="Title Placeholder 1">
             <a:extLst>
               <a:ext uri="{FF2B5EF4-FFF2-40B4-BE49-F238E27FC236}">
-                <a16:creationId xmlns:a16="http://schemas.microsoft.com/office/drawing/2014/main" id="{8686657C-1F88-7C92-E4E9-B586C268C508}"/>
+                <a16:creationId xmlns:a16="http://schemas.microsoft.com/office/drawing/2014/main" id="{816CBF7F-87FF-4BD5-0967-007FD2AB6CB7}"/>
               </a:ext>
             </a:extLst>
           </p:cNvPr>
@@ -6068,7 +6068,7 @@
           <p:cNvPr id="3" name="Text Placeholder 2">
             <a:extLst>
               <a:ext uri="{FF2B5EF4-FFF2-40B4-BE49-F238E27FC236}">
-                <a16:creationId xmlns:a16="http://schemas.microsoft.com/office/drawing/2014/main" id="{0744D047-4DF8-8B66-79C3-174A435EAA9F}"/>
+                <a16:creationId xmlns:a16="http://schemas.microsoft.com/office/drawing/2014/main" id="{FE0AFCB9-686C-BDDD-F3B1-F1D5881A54F8}"/>
               </a:ext>
             </a:extLst>
           </p:cNvPr>
@@ -6136,7 +6136,7 @@
           <p:cNvPr id="4" name="Date Placeholder 3">
             <a:extLst>
               <a:ext uri="{FF2B5EF4-FFF2-40B4-BE49-F238E27FC236}">
-                <a16:creationId xmlns:a16="http://schemas.microsoft.com/office/drawing/2014/main" id="{0E341E92-113C-2AAF-4602-25D999B54FD4}"/>
+                <a16:creationId xmlns:a16="http://schemas.microsoft.com/office/drawing/2014/main" id="{9742DC26-7219-5D09-C3EB-B86F63C36E9A}"/>
               </a:ext>
             </a:extLst>
           </p:cNvPr>
@@ -6170,7 +6170,7 @@
             </a:lvl1pPr>
           </a:lstStyle>
           <a:p>
-            <a:fld id="{68AB6C0A-96D3-480E-84E1-5AAAF379C7DC}" type="datetimeFigureOut">
+            <a:fld id="{8153C6BC-5116-40AF-9DCC-0B33639BC89C}" type="datetimeFigureOut">
               <a:rPr lang="en-ZA" smtClean="0"/>
               <a:t>2026/10/27</a:t>
             </a:fld>
@@ -6183,7 +6183,7 @@
           <p:cNvPr id="5" name="Footer Placeholder 4">
             <a:extLst>
               <a:ext uri="{FF2B5EF4-FFF2-40B4-BE49-F238E27FC236}">
-                <a16:creationId xmlns:a16="http://schemas.microsoft.com/office/drawing/2014/main" id="{3DAAC350-AD07-3355-8458-0E32433D3448}"/>
+                <a16:creationId xmlns:a16="http://schemas.microsoft.com/office/drawing/2014/main" id="{E6CFA0DE-6413-A230-29D4-8E06839E8DF5}"/>
               </a:ext>
             </a:extLst>
           </p:cNvPr>
@@ -6226,7 +6226,7 @@
           <p:cNvPr id="6" name="Slide Number Placeholder 5">
             <a:extLst>
               <a:ext uri="{FF2B5EF4-FFF2-40B4-BE49-F238E27FC236}">
-                <a16:creationId xmlns:a16="http://schemas.microsoft.com/office/drawing/2014/main" id="{33C88B15-7A21-1289-F477-4BCFB59C341F}"/>
+                <a16:creationId xmlns:a16="http://schemas.microsoft.com/office/drawing/2014/main" id="{885AC2DE-FBF8-9F9E-0077-75E6448EBB6E}"/>
               </a:ext>
             </a:extLst>
           </p:cNvPr>
@@ -6260,7 +6260,7 @@
             </a:lvl1pPr>
           </a:lstStyle>
           <a:p>
-            <a:fld id="{1D551152-66F7-4AC9-B92F-B6D6C08E8FCF}" type="slidenum">
+            <a:fld id="{DE9666F0-EC1E-4F49-9C01-524E517EA2EF}" type="slidenum">
               <a:rPr lang="en-ZA" smtClean="0"/>
               <a:t>‹#›</a:t>
             </a:fld>
@@ -6271,7 +6271,7 @@
     </p:spTree>
     <p:extLst>
       <p:ext uri="{BB962C8B-B14F-4D97-AF65-F5344CB8AC3E}">
-        <p14:creationId xmlns:p14="http://schemas.microsoft.com/office/powerpoint/2010/main" val="2084254505"/>
+        <p14:creationId xmlns:p14="http://schemas.microsoft.com/office/powerpoint/2010/main" val="1997298068"/>
       </p:ext>
     </p:extLst>
   </p:cSld>
@@ -6602,7 +6602,7 @@
           <p:cNvPr id="2" name="TextBox 1">
             <a:extLst>
               <a:ext uri="{FF2B5EF4-FFF2-40B4-BE49-F238E27FC236}">
-                <a16:creationId xmlns:a16="http://schemas.microsoft.com/office/drawing/2014/main" id="{A2564F0C-ACD8-CC93-38E4-F6967708B988}"/>
+                <a16:creationId xmlns:a16="http://schemas.microsoft.com/office/drawing/2014/main" id="{17710157-98E8-49ED-B3EA-300D32D294F1}"/>
               </a:ext>
             </a:extLst>
           </p:cNvPr>
@@ -6654,7 +6654,7 @@
           <p:cNvPr id="3" name="TextBox 2">
             <a:extLst>
               <a:ext uri="{FF2B5EF4-FFF2-40B4-BE49-F238E27FC236}">
-                <a16:creationId xmlns:a16="http://schemas.microsoft.com/office/drawing/2014/main" id="{7F5F3259-8504-050D-EF54-F36AEF18EC53}"/>
+                <a16:creationId xmlns:a16="http://schemas.microsoft.com/office/drawing/2014/main" id="{A1120796-5CD5-C6A9-5145-B845066EC266}"/>
               </a:ext>
             </a:extLst>
           </p:cNvPr>
@@ -6699,7 +6699,7 @@
           <p:cNvPr id="4" name="TextBox 3">
             <a:extLst>
               <a:ext uri="{FF2B5EF4-FFF2-40B4-BE49-F238E27FC236}">
-                <a16:creationId xmlns:a16="http://schemas.microsoft.com/office/drawing/2014/main" id="{5F112454-9DAF-5E95-7388-662FAFF1BAA7}"/>
+                <a16:creationId xmlns:a16="http://schemas.microsoft.com/office/drawing/2014/main" id="{5FB4B5B1-950A-10AE-5766-F685A5D54191}"/>
               </a:ext>
             </a:extLst>
           </p:cNvPr>
@@ -6750,7 +6750,7 @@
           <p:cNvPr id="5" name="TextBox 4">
             <a:extLst>
               <a:ext uri="{FF2B5EF4-FFF2-40B4-BE49-F238E27FC236}">
-                <a16:creationId xmlns:a16="http://schemas.microsoft.com/office/drawing/2014/main" id="{C071519C-C892-EA8D-70CA-F35E2B7989C1}"/>
+                <a16:creationId xmlns:a16="http://schemas.microsoft.com/office/drawing/2014/main" id="{C18EB692-6113-370E-A4FA-5D7D24985475}"/>
               </a:ext>
             </a:extLst>
           </p:cNvPr>
@@ -6802,7 +6802,7 @@
           <p:cNvPr id="6" name="TextBox 5">
             <a:extLst>
               <a:ext uri="{FF2B5EF4-FFF2-40B4-BE49-F238E27FC236}">
-                <a16:creationId xmlns:a16="http://schemas.microsoft.com/office/drawing/2014/main" id="{96F2C16F-2AAB-98A5-8CE6-3C9474AC2815}"/>
+                <a16:creationId xmlns:a16="http://schemas.microsoft.com/office/drawing/2014/main" id="{0537133C-3FD3-353C-0B1E-FB2859925BBC}"/>
               </a:ext>
             </a:extLst>
           </p:cNvPr>
@@ -6847,7 +6847,7 @@
           <p:cNvPr id="7" name="Group members - intentionally blank">
             <a:extLst>
               <a:ext uri="{FF2B5EF4-FFF2-40B4-BE49-F238E27FC236}">
-                <a16:creationId xmlns:a16="http://schemas.microsoft.com/office/drawing/2014/main" id="{FFE98996-A5AD-E626-A6D9-705EFF09BE49}"/>
+                <a16:creationId xmlns:a16="http://schemas.microsoft.com/office/drawing/2014/main" id="{5104D14F-BAC3-C58F-7B07-2ED1FCC03496}"/>
               </a:ext>
             </a:extLst>
           </p:cNvPr>
@@ -6887,7 +6887,7 @@
     </p:spTree>
     <p:extLst>
       <p:ext uri="{BB962C8B-B14F-4D97-AF65-F5344CB8AC3E}">
-        <p14:creationId xmlns:p14="http://schemas.microsoft.com/office/powerpoint/2010/main" val="1392393877"/>
+        <p14:creationId xmlns:p14="http://schemas.microsoft.com/office/powerpoint/2010/main" val="4028812773"/>
       </p:ext>
     </p:extLst>
   </p:cSld>
@@ -6927,7 +6927,7 @@
           <p:cNvPr id="2" name="TextBox 1">
             <a:extLst>
               <a:ext uri="{FF2B5EF4-FFF2-40B4-BE49-F238E27FC236}">
-                <a16:creationId xmlns:a16="http://schemas.microsoft.com/office/drawing/2014/main" id="{5E7B17DE-A084-E032-0395-9D32F90AECEA}"/>
+                <a16:creationId xmlns:a16="http://schemas.microsoft.com/office/drawing/2014/main" id="{DFFF1960-3CD1-8143-DC2A-268DE02E429A}"/>
               </a:ext>
             </a:extLst>
           </p:cNvPr>
@@ -6978,7 +6978,7 @@
           <p:cNvPr id="3" name="TextBox 2">
             <a:extLst>
               <a:ext uri="{FF2B5EF4-FFF2-40B4-BE49-F238E27FC236}">
-                <a16:creationId xmlns:a16="http://schemas.microsoft.com/office/drawing/2014/main" id="{300C3DB2-3282-10E9-D374-A2101C465DC0}"/>
+                <a16:creationId xmlns:a16="http://schemas.microsoft.com/office/drawing/2014/main" id="{FFDB12E8-FDA7-2719-4572-37EB015D0E6A}"/>
               </a:ext>
             </a:extLst>
           </p:cNvPr>
@@ -7023,7 +7023,7 @@
           <p:cNvPr id="4" name="TextBox 3">
             <a:extLst>
               <a:ext uri="{FF2B5EF4-FFF2-40B4-BE49-F238E27FC236}">
-                <a16:creationId xmlns:a16="http://schemas.microsoft.com/office/drawing/2014/main" id="{C4B26C05-D0EC-2AD7-AF40-7FD41BBAC1C0}"/>
+                <a16:creationId xmlns:a16="http://schemas.microsoft.com/office/drawing/2014/main" id="{3691E3D3-D15D-BCAB-C60B-250119E6B73A}"/>
               </a:ext>
             </a:extLst>
           </p:cNvPr>
@@ -7074,7 +7074,7 @@
           <p:cNvPr id="5" name="TextBox 4">
             <a:extLst>
               <a:ext uri="{FF2B5EF4-FFF2-40B4-BE49-F238E27FC236}">
-                <a16:creationId xmlns:a16="http://schemas.microsoft.com/office/drawing/2014/main" id="{07E92AAD-BEA4-5A9A-358C-CA9BB118A928}"/>
+                <a16:creationId xmlns:a16="http://schemas.microsoft.com/office/drawing/2014/main" id="{9727D655-E046-DA5E-A76E-B565943BE50F}"/>
               </a:ext>
             </a:extLst>
           </p:cNvPr>
@@ -7139,7 +7139,7 @@
     </p:spTree>
     <p:extLst>
       <p:ext uri="{BB962C8B-B14F-4D97-AF65-F5344CB8AC3E}">
-        <p14:creationId xmlns:p14="http://schemas.microsoft.com/office/powerpoint/2010/main" val="2411994209"/>
+        <p14:creationId xmlns:p14="http://schemas.microsoft.com/office/powerpoint/2010/main" val="815445924"/>
       </p:ext>
     </p:extLst>
   </p:cSld>
@@ -7179,7 +7179,7 @@
           <p:cNvPr id="2" name="TextBox 1">
             <a:extLst>
               <a:ext uri="{FF2B5EF4-FFF2-40B4-BE49-F238E27FC236}">
-                <a16:creationId xmlns:a16="http://schemas.microsoft.com/office/drawing/2014/main" id="{B2CE0984-9E0F-C13C-FCB5-9C8F9181A5CF}"/>
+                <a16:creationId xmlns:a16="http://schemas.microsoft.com/office/drawing/2014/main" id="{83222E45-512F-14EA-CC0D-2C98243BB465}"/>
               </a:ext>
             </a:extLst>
           </p:cNvPr>
@@ -7224,7 +7224,7 @@
           <p:cNvPr id="3" name="TextBox 2">
             <a:extLst>
               <a:ext uri="{FF2B5EF4-FFF2-40B4-BE49-F238E27FC236}">
-                <a16:creationId xmlns:a16="http://schemas.microsoft.com/office/drawing/2014/main" id="{542E7C0A-ABF6-C5E3-E310-6B9B7AB3FA7F}"/>
+                <a16:creationId xmlns:a16="http://schemas.microsoft.com/office/drawing/2014/main" id="{34763464-EDF6-046C-5A0F-D6D34EEB198F}"/>
               </a:ext>
             </a:extLst>
           </p:cNvPr>
@@ -7269,7 +7269,7 @@
           <p:cNvPr id="4" name="Table 3">
             <a:extLst>
               <a:ext uri="{FF2B5EF4-FFF2-40B4-BE49-F238E27FC236}">
-                <a16:creationId xmlns:a16="http://schemas.microsoft.com/office/drawing/2014/main" id="{1500F6A6-4C7C-6A63-F876-2824FF769D5C}"/>
+                <a16:creationId xmlns:a16="http://schemas.microsoft.com/office/drawing/2014/main" id="{E547E8AA-9D2B-90BE-83DD-B54E8A8AA000}"/>
               </a:ext>
             </a:extLst>
           </p:cNvPr>
@@ -7279,7 +7279,7 @@
           <p:nvPr>
             <p:extLst>
               <p:ext uri="{D42A27DB-BD31-4B8C-83A1-F6EECF244321}">
-                <p14:modId xmlns:p14="http://schemas.microsoft.com/office/powerpoint/2010/main" val="2735347984"/>
+                <p14:modId xmlns:p14="http://schemas.microsoft.com/office/powerpoint/2010/main" val="1038354969"/>
               </p:ext>
             </p:extLst>
           </p:nvPr>
@@ -7298,21 +7298,21 @@
                 <a:gridCol w="5486400">
                   <a:extLst>
                     <a:ext uri="{9D8B030D-6E8A-4147-A177-3AD203B41FA5}">
-                      <a16:colId xmlns:a16="http://schemas.microsoft.com/office/drawing/2014/main" val="3113583335"/>
+                      <a16:colId xmlns:a16="http://schemas.microsoft.com/office/drawing/2014/main" val="3987295584"/>
                     </a:ext>
                   </a:extLst>
                 </a:gridCol>
                 <a:gridCol w="2743200">
                   <a:extLst>
                     <a:ext uri="{9D8B030D-6E8A-4147-A177-3AD203B41FA5}">
-                      <a16:colId xmlns:a16="http://schemas.microsoft.com/office/drawing/2014/main" val="2187291762"/>
+                      <a16:colId xmlns:a16="http://schemas.microsoft.com/office/drawing/2014/main" val="3948894087"/>
                     </a:ext>
                   </a:extLst>
                 </a:gridCol>
                 <a:gridCol w="2743200">
                   <a:extLst>
                     <a:ext uri="{9D8B030D-6E8A-4147-A177-3AD203B41FA5}">
-                      <a16:colId xmlns:a16="http://schemas.microsoft.com/office/drawing/2014/main" val="1787845863"/>
+                      <a16:colId xmlns:a16="http://schemas.microsoft.com/office/drawing/2014/main" val="1552708560"/>
                     </a:ext>
                   </a:extLst>
                 </a:gridCol>
@@ -7386,7 +7386,7 @@
                 </a:tc>
                 <a:extLst>
                   <a:ext uri="{0D108BD9-81ED-4DB2-BD59-A6C34878D82A}">
-                    <a16:rowId xmlns:a16="http://schemas.microsoft.com/office/drawing/2014/main" val="2388410184"/>
+                    <a16:rowId xmlns:a16="http://schemas.microsoft.com/office/drawing/2014/main" val="1715058002"/>
                   </a:ext>
                 </a:extLst>
               </a:tr>
@@ -7459,7 +7459,7 @@
                 </a:tc>
                 <a:extLst>
                   <a:ext uri="{0D108BD9-81ED-4DB2-BD59-A6C34878D82A}">
-                    <a16:rowId xmlns:a16="http://schemas.microsoft.com/office/drawing/2014/main" val="3551106763"/>
+                    <a16:rowId xmlns:a16="http://schemas.microsoft.com/office/drawing/2014/main" val="1382259021"/>
                   </a:ext>
                 </a:extLst>
               </a:tr>
@@ -7532,7 +7532,7 @@
                 </a:tc>
                 <a:extLst>
                   <a:ext uri="{0D108BD9-81ED-4DB2-BD59-A6C34878D82A}">
-                    <a16:rowId xmlns:a16="http://schemas.microsoft.com/office/drawing/2014/main" val="2966069229"/>
+                    <a16:rowId xmlns:a16="http://schemas.microsoft.com/office/drawing/2014/main" val="1748331378"/>
                   </a:ext>
                 </a:extLst>
               </a:tr>
@@ -7605,7 +7605,7 @@
                 </a:tc>
                 <a:extLst>
                   <a:ext uri="{0D108BD9-81ED-4DB2-BD59-A6C34878D82A}">
-                    <a16:rowId xmlns:a16="http://schemas.microsoft.com/office/drawing/2014/main" val="2885859154"/>
+                    <a16:rowId xmlns:a16="http://schemas.microsoft.com/office/drawing/2014/main" val="3729673307"/>
                   </a:ext>
                 </a:extLst>
               </a:tr>
@@ -7678,7 +7678,7 @@
                 </a:tc>
                 <a:extLst>
                   <a:ext uri="{0D108BD9-81ED-4DB2-BD59-A6C34878D82A}">
-                    <a16:rowId xmlns:a16="http://schemas.microsoft.com/office/drawing/2014/main" val="4060262858"/>
+                    <a16:rowId xmlns:a16="http://schemas.microsoft.com/office/drawing/2014/main" val="3747237456"/>
                   </a:ext>
                 </a:extLst>
               </a:tr>
@@ -7691,7 +7691,7 @@
           <p:cNvPr id="5" name="TextBox 4">
             <a:extLst>
               <a:ext uri="{FF2B5EF4-FFF2-40B4-BE49-F238E27FC236}">
-                <a16:creationId xmlns:a16="http://schemas.microsoft.com/office/drawing/2014/main" id="{20826404-E9A3-963B-1504-8BE303D9F0E5}"/>
+                <a16:creationId xmlns:a16="http://schemas.microsoft.com/office/drawing/2014/main" id="{DCDAA0C5-2C00-A310-4D50-FC2CA90AB621}"/>
               </a:ext>
             </a:extLst>
           </p:cNvPr>
@@ -7744,7 +7744,7 @@
           <p:cNvPr id="6" name="TextBox 5">
             <a:extLst>
               <a:ext uri="{FF2B5EF4-FFF2-40B4-BE49-F238E27FC236}">
-                <a16:creationId xmlns:a16="http://schemas.microsoft.com/office/drawing/2014/main" id="{34F36C0C-7BBD-4A4C-8CBE-D46A85B98AAA}"/>
+                <a16:creationId xmlns:a16="http://schemas.microsoft.com/office/drawing/2014/main" id="{F740F726-5407-A4C4-820C-2AEBE0D0D021}"/>
               </a:ext>
             </a:extLst>
           </p:cNvPr>
@@ -7788,7 +7788,7 @@
     </p:spTree>
     <p:extLst>
       <p:ext uri="{BB962C8B-B14F-4D97-AF65-F5344CB8AC3E}">
-        <p14:creationId xmlns:p14="http://schemas.microsoft.com/office/powerpoint/2010/main" val="3526886879"/>
+        <p14:creationId xmlns:p14="http://schemas.microsoft.com/office/powerpoint/2010/main" val="2336106870"/>
       </p:ext>
     </p:extLst>
   </p:cSld>
@@ -7828,7 +7828,7 @@
           <p:cNvPr id="2" name="TextBox 1">
             <a:extLst>
               <a:ext uri="{FF2B5EF4-FFF2-40B4-BE49-F238E27FC236}">
-                <a16:creationId xmlns:a16="http://schemas.microsoft.com/office/drawing/2014/main" id="{58C9BBB2-6BB9-F6EA-C5A7-6CB0DD818CE9}"/>
+                <a16:creationId xmlns:a16="http://schemas.microsoft.com/office/drawing/2014/main" id="{78582E76-A096-9106-AC28-AE0969C973D3}"/>
               </a:ext>
             </a:extLst>
           </p:cNvPr>
@@ -7873,7 +7873,7 @@
           <p:cNvPr id="3" name="TextBox 2">
             <a:extLst>
               <a:ext uri="{FF2B5EF4-FFF2-40B4-BE49-F238E27FC236}">
-                <a16:creationId xmlns:a16="http://schemas.microsoft.com/office/drawing/2014/main" id="{64C84866-CB79-9DD0-5167-423B1569BB03}"/>
+                <a16:creationId xmlns:a16="http://schemas.microsoft.com/office/drawing/2014/main" id="{B235DE72-2483-4489-2292-9A463A18B97F}"/>
               </a:ext>
             </a:extLst>
           </p:cNvPr>
@@ -7918,7 +7918,7 @@
           <p:cNvPr id="4" name="TextBox 3">
             <a:extLst>
               <a:ext uri="{FF2B5EF4-FFF2-40B4-BE49-F238E27FC236}">
-                <a16:creationId xmlns:a16="http://schemas.microsoft.com/office/drawing/2014/main" id="{52480B3F-026C-5B35-3AA6-5A7D757AED4B}"/>
+                <a16:creationId xmlns:a16="http://schemas.microsoft.com/office/drawing/2014/main" id="{7B0B8B83-7BEF-C9B6-8EF9-637604E7889F}"/>
               </a:ext>
             </a:extLst>
           </p:cNvPr>
@@ -7963,7 +7963,7 @@
           <p:cNvPr id="5" name="TextBox 4">
             <a:extLst>
               <a:ext uri="{FF2B5EF4-FFF2-40B4-BE49-F238E27FC236}">
-                <a16:creationId xmlns:a16="http://schemas.microsoft.com/office/drawing/2014/main" id="{1C507FFC-E4B0-53BF-CDDC-E64C3E6AE754}"/>
+                <a16:creationId xmlns:a16="http://schemas.microsoft.com/office/drawing/2014/main" id="{0DD4932A-46E6-E628-0EBD-95142F6E33A9}"/>
               </a:ext>
             </a:extLst>
           </p:cNvPr>
@@ -8016,7 +8016,7 @@
           <p:cNvPr id="6" name="TextBox 5">
             <a:extLst>
               <a:ext uri="{FF2B5EF4-FFF2-40B4-BE49-F238E27FC236}">
-                <a16:creationId xmlns:a16="http://schemas.microsoft.com/office/drawing/2014/main" id="{D09AB22C-0B5D-DAFB-41CF-F40E2C762887}"/>
+                <a16:creationId xmlns:a16="http://schemas.microsoft.com/office/drawing/2014/main" id="{D235A97E-0A88-99FA-2F81-4AFEA860B85E}"/>
               </a:ext>
             </a:extLst>
           </p:cNvPr>
@@ -8061,7 +8061,7 @@
           <p:cNvPr id="7" name="TextBox 6">
             <a:extLst>
               <a:ext uri="{FF2B5EF4-FFF2-40B4-BE49-F238E27FC236}">
-                <a16:creationId xmlns:a16="http://schemas.microsoft.com/office/drawing/2014/main" id="{7B29F127-5EA8-1BBC-87AF-3D7B5813DB6B}"/>
+                <a16:creationId xmlns:a16="http://schemas.microsoft.com/office/drawing/2014/main" id="{8F193D38-3208-50CF-3882-964DCE867F3C}"/>
               </a:ext>
             </a:extLst>
           </p:cNvPr>
@@ -8114,7 +8114,7 @@
           <p:cNvPr id="8" name="TextBox 7">
             <a:extLst>
               <a:ext uri="{FF2B5EF4-FFF2-40B4-BE49-F238E27FC236}">
-                <a16:creationId xmlns:a16="http://schemas.microsoft.com/office/drawing/2014/main" id="{334F19D1-8C5A-C098-450B-2225A6941EE2}"/>
+                <a16:creationId xmlns:a16="http://schemas.microsoft.com/office/drawing/2014/main" id="{053CCC49-5520-E658-808A-C3C1EA19045D}"/>
               </a:ext>
             </a:extLst>
           </p:cNvPr>
@@ -8166,7 +8166,7 @@
           <p:cNvPr id="9" name="TextBox 8">
             <a:extLst>
               <a:ext uri="{FF2B5EF4-FFF2-40B4-BE49-F238E27FC236}">
-                <a16:creationId xmlns:a16="http://schemas.microsoft.com/office/drawing/2014/main" id="{16635277-8B02-F6D4-C901-6920CB211591}"/>
+                <a16:creationId xmlns:a16="http://schemas.microsoft.com/office/drawing/2014/main" id="{230B7244-FE67-EE42-6903-655A952BC8B7}"/>
               </a:ext>
             </a:extLst>
           </p:cNvPr>
@@ -8215,7 +8215,7 @@
     </p:spTree>
     <p:extLst>
       <p:ext uri="{BB962C8B-B14F-4D97-AF65-F5344CB8AC3E}">
-        <p14:creationId xmlns:p14="http://schemas.microsoft.com/office/powerpoint/2010/main" val="3781276397"/>
+        <p14:creationId xmlns:p14="http://schemas.microsoft.com/office/powerpoint/2010/main" val="2877683022"/>
       </p:ext>
     </p:extLst>
   </p:cSld>
@@ -8255,7 +8255,7 @@
           <p:cNvPr id="2" name="TextBox 1">
             <a:extLst>
               <a:ext uri="{FF2B5EF4-FFF2-40B4-BE49-F238E27FC236}">
-                <a16:creationId xmlns:a16="http://schemas.microsoft.com/office/drawing/2014/main" id="{105FAE22-DC02-ABB9-43FC-3737899C52FA}"/>
+                <a16:creationId xmlns:a16="http://schemas.microsoft.com/office/drawing/2014/main" id="{D793BB3D-4D71-3E7C-3BB6-8482202BF63F}"/>
               </a:ext>
             </a:extLst>
           </p:cNvPr>
@@ -8300,7 +8300,7 @@
           <p:cNvPr id="3" name="TextBox 2">
             <a:extLst>
               <a:ext uri="{FF2B5EF4-FFF2-40B4-BE49-F238E27FC236}">
-                <a16:creationId xmlns:a16="http://schemas.microsoft.com/office/drawing/2014/main" id="{BFE54D0C-1DC9-7719-F128-B25C424D7311}"/>
+                <a16:creationId xmlns:a16="http://schemas.microsoft.com/office/drawing/2014/main" id="{0644F12B-3728-264F-82E5-51DDD6E9AA82}"/>
               </a:ext>
             </a:extLst>
           </p:cNvPr>
@@ -8345,7 +8345,7 @@
           <p:cNvPr id="4" name="TextBox 3">
             <a:extLst>
               <a:ext uri="{FF2B5EF4-FFF2-40B4-BE49-F238E27FC236}">
-                <a16:creationId xmlns:a16="http://schemas.microsoft.com/office/drawing/2014/main" id="{58A176E5-8BB7-DBFC-3BD7-7C999167C5F5}"/>
+                <a16:creationId xmlns:a16="http://schemas.microsoft.com/office/drawing/2014/main" id="{28BC7E89-BB67-B591-110E-4D454EF319CF}"/>
               </a:ext>
             </a:extLst>
           </p:cNvPr>
@@ -8390,7 +8390,7 @@
           <p:cNvPr id="5" name="TextBox 4">
             <a:extLst>
               <a:ext uri="{FF2B5EF4-FFF2-40B4-BE49-F238E27FC236}">
-                <a16:creationId xmlns:a16="http://schemas.microsoft.com/office/drawing/2014/main" id="{F872A7B3-C07C-45B2-6531-03BB92632973}"/>
+                <a16:creationId xmlns:a16="http://schemas.microsoft.com/office/drawing/2014/main" id="{ED5CA8A7-C740-0A32-C956-53C83E30B68B}"/>
               </a:ext>
             </a:extLst>
           </p:cNvPr>
@@ -8400,7 +8400,7 @@
         <p:spPr>
           <a:xfrm>
             <a:off x="609600" y="2133599"/>
-            <a:ext cx="3302000" cy="1536700"/>
+            <a:ext cx="3302000" cy="1727200"/>
           </a:xfrm>
           <a:prstGeom prst="rect">
             <a:avLst/>
@@ -8419,17 +8419,18 @@
               </a:spcAft>
             </a:pPr>
             <a:r>
-              <a:rPr lang="en-US" sz="2300">
+              <a:rPr lang="en-US" sz="2200">
                 <a:solidFill>
                   <a:srgbClr val="20364A"/>
                 </a:solidFill>
                 <a:latin typeface="Aptos" panose="020B0004020202020204" pitchFamily="34" charset="0"/>
               </a:rPr>
-              <a:t>Image or sample
-Choose model
-Loading, then probabilities</a:t>
-            </a:r>
-            <a:endParaRPr lang="en-ZA" sz="2300">
+              <a:t>Open image / Samples
+Model menu, Classify
+Class and confidence
+Details: probabilities</a:t>
+            </a:r>
+            <a:endParaRPr lang="en-ZA" sz="2200">
               <a:solidFill>
                 <a:srgbClr val="20364A"/>
               </a:solidFill>
@@ -8443,7 +8444,7 @@
           <p:cNvPr id="6" name="TextBox 5">
             <a:extLst>
               <a:ext uri="{FF2B5EF4-FFF2-40B4-BE49-F238E27FC236}">
-                <a16:creationId xmlns:a16="http://schemas.microsoft.com/office/drawing/2014/main" id="{B8125495-D57B-4E53-A93C-4E0814A8F405}"/>
+                <a16:creationId xmlns:a16="http://schemas.microsoft.com/office/drawing/2014/main" id="{44558F73-910F-BAEC-DFA6-5877EE364443}"/>
               </a:ext>
             </a:extLst>
           </p:cNvPr>
@@ -8478,7 +8479,7 @@
                 </a:solidFill>
                 <a:latin typeface="Aptos" panose="020B0004020202020204" pitchFamily="34" charset="0"/>
               </a:rPr>
-              <a:t>Results</a:t>
+              <a:t>Study</a:t>
             </a:r>
           </a:p>
         </p:txBody>
@@ -8488,7 +8489,7 @@
           <p:cNvPr id="7" name="TextBox 6">
             <a:extLst>
               <a:ext uri="{FF2B5EF4-FFF2-40B4-BE49-F238E27FC236}">
-                <a16:creationId xmlns:a16="http://schemas.microsoft.com/office/drawing/2014/main" id="{4946A15A-89A1-8CD1-0B3B-81920D97CEAC}"/>
+                <a16:creationId xmlns:a16="http://schemas.microsoft.com/office/drawing/2014/main" id="{EAEEAE27-0C8E-A825-5188-911EFD96EDE4}"/>
               </a:ext>
             </a:extLst>
           </p:cNvPr>
@@ -8541,7 +8542,7 @@
           <p:cNvPr id="8" name="TextBox 7">
             <a:extLst>
               <a:ext uri="{FF2B5EF4-FFF2-40B4-BE49-F238E27FC236}">
-                <a16:creationId xmlns:a16="http://schemas.microsoft.com/office/drawing/2014/main" id="{67C0BF7C-04D8-5E2D-4BF9-FA7E04A34E82}"/>
+                <a16:creationId xmlns:a16="http://schemas.microsoft.com/office/drawing/2014/main" id="{46CAAE6F-FA28-65F1-8BC3-967F9732F827}"/>
               </a:ext>
             </a:extLst>
           </p:cNvPr>
@@ -8576,7 +8577,7 @@
                 </a:solidFill>
                 <a:latin typeface="Aptos" panose="020B0004020202020204" pitchFamily="34" charset="0"/>
               </a:rPr>
-              <a:t>Dataset</a:t>
+              <a:t>Samples</a:t>
             </a:r>
           </a:p>
         </p:txBody>
@@ -8586,7 +8587,7 @@
           <p:cNvPr id="9" name="TextBox 8">
             <a:extLst>
               <a:ext uri="{FF2B5EF4-FFF2-40B4-BE49-F238E27FC236}">
-                <a16:creationId xmlns:a16="http://schemas.microsoft.com/office/drawing/2014/main" id="{8033E54E-F626-61EA-CA46-A0533BED3417}"/>
+                <a16:creationId xmlns:a16="http://schemas.microsoft.com/office/drawing/2014/main" id="{B6C05DA6-5D7D-9EC5-8FC2-810F2BECCF79}"/>
               </a:ext>
             </a:extLst>
           </p:cNvPr>
@@ -8639,7 +8640,7 @@
           <p:cNvPr id="10" name="TextBox 9">
             <a:extLst>
               <a:ext uri="{FF2B5EF4-FFF2-40B4-BE49-F238E27FC236}">
-                <a16:creationId xmlns:a16="http://schemas.microsoft.com/office/drawing/2014/main" id="{AD06EA9E-71DF-4036-D300-881663EA7358}"/>
+                <a16:creationId xmlns:a16="http://schemas.microsoft.com/office/drawing/2014/main" id="{D22529C5-F0CF-36FB-0416-CEF2647AD24A}"/>
               </a:ext>
             </a:extLst>
           </p:cNvPr>
@@ -8691,7 +8692,7 @@
           <p:cNvPr id="11" name="TextBox 10">
             <a:extLst>
               <a:ext uri="{FF2B5EF4-FFF2-40B4-BE49-F238E27FC236}">
-                <a16:creationId xmlns:a16="http://schemas.microsoft.com/office/drawing/2014/main" id="{322B9BAC-D19B-C8C4-F07C-BF9F73F4C707}"/>
+                <a16:creationId xmlns:a16="http://schemas.microsoft.com/office/drawing/2014/main" id="{1CA8F5A7-AA04-5FDA-FD8D-16ED7C1197D7}"/>
               </a:ext>
             </a:extLst>
           </p:cNvPr>
@@ -8740,7 +8741,7 @@
     </p:spTree>
     <p:extLst>
       <p:ext uri="{BB962C8B-B14F-4D97-AF65-F5344CB8AC3E}">
-        <p14:creationId xmlns:p14="http://schemas.microsoft.com/office/powerpoint/2010/main" val="2026363235"/>
+        <p14:creationId xmlns:p14="http://schemas.microsoft.com/office/powerpoint/2010/main" val="4203851223"/>
       </p:ext>
     </p:extLst>
   </p:cSld>
@@ -8780,7 +8781,7 @@
           <p:cNvPr id="2" name="TextBox 1">
             <a:extLst>
               <a:ext uri="{FF2B5EF4-FFF2-40B4-BE49-F238E27FC236}">
-                <a16:creationId xmlns:a16="http://schemas.microsoft.com/office/drawing/2014/main" id="{D3D95891-6279-B8EF-5D99-501A0CE15598}"/>
+                <a16:creationId xmlns:a16="http://schemas.microsoft.com/office/drawing/2014/main" id="{F3B43B98-4625-51DE-FE79-D9E5148E8751}"/>
               </a:ext>
             </a:extLst>
           </p:cNvPr>
@@ -8825,7 +8826,7 @@
           <p:cNvPr id="3" name="TextBox 2">
             <a:extLst>
               <a:ext uri="{FF2B5EF4-FFF2-40B4-BE49-F238E27FC236}">
-                <a16:creationId xmlns:a16="http://schemas.microsoft.com/office/drawing/2014/main" id="{ECC295BC-DD32-CC08-280F-4B3C867AA27A}"/>
+                <a16:creationId xmlns:a16="http://schemas.microsoft.com/office/drawing/2014/main" id="{E06A3750-E855-63FD-D95E-ECA6AF50A557}"/>
               </a:ext>
             </a:extLst>
           </p:cNvPr>
@@ -8870,7 +8871,7 @@
           <p:cNvPr id="4" name="TextBox 3">
             <a:extLst>
               <a:ext uri="{FF2B5EF4-FFF2-40B4-BE49-F238E27FC236}">
-                <a16:creationId xmlns:a16="http://schemas.microsoft.com/office/drawing/2014/main" id="{76886ACD-BD81-521A-BC7E-7A197785D322}"/>
+                <a16:creationId xmlns:a16="http://schemas.microsoft.com/office/drawing/2014/main" id="{6D0FB815-738E-0B88-C9D8-3BD29DD631EF}"/>
               </a:ext>
             </a:extLst>
           </p:cNvPr>
@@ -8921,7 +8922,7 @@
           <p:cNvPr id="5" name="TextBox 4">
             <a:extLst>
               <a:ext uri="{FF2B5EF4-FFF2-40B4-BE49-F238E27FC236}">
-                <a16:creationId xmlns:a16="http://schemas.microsoft.com/office/drawing/2014/main" id="{19142413-A71E-5A8D-7C05-C45B9B44337B}"/>
+                <a16:creationId xmlns:a16="http://schemas.microsoft.com/office/drawing/2014/main" id="{F964C4C8-70C8-C1A2-2326-3CF710E4213B}"/>
               </a:ext>
             </a:extLst>
           </p:cNvPr>
@@ -8966,7 +8967,7 @@
           <p:cNvPr id="6" name="TextBox 5">
             <a:extLst>
               <a:ext uri="{FF2B5EF4-FFF2-40B4-BE49-F238E27FC236}">
-                <a16:creationId xmlns:a16="http://schemas.microsoft.com/office/drawing/2014/main" id="{610F6464-8E2F-75FF-1A3C-0F67D02C71F9}"/>
+                <a16:creationId xmlns:a16="http://schemas.microsoft.com/office/drawing/2014/main" id="{5935BF7A-1845-31E2-7F81-B84BE124F6D4}"/>
               </a:ext>
             </a:extLst>
           </p:cNvPr>
@@ -9011,7 +9012,7 @@
           <p:cNvPr id="7" name="TextBox 6">
             <a:extLst>
               <a:ext uri="{FF2B5EF4-FFF2-40B4-BE49-F238E27FC236}">
-                <a16:creationId xmlns:a16="http://schemas.microsoft.com/office/drawing/2014/main" id="{0F6BB773-4CF5-E40B-C3B3-371B43A9B11A}"/>
+                <a16:creationId xmlns:a16="http://schemas.microsoft.com/office/drawing/2014/main" id="{4DD5BB16-0E57-6CC9-4A5A-58079906762E}"/>
               </a:ext>
             </a:extLst>
           </p:cNvPr>
@@ -9056,7 +9057,7 @@
           <p:cNvPr id="8" name="TextBox 7">
             <a:extLst>
               <a:ext uri="{FF2B5EF4-FFF2-40B4-BE49-F238E27FC236}">
-                <a16:creationId xmlns:a16="http://schemas.microsoft.com/office/drawing/2014/main" id="{FD97C878-6F79-F621-502A-3B9276E5DA69}"/>
+                <a16:creationId xmlns:a16="http://schemas.microsoft.com/office/drawing/2014/main" id="{B133B113-452B-BFE2-BAB5-5EDE301AB479}"/>
               </a:ext>
             </a:extLst>
           </p:cNvPr>
@@ -9107,7 +9108,7 @@
           <p:cNvPr id="9" name="TextBox 8">
             <a:extLst>
               <a:ext uri="{FF2B5EF4-FFF2-40B4-BE49-F238E27FC236}">
-                <a16:creationId xmlns:a16="http://schemas.microsoft.com/office/drawing/2014/main" id="{CC0FFAE5-FAC6-2584-1019-321A5ED930C0}"/>
+                <a16:creationId xmlns:a16="http://schemas.microsoft.com/office/drawing/2014/main" id="{C80EE310-BDB3-FBA9-CF26-CC541916897A}"/>
               </a:ext>
             </a:extLst>
           </p:cNvPr>
@@ -9152,7 +9153,7 @@
           <p:cNvPr id="10" name="TextBox 9">
             <a:extLst>
               <a:ext uri="{FF2B5EF4-FFF2-40B4-BE49-F238E27FC236}">
-                <a16:creationId xmlns:a16="http://schemas.microsoft.com/office/drawing/2014/main" id="{BB1FBD92-1DD1-5D3A-84A5-7A26A50251CA}"/>
+                <a16:creationId xmlns:a16="http://schemas.microsoft.com/office/drawing/2014/main" id="{4B04CE68-4768-E918-9F7B-92278523B896}"/>
               </a:ext>
             </a:extLst>
           </p:cNvPr>
@@ -9203,7 +9204,7 @@
           <p:cNvPr id="11" name="TextBox 10">
             <a:extLst>
               <a:ext uri="{FF2B5EF4-FFF2-40B4-BE49-F238E27FC236}">
-                <a16:creationId xmlns:a16="http://schemas.microsoft.com/office/drawing/2014/main" id="{18F4D895-1D1B-DA38-7F5C-30E86F70E0E5}"/>
+                <a16:creationId xmlns:a16="http://schemas.microsoft.com/office/drawing/2014/main" id="{41B61CA5-0DB2-5B09-59A0-B4CFB31F25C5}"/>
               </a:ext>
             </a:extLst>
           </p:cNvPr>
@@ -9248,7 +9249,7 @@
           <p:cNvPr id="12" name="TextBox 11">
             <a:extLst>
               <a:ext uri="{FF2B5EF4-FFF2-40B4-BE49-F238E27FC236}">
-                <a16:creationId xmlns:a16="http://schemas.microsoft.com/office/drawing/2014/main" id="{D4AD8DEC-DAE2-0FAE-A868-A65AAEBF1040}"/>
+                <a16:creationId xmlns:a16="http://schemas.microsoft.com/office/drawing/2014/main" id="{7A5524D7-3349-6BB7-B94F-B4DBB1681527}"/>
               </a:ext>
             </a:extLst>
           </p:cNvPr>
@@ -9299,7 +9300,7 @@
           <p:cNvPr id="13" name="TextBox 12">
             <a:extLst>
               <a:ext uri="{FF2B5EF4-FFF2-40B4-BE49-F238E27FC236}">
-                <a16:creationId xmlns:a16="http://schemas.microsoft.com/office/drawing/2014/main" id="{F8AD5406-2F23-D6B4-18D7-DB5D38197CF9}"/>
+                <a16:creationId xmlns:a16="http://schemas.microsoft.com/office/drawing/2014/main" id="{B1F0E6FD-F63F-E44A-57C7-26FA0F43722A}"/>
               </a:ext>
             </a:extLst>
           </p:cNvPr>
@@ -9350,7 +9351,7 @@
           <p:cNvPr id="14" name="TextBox 13">
             <a:extLst>
               <a:ext uri="{FF2B5EF4-FFF2-40B4-BE49-F238E27FC236}">
-                <a16:creationId xmlns:a16="http://schemas.microsoft.com/office/drawing/2014/main" id="{FFB488D5-456E-28DA-1843-9097A303A547}"/>
+                <a16:creationId xmlns:a16="http://schemas.microsoft.com/office/drawing/2014/main" id="{8B3D24E5-3654-B492-B0E5-C174EC36D71C}"/>
               </a:ext>
             </a:extLst>
           </p:cNvPr>
@@ -9401,7 +9402,7 @@
           <p:cNvPr id="15" name="TextBox 14">
             <a:extLst>
               <a:ext uri="{FF2B5EF4-FFF2-40B4-BE49-F238E27FC236}">
-                <a16:creationId xmlns:a16="http://schemas.microsoft.com/office/drawing/2014/main" id="{AE9FC75F-0A49-9773-B0A2-AE63ED347CF6}"/>
+                <a16:creationId xmlns:a16="http://schemas.microsoft.com/office/drawing/2014/main" id="{9894540C-60A3-12B8-2852-248486B80C4F}"/>
               </a:ext>
             </a:extLst>
           </p:cNvPr>
@@ -9452,7 +9453,7 @@
           <p:cNvPr id="16" name="TextBox 15">
             <a:extLst>
               <a:ext uri="{FF2B5EF4-FFF2-40B4-BE49-F238E27FC236}">
-                <a16:creationId xmlns:a16="http://schemas.microsoft.com/office/drawing/2014/main" id="{A19260D9-7307-ABBA-BD53-2EA5E32EFF31}"/>
+                <a16:creationId xmlns:a16="http://schemas.microsoft.com/office/drawing/2014/main" id="{D377FFD7-5AD5-185B-AD23-0031378CE589}"/>
               </a:ext>
             </a:extLst>
           </p:cNvPr>
@@ -9502,7 +9503,7 @@
     </p:spTree>
     <p:extLst>
       <p:ext uri="{BB962C8B-B14F-4D97-AF65-F5344CB8AC3E}">
-        <p14:creationId xmlns:p14="http://schemas.microsoft.com/office/powerpoint/2010/main" val="2740864315"/>
+        <p14:creationId xmlns:p14="http://schemas.microsoft.com/office/powerpoint/2010/main" val="3500400867"/>
       </p:ext>
     </p:extLst>
   </p:cSld>
@@ -9542,7 +9543,7 @@
           <p:cNvPr id="2" name="TextBox 1">
             <a:extLst>
               <a:ext uri="{FF2B5EF4-FFF2-40B4-BE49-F238E27FC236}">
-                <a16:creationId xmlns:a16="http://schemas.microsoft.com/office/drawing/2014/main" id="{EA6FF4F8-AE4C-E192-F9B6-C0B430E6F276}"/>
+                <a16:creationId xmlns:a16="http://schemas.microsoft.com/office/drawing/2014/main" id="{F7B44E3D-3078-DBB1-2801-09B81A3E1E82}"/>
               </a:ext>
             </a:extLst>
           </p:cNvPr>
@@ -9593,7 +9594,7 @@
           <p:cNvPr id="3" name="TextBox 2">
             <a:extLst>
               <a:ext uri="{FF2B5EF4-FFF2-40B4-BE49-F238E27FC236}">
-                <a16:creationId xmlns:a16="http://schemas.microsoft.com/office/drawing/2014/main" id="{4723D837-FE25-D033-51E9-89C008B84F76}"/>
+                <a16:creationId xmlns:a16="http://schemas.microsoft.com/office/drawing/2014/main" id="{D7C333E6-A6BF-22D9-3CAC-B9C8348CF95D}"/>
               </a:ext>
             </a:extLst>
           </p:cNvPr>
@@ -9638,7 +9639,7 @@
           <p:cNvPr id="4" name="TextBox 3">
             <a:extLst>
               <a:ext uri="{FF2B5EF4-FFF2-40B4-BE49-F238E27FC236}">
-                <a16:creationId xmlns:a16="http://schemas.microsoft.com/office/drawing/2014/main" id="{FC97A30F-F941-43B1-CB8F-9C77993811C5}"/>
+                <a16:creationId xmlns:a16="http://schemas.microsoft.com/office/drawing/2014/main" id="{6A1E20FD-A05B-067F-AC2B-5C562069E217}"/>
               </a:ext>
             </a:extLst>
           </p:cNvPr>
@@ -9689,7 +9690,7 @@
           <p:cNvPr id="6" name="Picture 5">
             <a:extLst>
               <a:ext uri="{FF2B5EF4-FFF2-40B4-BE49-F238E27FC236}">
-                <a16:creationId xmlns:a16="http://schemas.microsoft.com/office/drawing/2014/main" id="{57653C2D-12DD-A500-5D0F-A5F3E7589978}"/>
+                <a16:creationId xmlns:a16="http://schemas.microsoft.com/office/drawing/2014/main" id="{4D7997C8-74E5-57C4-8E4A-D9909883FBD7}"/>
               </a:ext>
             </a:extLst>
           </p:cNvPr>
@@ -9725,7 +9726,7 @@
           <p:cNvPr id="7" name="TextBox 6">
             <a:extLst>
               <a:ext uri="{FF2B5EF4-FFF2-40B4-BE49-F238E27FC236}">
-                <a16:creationId xmlns:a16="http://schemas.microsoft.com/office/drawing/2014/main" id="{1055D9AD-D8BB-EF4C-F214-8682277FCA5A}"/>
+                <a16:creationId xmlns:a16="http://schemas.microsoft.com/office/drawing/2014/main" id="{A2F583FE-51D9-806A-A1CF-38B49ABAE9FC}"/>
               </a:ext>
             </a:extLst>
           </p:cNvPr>
@@ -9770,7 +9771,7 @@
           <p:cNvPr id="9" name="Picture 8">
             <a:extLst>
               <a:ext uri="{FF2B5EF4-FFF2-40B4-BE49-F238E27FC236}">
-                <a16:creationId xmlns:a16="http://schemas.microsoft.com/office/drawing/2014/main" id="{619E765F-157B-5357-E4E3-F48DA570C3AA}"/>
+                <a16:creationId xmlns:a16="http://schemas.microsoft.com/office/drawing/2014/main" id="{1E80AF31-8D79-1021-BB3D-53B462B63D7B}"/>
               </a:ext>
             </a:extLst>
           </p:cNvPr>
@@ -9806,7 +9807,7 @@
           <p:cNvPr id="10" name="TextBox 9">
             <a:extLst>
               <a:ext uri="{FF2B5EF4-FFF2-40B4-BE49-F238E27FC236}">
-                <a16:creationId xmlns:a16="http://schemas.microsoft.com/office/drawing/2014/main" id="{63B788C6-D40C-AC0A-4D59-FC586FF7D099}"/>
+                <a16:creationId xmlns:a16="http://schemas.microsoft.com/office/drawing/2014/main" id="{45C832F4-1878-69C3-F814-D1C3339076C0}"/>
               </a:ext>
             </a:extLst>
           </p:cNvPr>
@@ -9851,7 +9852,7 @@
           <p:cNvPr id="12" name="Picture 11">
             <a:extLst>
               <a:ext uri="{FF2B5EF4-FFF2-40B4-BE49-F238E27FC236}">
-                <a16:creationId xmlns:a16="http://schemas.microsoft.com/office/drawing/2014/main" id="{0DEB6EA4-A3C9-D709-31B3-C5C67315C5F4}"/>
+                <a16:creationId xmlns:a16="http://schemas.microsoft.com/office/drawing/2014/main" id="{D6BC70BA-40A0-5D67-4ED9-6256B26A42F8}"/>
               </a:ext>
             </a:extLst>
           </p:cNvPr>
@@ -9887,7 +9888,7 @@
           <p:cNvPr id="13" name="TextBox 12">
             <a:extLst>
               <a:ext uri="{FF2B5EF4-FFF2-40B4-BE49-F238E27FC236}">
-                <a16:creationId xmlns:a16="http://schemas.microsoft.com/office/drawing/2014/main" id="{6372246E-D2F2-8FEC-A7C4-02E9CDA7AB51}"/>
+                <a16:creationId xmlns:a16="http://schemas.microsoft.com/office/drawing/2014/main" id="{A36934BA-4333-DA9E-1530-A5C2380770B9}"/>
               </a:ext>
             </a:extLst>
           </p:cNvPr>
@@ -9932,7 +9933,7 @@
           <p:cNvPr id="15" name="Picture 14">
             <a:extLst>
               <a:ext uri="{FF2B5EF4-FFF2-40B4-BE49-F238E27FC236}">
-                <a16:creationId xmlns:a16="http://schemas.microsoft.com/office/drawing/2014/main" id="{277A7B52-B47B-59F2-8EFA-C4E993B5EDD3}"/>
+                <a16:creationId xmlns:a16="http://schemas.microsoft.com/office/drawing/2014/main" id="{993C9DD1-4BAD-3C03-A233-CE3B8986A67C}"/>
               </a:ext>
             </a:extLst>
           </p:cNvPr>
@@ -9968,7 +9969,7 @@
           <p:cNvPr id="16" name="TextBox 15">
             <a:extLst>
               <a:ext uri="{FF2B5EF4-FFF2-40B4-BE49-F238E27FC236}">
-                <a16:creationId xmlns:a16="http://schemas.microsoft.com/office/drawing/2014/main" id="{50C4CC9E-BE87-3DCC-50F7-9A97E349A24D}"/>
+                <a16:creationId xmlns:a16="http://schemas.microsoft.com/office/drawing/2014/main" id="{5DAC41E2-FAD2-2064-58B3-BA53C75E5815}"/>
               </a:ext>
             </a:extLst>
           </p:cNvPr>
@@ -10013,7 +10014,7 @@
           <p:cNvPr id="18" name="Picture 17">
             <a:extLst>
               <a:ext uri="{FF2B5EF4-FFF2-40B4-BE49-F238E27FC236}">
-                <a16:creationId xmlns:a16="http://schemas.microsoft.com/office/drawing/2014/main" id="{6F6672AB-8345-8FD7-B124-B2EAE8F5E2EB}"/>
+                <a16:creationId xmlns:a16="http://schemas.microsoft.com/office/drawing/2014/main" id="{435131F6-DED0-626F-CBF5-83C19E6C987B}"/>
               </a:ext>
             </a:extLst>
           </p:cNvPr>
@@ -10049,7 +10050,7 @@
           <p:cNvPr id="19" name="TextBox 18">
             <a:extLst>
               <a:ext uri="{FF2B5EF4-FFF2-40B4-BE49-F238E27FC236}">
-                <a16:creationId xmlns:a16="http://schemas.microsoft.com/office/drawing/2014/main" id="{8E2A61F3-8C1D-B649-7A7C-9E17760E2D93}"/>
+                <a16:creationId xmlns:a16="http://schemas.microsoft.com/office/drawing/2014/main" id="{8318DEF8-1EDF-9620-DD69-28C2B3ADB3E2}"/>
               </a:ext>
             </a:extLst>
           </p:cNvPr>
@@ -10094,7 +10095,7 @@
           <p:cNvPr id="21" name="Picture 20">
             <a:extLst>
               <a:ext uri="{FF2B5EF4-FFF2-40B4-BE49-F238E27FC236}">
-                <a16:creationId xmlns:a16="http://schemas.microsoft.com/office/drawing/2014/main" id="{E213FBFD-CA83-4364-CCE0-FCEE3F1362AA}"/>
+                <a16:creationId xmlns:a16="http://schemas.microsoft.com/office/drawing/2014/main" id="{4A8CA349-2546-8812-54D6-25052D668B92}"/>
               </a:ext>
             </a:extLst>
           </p:cNvPr>
@@ -10130,7 +10131,7 @@
           <p:cNvPr id="22" name="TextBox 21">
             <a:extLst>
               <a:ext uri="{FF2B5EF4-FFF2-40B4-BE49-F238E27FC236}">
-                <a16:creationId xmlns:a16="http://schemas.microsoft.com/office/drawing/2014/main" id="{027257A9-0D2F-1144-4BC8-D90F2D2DA820}"/>
+                <a16:creationId xmlns:a16="http://schemas.microsoft.com/office/drawing/2014/main" id="{7EA42B8D-D0BE-B23B-FF4B-B608D1D1FD96}"/>
               </a:ext>
             </a:extLst>
           </p:cNvPr>
@@ -10175,7 +10176,7 @@
           <p:cNvPr id="24" name="Picture 23">
             <a:extLst>
               <a:ext uri="{FF2B5EF4-FFF2-40B4-BE49-F238E27FC236}">
-                <a16:creationId xmlns:a16="http://schemas.microsoft.com/office/drawing/2014/main" id="{03A8F7D2-E2A4-BB99-8A7B-ED0FD88D3A87}"/>
+                <a16:creationId xmlns:a16="http://schemas.microsoft.com/office/drawing/2014/main" id="{9321A717-EEC1-9318-D011-D7EF15A3159F}"/>
               </a:ext>
             </a:extLst>
           </p:cNvPr>
@@ -10211,7 +10212,7 @@
           <p:cNvPr id="25" name="TextBox 24">
             <a:extLst>
               <a:ext uri="{FF2B5EF4-FFF2-40B4-BE49-F238E27FC236}">
-                <a16:creationId xmlns:a16="http://schemas.microsoft.com/office/drawing/2014/main" id="{94863AFF-AA80-E68F-F80A-3D7D8A0F6C8A}"/>
+                <a16:creationId xmlns:a16="http://schemas.microsoft.com/office/drawing/2014/main" id="{856D42EB-EBBB-9E13-66F8-3E7E7910CCB7}"/>
               </a:ext>
             </a:extLst>
           </p:cNvPr>
@@ -10256,7 +10257,7 @@
           <p:cNvPr id="26" name="TextBox 25">
             <a:extLst>
               <a:ext uri="{FF2B5EF4-FFF2-40B4-BE49-F238E27FC236}">
-                <a16:creationId xmlns:a16="http://schemas.microsoft.com/office/drawing/2014/main" id="{63766BD0-B777-DBA1-D65A-82F3E6F99D90}"/>
+                <a16:creationId xmlns:a16="http://schemas.microsoft.com/office/drawing/2014/main" id="{42F172B3-FE68-8946-6527-41639357D708}"/>
               </a:ext>
             </a:extLst>
           </p:cNvPr>
@@ -10307,7 +10308,7 @@
           <p:cNvPr id="27" name="TextBox 26">
             <a:extLst>
               <a:ext uri="{FF2B5EF4-FFF2-40B4-BE49-F238E27FC236}">
-                <a16:creationId xmlns:a16="http://schemas.microsoft.com/office/drawing/2014/main" id="{53EBAF50-3D36-E1B7-BE37-57E7ADD1E6CA}"/>
+                <a16:creationId xmlns:a16="http://schemas.microsoft.com/office/drawing/2014/main" id="{FF1E3068-A7C1-42C2-51F0-9C76AA25D88C}"/>
               </a:ext>
             </a:extLst>
           </p:cNvPr>
@@ -10356,7 +10357,7 @@
     </p:spTree>
     <p:extLst>
       <p:ext uri="{BB962C8B-B14F-4D97-AF65-F5344CB8AC3E}">
-        <p14:creationId xmlns:p14="http://schemas.microsoft.com/office/powerpoint/2010/main" val="2883514900"/>
+        <p14:creationId xmlns:p14="http://schemas.microsoft.com/office/powerpoint/2010/main" val="2777366968"/>
       </p:ext>
     </p:extLst>
   </p:cSld>
@@ -10396,7 +10397,7 @@
           <p:cNvPr id="2" name="TextBox 1">
             <a:extLst>
               <a:ext uri="{FF2B5EF4-FFF2-40B4-BE49-F238E27FC236}">
-                <a16:creationId xmlns:a16="http://schemas.microsoft.com/office/drawing/2014/main" id="{27C976C1-F1C2-CC40-7195-20A0FAD236A4}"/>
+                <a16:creationId xmlns:a16="http://schemas.microsoft.com/office/drawing/2014/main" id="{EC8F27B7-20ED-8D0C-ABB4-E9C26FC9AF4C}"/>
               </a:ext>
             </a:extLst>
           </p:cNvPr>
@@ -10447,7 +10448,7 @@
           <p:cNvPr id="3" name="TextBox 2">
             <a:extLst>
               <a:ext uri="{FF2B5EF4-FFF2-40B4-BE49-F238E27FC236}">
-                <a16:creationId xmlns:a16="http://schemas.microsoft.com/office/drawing/2014/main" id="{CDCD18D0-A239-907A-5752-ECCDE77014D7}"/>
+                <a16:creationId xmlns:a16="http://schemas.microsoft.com/office/drawing/2014/main" id="{31029E97-E770-20AF-FAE7-CDB137B6160D}"/>
               </a:ext>
             </a:extLst>
           </p:cNvPr>
@@ -10492,7 +10493,7 @@
           <p:cNvPr id="4" name="Table 3">
             <a:extLst>
               <a:ext uri="{FF2B5EF4-FFF2-40B4-BE49-F238E27FC236}">
-                <a16:creationId xmlns:a16="http://schemas.microsoft.com/office/drawing/2014/main" id="{4AA5F4F6-3E23-9CB1-030C-BB63A45586C7}"/>
+                <a16:creationId xmlns:a16="http://schemas.microsoft.com/office/drawing/2014/main" id="{36E25969-A32A-012F-D8D9-1916D6490C1B}"/>
               </a:ext>
             </a:extLst>
           </p:cNvPr>
@@ -10502,7 +10503,7 @@
           <p:nvPr>
             <p:extLst>
               <p:ext uri="{D42A27DB-BD31-4B8C-83A1-F6EECF244321}">
-                <p14:modId xmlns:p14="http://schemas.microsoft.com/office/powerpoint/2010/main" val="4205653320"/>
+                <p14:modId xmlns:p14="http://schemas.microsoft.com/office/powerpoint/2010/main" val="214777138"/>
               </p:ext>
             </p:extLst>
           </p:nvPr>
@@ -10521,28 +10522,28 @@
                 <a:gridCol w="3621024">
                   <a:extLst>
                     <a:ext uri="{9D8B030D-6E8A-4147-A177-3AD203B41FA5}">
-                      <a16:colId xmlns:a16="http://schemas.microsoft.com/office/drawing/2014/main" val="3593156543"/>
+                      <a16:colId xmlns:a16="http://schemas.microsoft.com/office/drawing/2014/main" val="2783823124"/>
                     </a:ext>
                   </a:extLst>
                 </a:gridCol>
                 <a:gridCol w="2194560">
                   <a:extLst>
                     <a:ext uri="{9D8B030D-6E8A-4147-A177-3AD203B41FA5}">
-                      <a16:colId xmlns:a16="http://schemas.microsoft.com/office/drawing/2014/main" val="3781838685"/>
+                      <a16:colId xmlns:a16="http://schemas.microsoft.com/office/drawing/2014/main" val="817821319"/>
                     </a:ext>
                   </a:extLst>
                 </a:gridCol>
                 <a:gridCol w="2523744">
                   <a:extLst>
                     <a:ext uri="{9D8B030D-6E8A-4147-A177-3AD203B41FA5}">
-                      <a16:colId xmlns:a16="http://schemas.microsoft.com/office/drawing/2014/main" val="2537274318"/>
+                      <a16:colId xmlns:a16="http://schemas.microsoft.com/office/drawing/2014/main" val="1551817629"/>
                     </a:ext>
                   </a:extLst>
                 </a:gridCol>
                 <a:gridCol w="2633472">
                   <a:extLst>
                     <a:ext uri="{9D8B030D-6E8A-4147-A177-3AD203B41FA5}">
-                      <a16:colId xmlns:a16="http://schemas.microsoft.com/office/drawing/2014/main" val="2052293164"/>
+                      <a16:colId xmlns:a16="http://schemas.microsoft.com/office/drawing/2014/main" val="3437956118"/>
                     </a:ext>
                   </a:extLst>
                 </a:gridCol>
@@ -10638,7 +10639,7 @@
                 </a:tc>
                 <a:extLst>
                   <a:ext uri="{0D108BD9-81ED-4DB2-BD59-A6C34878D82A}">
-                    <a16:rowId xmlns:a16="http://schemas.microsoft.com/office/drawing/2014/main" val="1956378578"/>
+                    <a16:rowId xmlns:a16="http://schemas.microsoft.com/office/drawing/2014/main" val="2835764962"/>
                   </a:ext>
                 </a:extLst>
               </a:tr>
@@ -10733,7 +10734,7 @@
                 </a:tc>
                 <a:extLst>
                   <a:ext uri="{0D108BD9-81ED-4DB2-BD59-A6C34878D82A}">
-                    <a16:rowId xmlns:a16="http://schemas.microsoft.com/office/drawing/2014/main" val="1891603612"/>
+                    <a16:rowId xmlns:a16="http://schemas.microsoft.com/office/drawing/2014/main" val="1853394338"/>
                   </a:ext>
                 </a:extLst>
               </a:tr>
@@ -10828,7 +10829,7 @@
                 </a:tc>
                 <a:extLst>
                   <a:ext uri="{0D108BD9-81ED-4DB2-BD59-A6C34878D82A}">
-                    <a16:rowId xmlns:a16="http://schemas.microsoft.com/office/drawing/2014/main" val="862552334"/>
+                    <a16:rowId xmlns:a16="http://schemas.microsoft.com/office/drawing/2014/main" val="2012478497"/>
                   </a:ext>
                 </a:extLst>
               </a:tr>
@@ -10841,7 +10842,7 @@
           <p:cNvPr id="5" name="TextBox 4">
             <a:extLst>
               <a:ext uri="{FF2B5EF4-FFF2-40B4-BE49-F238E27FC236}">
-                <a16:creationId xmlns:a16="http://schemas.microsoft.com/office/drawing/2014/main" id="{2414AEAA-84B1-BB20-A649-C654AC832A01}"/>
+                <a16:creationId xmlns:a16="http://schemas.microsoft.com/office/drawing/2014/main" id="{B80D6F52-44AF-A99C-AF78-8677CA57B5DA}"/>
               </a:ext>
             </a:extLst>
           </p:cNvPr>
@@ -10892,7 +10893,7 @@
           <p:cNvPr id="6" name="TextBox 5">
             <a:extLst>
               <a:ext uri="{FF2B5EF4-FFF2-40B4-BE49-F238E27FC236}">
-                <a16:creationId xmlns:a16="http://schemas.microsoft.com/office/drawing/2014/main" id="{331D381F-0529-16DD-2F60-5713E3B600CF}"/>
+                <a16:creationId xmlns:a16="http://schemas.microsoft.com/office/drawing/2014/main" id="{B8DBDCE4-8418-5B8A-8CBF-D160F955F438}"/>
               </a:ext>
             </a:extLst>
           </p:cNvPr>
@@ -10944,7 +10945,7 @@
           <p:cNvPr id="7" name="TextBox 6">
             <a:extLst>
               <a:ext uri="{FF2B5EF4-FFF2-40B4-BE49-F238E27FC236}">
-                <a16:creationId xmlns:a16="http://schemas.microsoft.com/office/drawing/2014/main" id="{FD69F2FD-F611-B02F-B272-834AD2AABCDC}"/>
+                <a16:creationId xmlns:a16="http://schemas.microsoft.com/office/drawing/2014/main" id="{20F57580-732B-DCDA-456F-484ACBC952BC}"/>
               </a:ext>
             </a:extLst>
           </p:cNvPr>
@@ -10993,7 +10994,7 @@
     </p:spTree>
     <p:extLst>
       <p:ext uri="{BB962C8B-B14F-4D97-AF65-F5344CB8AC3E}">
-        <p14:creationId xmlns:p14="http://schemas.microsoft.com/office/powerpoint/2010/main" val="4234476797"/>
+        <p14:creationId xmlns:p14="http://schemas.microsoft.com/office/powerpoint/2010/main" val="1103005315"/>
       </p:ext>
     </p:extLst>
   </p:cSld>
@@ -11033,7 +11034,7 @@
           <p:cNvPr id="2" name="TextBox 1">
             <a:extLst>
               <a:ext uri="{FF2B5EF4-FFF2-40B4-BE49-F238E27FC236}">
-                <a16:creationId xmlns:a16="http://schemas.microsoft.com/office/drawing/2014/main" id="{CA113191-55DF-5827-EBAB-94E9558E9B67}"/>
+                <a16:creationId xmlns:a16="http://schemas.microsoft.com/office/drawing/2014/main" id="{D3580ED6-B912-25CB-EB5D-9769A2B053D1}"/>
               </a:ext>
             </a:extLst>
           </p:cNvPr>
@@ -11084,7 +11085,7 @@
           <p:cNvPr id="3" name="TextBox 2">
             <a:extLst>
               <a:ext uri="{FF2B5EF4-FFF2-40B4-BE49-F238E27FC236}">
-                <a16:creationId xmlns:a16="http://schemas.microsoft.com/office/drawing/2014/main" id="{E4EE517F-CA76-6C21-CD1A-681E4A0FBDC0}"/>
+                <a16:creationId xmlns:a16="http://schemas.microsoft.com/office/drawing/2014/main" id="{0E694AFF-A951-814D-3E96-0C02DBD5A537}"/>
               </a:ext>
             </a:extLst>
           </p:cNvPr>
@@ -11129,7 +11130,7 @@
           <p:cNvPr id="4" name="Table 3">
             <a:extLst>
               <a:ext uri="{FF2B5EF4-FFF2-40B4-BE49-F238E27FC236}">
-                <a16:creationId xmlns:a16="http://schemas.microsoft.com/office/drawing/2014/main" id="{F4232AC3-961C-29BE-DDF8-B71D158A194E}"/>
+                <a16:creationId xmlns:a16="http://schemas.microsoft.com/office/drawing/2014/main" id="{6ECCDD52-83EF-568A-4EDC-5813F69A341B}"/>
               </a:ext>
             </a:extLst>
           </p:cNvPr>
@@ -11139,7 +11140,7 @@
           <p:nvPr>
             <p:extLst>
               <p:ext uri="{D42A27DB-BD31-4B8C-83A1-F6EECF244321}">
-                <p14:modId xmlns:p14="http://schemas.microsoft.com/office/powerpoint/2010/main" val="1870780537"/>
+                <p14:modId xmlns:p14="http://schemas.microsoft.com/office/powerpoint/2010/main" val="2413039913"/>
               </p:ext>
             </p:extLst>
           </p:nvPr>
@@ -11158,21 +11159,21 @@
                 <a:gridCol w="3072384">
                   <a:extLst>
                     <a:ext uri="{9D8B030D-6E8A-4147-A177-3AD203B41FA5}">
-                      <a16:colId xmlns:a16="http://schemas.microsoft.com/office/drawing/2014/main" val="1601587634"/>
+                      <a16:colId xmlns:a16="http://schemas.microsoft.com/office/drawing/2014/main" val="4130436064"/>
                     </a:ext>
                   </a:extLst>
                 </a:gridCol>
                 <a:gridCol w="5925312">
                   <a:extLst>
                     <a:ext uri="{9D8B030D-6E8A-4147-A177-3AD203B41FA5}">
-                      <a16:colId xmlns:a16="http://schemas.microsoft.com/office/drawing/2014/main" val="3935080969"/>
+                      <a16:colId xmlns:a16="http://schemas.microsoft.com/office/drawing/2014/main" val="1820903681"/>
                     </a:ext>
                   </a:extLst>
                 </a:gridCol>
                 <a:gridCol w="1975104">
                   <a:extLst>
                     <a:ext uri="{9D8B030D-6E8A-4147-A177-3AD203B41FA5}">
-                      <a16:colId xmlns:a16="http://schemas.microsoft.com/office/drawing/2014/main" val="3584971336"/>
+                      <a16:colId xmlns:a16="http://schemas.microsoft.com/office/drawing/2014/main" val="2446637768"/>
                     </a:ext>
                   </a:extLst>
                 </a:gridCol>
@@ -11246,7 +11247,7 @@
                 </a:tc>
                 <a:extLst>
                   <a:ext uri="{0D108BD9-81ED-4DB2-BD59-A6C34878D82A}">
-                    <a16:rowId xmlns:a16="http://schemas.microsoft.com/office/drawing/2014/main" val="1822077649"/>
+                    <a16:rowId xmlns:a16="http://schemas.microsoft.com/office/drawing/2014/main" val="893926383"/>
                   </a:ext>
                 </a:extLst>
               </a:tr>
@@ -11326,7 +11327,7 @@
                 </a:tc>
                 <a:extLst>
                   <a:ext uri="{0D108BD9-81ED-4DB2-BD59-A6C34878D82A}">
-                    <a16:rowId xmlns:a16="http://schemas.microsoft.com/office/drawing/2014/main" val="69633147"/>
+                    <a16:rowId xmlns:a16="http://schemas.microsoft.com/office/drawing/2014/main" val="989503882"/>
                   </a:ext>
                 </a:extLst>
               </a:tr>
@@ -11400,7 +11401,7 @@
                 </a:tc>
                 <a:extLst>
                   <a:ext uri="{0D108BD9-81ED-4DB2-BD59-A6C34878D82A}">
-                    <a16:rowId xmlns:a16="http://schemas.microsoft.com/office/drawing/2014/main" val="4019643982"/>
+                    <a16:rowId xmlns:a16="http://schemas.microsoft.com/office/drawing/2014/main" val="1571900532"/>
                   </a:ext>
                 </a:extLst>
               </a:tr>
@@ -11480,7 +11481,7 @@
                 </a:tc>
                 <a:extLst>
                   <a:ext uri="{0D108BD9-81ED-4DB2-BD59-A6C34878D82A}">
-                    <a16:rowId xmlns:a16="http://schemas.microsoft.com/office/drawing/2014/main" val="2330357477"/>
+                    <a16:rowId xmlns:a16="http://schemas.microsoft.com/office/drawing/2014/main" val="2675349543"/>
                   </a:ext>
                 </a:extLst>
               </a:tr>
@@ -11560,7 +11561,7 @@
                 </a:tc>
                 <a:extLst>
                   <a:ext uri="{0D108BD9-81ED-4DB2-BD59-A6C34878D82A}">
-                    <a16:rowId xmlns:a16="http://schemas.microsoft.com/office/drawing/2014/main" val="2483170892"/>
+                    <a16:rowId xmlns:a16="http://schemas.microsoft.com/office/drawing/2014/main" val="1469045471"/>
                   </a:ext>
                 </a:extLst>
               </a:tr>
@@ -11573,7 +11574,7 @@
           <p:cNvPr id="5" name="TextBox 4">
             <a:extLst>
               <a:ext uri="{FF2B5EF4-FFF2-40B4-BE49-F238E27FC236}">
-                <a16:creationId xmlns:a16="http://schemas.microsoft.com/office/drawing/2014/main" id="{DCC72B1F-FEDC-31C0-9FCD-44B5D42DBFE3}"/>
+                <a16:creationId xmlns:a16="http://schemas.microsoft.com/office/drawing/2014/main" id="{25929649-85DF-656F-1233-3B1ABD5CE6A9}"/>
               </a:ext>
             </a:extLst>
           </p:cNvPr>
@@ -11622,7 +11623,7 @@
     </p:spTree>
     <p:extLst>
       <p:ext uri="{BB962C8B-B14F-4D97-AF65-F5344CB8AC3E}">
-        <p14:creationId xmlns:p14="http://schemas.microsoft.com/office/powerpoint/2010/main" val="2859900055"/>
+        <p14:creationId xmlns:p14="http://schemas.microsoft.com/office/powerpoint/2010/main" val="1087379132"/>
       </p:ext>
     </p:extLst>
   </p:cSld>
@@ -11662,7 +11663,7 @@
           <p:cNvPr id="2" name="TextBox 1">
             <a:extLst>
               <a:ext uri="{FF2B5EF4-FFF2-40B4-BE49-F238E27FC236}">
-                <a16:creationId xmlns:a16="http://schemas.microsoft.com/office/drawing/2014/main" id="{07C51494-2FFB-E74B-9678-77831AEC3668}"/>
+                <a16:creationId xmlns:a16="http://schemas.microsoft.com/office/drawing/2014/main" id="{2091F8C8-7C62-6E2D-9524-47421FF211A0}"/>
               </a:ext>
             </a:extLst>
           </p:cNvPr>
@@ -11707,7 +11708,7 @@
           <p:cNvPr id="3" name="TextBox 2">
             <a:extLst>
               <a:ext uri="{FF2B5EF4-FFF2-40B4-BE49-F238E27FC236}">
-                <a16:creationId xmlns:a16="http://schemas.microsoft.com/office/drawing/2014/main" id="{8E3A65B4-3BCC-FD16-5C72-3964C57FB99A}"/>
+                <a16:creationId xmlns:a16="http://schemas.microsoft.com/office/drawing/2014/main" id="{05DCBBCF-54C1-807A-428D-88418711D99A}"/>
               </a:ext>
             </a:extLst>
           </p:cNvPr>
@@ -11752,7 +11753,7 @@
           <p:cNvPr id="4" name="TextBox 3">
             <a:extLst>
               <a:ext uri="{FF2B5EF4-FFF2-40B4-BE49-F238E27FC236}">
-                <a16:creationId xmlns:a16="http://schemas.microsoft.com/office/drawing/2014/main" id="{1CF80559-7CAC-57BB-691A-D1E3E5A65CFB}"/>
+                <a16:creationId xmlns:a16="http://schemas.microsoft.com/office/drawing/2014/main" id="{E7D30742-167B-A2A1-7783-2A08ED7AF8F3}"/>
               </a:ext>
             </a:extLst>
           </p:cNvPr>
@@ -11797,7 +11798,7 @@
           <p:cNvPr id="5" name="TextBox 4">
             <a:extLst>
               <a:ext uri="{FF2B5EF4-FFF2-40B4-BE49-F238E27FC236}">
-                <a16:creationId xmlns:a16="http://schemas.microsoft.com/office/drawing/2014/main" id="{919ACB6C-7088-57D6-ADDA-503FC81BE5D5}"/>
+                <a16:creationId xmlns:a16="http://schemas.microsoft.com/office/drawing/2014/main" id="{E1AC9CB2-75D5-B819-4F3F-F3605A388BFE}"/>
               </a:ext>
             </a:extLst>
           </p:cNvPr>
@@ -11851,7 +11852,7 @@
           <p:cNvPr id="6" name="TextBox 5">
             <a:extLst>
               <a:ext uri="{FF2B5EF4-FFF2-40B4-BE49-F238E27FC236}">
-                <a16:creationId xmlns:a16="http://schemas.microsoft.com/office/drawing/2014/main" id="{3C39627A-C4E0-816B-3C88-EFF85929C010}"/>
+                <a16:creationId xmlns:a16="http://schemas.microsoft.com/office/drawing/2014/main" id="{71F451C1-33DC-1025-F4B6-7D7702B3FB0F}"/>
               </a:ext>
             </a:extLst>
           </p:cNvPr>
@@ -11896,7 +11897,7 @@
           <p:cNvPr id="7" name="TextBox 6">
             <a:extLst>
               <a:ext uri="{FF2B5EF4-FFF2-40B4-BE49-F238E27FC236}">
-                <a16:creationId xmlns:a16="http://schemas.microsoft.com/office/drawing/2014/main" id="{D9F88D5D-AF6B-4BC7-4507-5850BB6FC428}"/>
+                <a16:creationId xmlns:a16="http://schemas.microsoft.com/office/drawing/2014/main" id="{FDCC20DB-C1C7-E704-2F27-600EA190089D}"/>
               </a:ext>
             </a:extLst>
           </p:cNvPr>
@@ -11944,7 +11945,7 @@
           <p:cNvPr id="8" name="TextBox 7">
             <a:extLst>
               <a:ext uri="{FF2B5EF4-FFF2-40B4-BE49-F238E27FC236}">
-                <a16:creationId xmlns:a16="http://schemas.microsoft.com/office/drawing/2014/main" id="{7BF3CBCB-1BB2-D66F-52A5-E3B6776C45A4}"/>
+                <a16:creationId xmlns:a16="http://schemas.microsoft.com/office/drawing/2014/main" id="{D1BD4FD2-AD49-97B2-5E03-17865C71D538}"/>
               </a:ext>
             </a:extLst>
           </p:cNvPr>
@@ -11995,7 +11996,7 @@
           <p:cNvPr id="9" name="TextBox 8">
             <a:extLst>
               <a:ext uri="{FF2B5EF4-FFF2-40B4-BE49-F238E27FC236}">
-                <a16:creationId xmlns:a16="http://schemas.microsoft.com/office/drawing/2014/main" id="{C6AA4A77-BA71-E315-86EE-747EDD78F5E7}"/>
+                <a16:creationId xmlns:a16="http://schemas.microsoft.com/office/drawing/2014/main" id="{B7DB259E-833A-225E-B803-7D082272AB2E}"/>
               </a:ext>
             </a:extLst>
           </p:cNvPr>
@@ -12044,7 +12045,7 @@
     </p:spTree>
     <p:extLst>
       <p:ext uri="{BB962C8B-B14F-4D97-AF65-F5344CB8AC3E}">
-        <p14:creationId xmlns:p14="http://schemas.microsoft.com/office/powerpoint/2010/main" val="2734396025"/>
+        <p14:creationId xmlns:p14="http://schemas.microsoft.com/office/powerpoint/2010/main" val="2673318268"/>
       </p:ext>
     </p:extLst>
   </p:cSld>
@@ -12084,7 +12085,7 @@
           <p:cNvPr id="2" name="TextBox 1">
             <a:extLst>
               <a:ext uri="{FF2B5EF4-FFF2-40B4-BE49-F238E27FC236}">
-                <a16:creationId xmlns:a16="http://schemas.microsoft.com/office/drawing/2014/main" id="{94688DC3-FD5D-957F-161D-88F9E459E531}"/>
+                <a16:creationId xmlns:a16="http://schemas.microsoft.com/office/drawing/2014/main" id="{097F149E-8ACA-454D-62E2-C8EA531E365E}"/>
               </a:ext>
             </a:extLst>
           </p:cNvPr>
@@ -12129,7 +12130,7 @@
           <p:cNvPr id="3" name="TextBox 2">
             <a:extLst>
               <a:ext uri="{FF2B5EF4-FFF2-40B4-BE49-F238E27FC236}">
-                <a16:creationId xmlns:a16="http://schemas.microsoft.com/office/drawing/2014/main" id="{E6DBC099-8538-2ABF-E809-F44E975EE6E2}"/>
+                <a16:creationId xmlns:a16="http://schemas.microsoft.com/office/drawing/2014/main" id="{47A5491E-A9E4-8D64-FD43-716BAE90F1CA}"/>
               </a:ext>
             </a:extLst>
           </p:cNvPr>
@@ -12174,7 +12175,7 @@
           <p:cNvPr id="4" name="TextBox 3">
             <a:extLst>
               <a:ext uri="{FF2B5EF4-FFF2-40B4-BE49-F238E27FC236}">
-                <a16:creationId xmlns:a16="http://schemas.microsoft.com/office/drawing/2014/main" id="{E87CD1DF-1589-1416-577F-CD16CA877528}"/>
+                <a16:creationId xmlns:a16="http://schemas.microsoft.com/office/drawing/2014/main" id="{6C5DF9A2-CD51-69F9-87CB-E92D38012726}"/>
               </a:ext>
             </a:extLst>
           </p:cNvPr>
@@ -12225,7 +12226,7 @@
           <p:cNvPr id="5" name="TextBox 4">
             <a:extLst>
               <a:ext uri="{FF2B5EF4-FFF2-40B4-BE49-F238E27FC236}">
-                <a16:creationId xmlns:a16="http://schemas.microsoft.com/office/drawing/2014/main" id="{CB03047E-9D90-8E80-5923-B99A74188FF5}"/>
+                <a16:creationId xmlns:a16="http://schemas.microsoft.com/office/drawing/2014/main" id="{44059607-9B1E-0436-B1C5-871E2354FDCC}"/>
               </a:ext>
             </a:extLst>
           </p:cNvPr>
@@ -12306,7 +12307,7 @@
     </p:spTree>
     <p:extLst>
       <p:ext uri="{BB962C8B-B14F-4D97-AF65-F5344CB8AC3E}">
-        <p14:creationId xmlns:p14="http://schemas.microsoft.com/office/powerpoint/2010/main" val="692365576"/>
+        <p14:creationId xmlns:p14="http://schemas.microsoft.com/office/powerpoint/2010/main" val="3348517082"/>
       </p:ext>
     </p:extLst>
   </p:cSld>
@@ -12346,7 +12347,7 @@
           <p:cNvPr id="2" name="TextBox 1">
             <a:extLst>
               <a:ext uri="{FF2B5EF4-FFF2-40B4-BE49-F238E27FC236}">
-                <a16:creationId xmlns:a16="http://schemas.microsoft.com/office/drawing/2014/main" id="{5280DB42-057B-93A0-5A85-4D6700AFC5D2}"/>
+                <a16:creationId xmlns:a16="http://schemas.microsoft.com/office/drawing/2014/main" id="{0B169434-A7AE-753E-7254-952D3161F0F2}"/>
               </a:ext>
             </a:extLst>
           </p:cNvPr>
@@ -12397,7 +12398,7 @@
           <p:cNvPr id="3" name="TextBox 2">
             <a:extLst>
               <a:ext uri="{FF2B5EF4-FFF2-40B4-BE49-F238E27FC236}">
-                <a16:creationId xmlns:a16="http://schemas.microsoft.com/office/drawing/2014/main" id="{C200138E-0E95-2D66-4509-85436BE4EEF7}"/>
+                <a16:creationId xmlns:a16="http://schemas.microsoft.com/office/drawing/2014/main" id="{FF781638-6315-AEE5-F2C6-A6EDD2516210}"/>
               </a:ext>
             </a:extLst>
           </p:cNvPr>
@@ -12442,7 +12443,7 @@
           <p:cNvPr id="4" name="Table 3">
             <a:extLst>
               <a:ext uri="{FF2B5EF4-FFF2-40B4-BE49-F238E27FC236}">
-                <a16:creationId xmlns:a16="http://schemas.microsoft.com/office/drawing/2014/main" id="{5B88A107-42FA-8904-282C-4B27808CD1F1}"/>
+                <a16:creationId xmlns:a16="http://schemas.microsoft.com/office/drawing/2014/main" id="{30BBD84E-D3FA-5685-D8CA-A4A852CC8690}"/>
               </a:ext>
             </a:extLst>
           </p:cNvPr>
@@ -12452,7 +12453,7 @@
           <p:nvPr>
             <p:extLst>
               <p:ext uri="{D42A27DB-BD31-4B8C-83A1-F6EECF244321}">
-                <p14:modId xmlns:p14="http://schemas.microsoft.com/office/powerpoint/2010/main" val="2160004769"/>
+                <p14:modId xmlns:p14="http://schemas.microsoft.com/office/powerpoint/2010/main" val="649249747"/>
               </p:ext>
             </p:extLst>
           </p:nvPr>
@@ -12471,35 +12472,35 @@
                 <a:gridCol w="3950208">
                   <a:extLst>
                     <a:ext uri="{9D8B030D-6E8A-4147-A177-3AD203B41FA5}">
-                      <a16:colId xmlns:a16="http://schemas.microsoft.com/office/drawing/2014/main" val="1287645323"/>
+                      <a16:colId xmlns:a16="http://schemas.microsoft.com/office/drawing/2014/main" val="3524154412"/>
                     </a:ext>
                   </a:extLst>
                 </a:gridCol>
                 <a:gridCol w="1755648">
                   <a:extLst>
                     <a:ext uri="{9D8B030D-6E8A-4147-A177-3AD203B41FA5}">
-                      <a16:colId xmlns:a16="http://schemas.microsoft.com/office/drawing/2014/main" val="1801595789"/>
+                      <a16:colId xmlns:a16="http://schemas.microsoft.com/office/drawing/2014/main" val="1410885501"/>
                     </a:ext>
                   </a:extLst>
                 </a:gridCol>
                 <a:gridCol w="1755648">
                   <a:extLst>
                     <a:ext uri="{9D8B030D-6E8A-4147-A177-3AD203B41FA5}">
-                      <a16:colId xmlns:a16="http://schemas.microsoft.com/office/drawing/2014/main" val="2206968401"/>
+                      <a16:colId xmlns:a16="http://schemas.microsoft.com/office/drawing/2014/main" val="1822260646"/>
                     </a:ext>
                   </a:extLst>
                 </a:gridCol>
                 <a:gridCol w="1755648">
                   <a:extLst>
                     <a:ext uri="{9D8B030D-6E8A-4147-A177-3AD203B41FA5}">
-                      <a16:colId xmlns:a16="http://schemas.microsoft.com/office/drawing/2014/main" val="265117453"/>
+                      <a16:colId xmlns:a16="http://schemas.microsoft.com/office/drawing/2014/main" val="1193437628"/>
                     </a:ext>
                   </a:extLst>
                 </a:gridCol>
                 <a:gridCol w="1755648">
                   <a:extLst>
                     <a:ext uri="{9D8B030D-6E8A-4147-A177-3AD203B41FA5}">
-                      <a16:colId xmlns:a16="http://schemas.microsoft.com/office/drawing/2014/main" val="1210121552"/>
+                      <a16:colId xmlns:a16="http://schemas.microsoft.com/office/drawing/2014/main" val="1462740971"/>
                     </a:ext>
                   </a:extLst>
                 </a:gridCol>
@@ -12617,7 +12618,7 @@
                 </a:tc>
                 <a:extLst>
                   <a:ext uri="{0D108BD9-81ED-4DB2-BD59-A6C34878D82A}">
-                    <a16:rowId xmlns:a16="http://schemas.microsoft.com/office/drawing/2014/main" val="2965938223"/>
+                    <a16:rowId xmlns:a16="http://schemas.microsoft.com/office/drawing/2014/main" val="3239752177"/>
                   </a:ext>
                 </a:extLst>
               </a:tr>
@@ -12734,7 +12735,7 @@
                 </a:tc>
                 <a:extLst>
                   <a:ext uri="{0D108BD9-81ED-4DB2-BD59-A6C34878D82A}">
-                    <a16:rowId xmlns:a16="http://schemas.microsoft.com/office/drawing/2014/main" val="3680230307"/>
+                    <a16:rowId xmlns:a16="http://schemas.microsoft.com/office/drawing/2014/main" val="1778793732"/>
                   </a:ext>
                 </a:extLst>
               </a:tr>
@@ -12851,7 +12852,7 @@
                 </a:tc>
                 <a:extLst>
                   <a:ext uri="{0D108BD9-81ED-4DB2-BD59-A6C34878D82A}">
-                    <a16:rowId xmlns:a16="http://schemas.microsoft.com/office/drawing/2014/main" val="2063857680"/>
+                    <a16:rowId xmlns:a16="http://schemas.microsoft.com/office/drawing/2014/main" val="2468347477"/>
                   </a:ext>
                 </a:extLst>
               </a:tr>
@@ -12968,7 +12969,7 @@
                 </a:tc>
                 <a:extLst>
                   <a:ext uri="{0D108BD9-81ED-4DB2-BD59-A6C34878D82A}">
-                    <a16:rowId xmlns:a16="http://schemas.microsoft.com/office/drawing/2014/main" val="2581080820"/>
+                    <a16:rowId xmlns:a16="http://schemas.microsoft.com/office/drawing/2014/main" val="1546717429"/>
                   </a:ext>
                 </a:extLst>
               </a:tr>
@@ -13085,7 +13086,7 @@
                 </a:tc>
                 <a:extLst>
                   <a:ext uri="{0D108BD9-81ED-4DB2-BD59-A6C34878D82A}">
-                    <a16:rowId xmlns:a16="http://schemas.microsoft.com/office/drawing/2014/main" val="798114905"/>
+                    <a16:rowId xmlns:a16="http://schemas.microsoft.com/office/drawing/2014/main" val="773582041"/>
                   </a:ext>
                 </a:extLst>
               </a:tr>
@@ -13098,7 +13099,7 @@
           <p:cNvPr id="5" name="TextBox 4">
             <a:extLst>
               <a:ext uri="{FF2B5EF4-FFF2-40B4-BE49-F238E27FC236}">
-                <a16:creationId xmlns:a16="http://schemas.microsoft.com/office/drawing/2014/main" id="{036012E2-CD42-32BA-A7E9-BF7DDFDAB200}"/>
+                <a16:creationId xmlns:a16="http://schemas.microsoft.com/office/drawing/2014/main" id="{FEF81A1E-F921-90DF-12D9-7E034664F243}"/>
               </a:ext>
             </a:extLst>
           </p:cNvPr>
@@ -13143,7 +13144,7 @@
           <p:cNvPr id="6" name="TextBox 5">
             <a:extLst>
               <a:ext uri="{FF2B5EF4-FFF2-40B4-BE49-F238E27FC236}">
-                <a16:creationId xmlns:a16="http://schemas.microsoft.com/office/drawing/2014/main" id="{FF028D2D-0CEC-9CDE-3DA7-8E19828E9216}"/>
+                <a16:creationId xmlns:a16="http://schemas.microsoft.com/office/drawing/2014/main" id="{E8F66940-6B1A-D456-056F-A3E0C5F7DCB6}"/>
               </a:ext>
             </a:extLst>
           </p:cNvPr>
@@ -13194,7 +13195,7 @@
           <p:cNvPr id="7" name="TextBox 6">
             <a:extLst>
               <a:ext uri="{FF2B5EF4-FFF2-40B4-BE49-F238E27FC236}">
-                <a16:creationId xmlns:a16="http://schemas.microsoft.com/office/drawing/2014/main" id="{F94D37D9-F118-846A-25A9-974A1F11984E}"/>
+                <a16:creationId xmlns:a16="http://schemas.microsoft.com/office/drawing/2014/main" id="{1614BB79-12B5-A891-B998-FD2F19917C06}"/>
               </a:ext>
             </a:extLst>
           </p:cNvPr>
@@ -13244,7 +13245,7 @@
     </p:spTree>
     <p:extLst>
       <p:ext uri="{BB962C8B-B14F-4D97-AF65-F5344CB8AC3E}">
-        <p14:creationId xmlns:p14="http://schemas.microsoft.com/office/powerpoint/2010/main" val="3122438516"/>
+        <p14:creationId xmlns:p14="http://schemas.microsoft.com/office/powerpoint/2010/main" val="2553043819"/>
       </p:ext>
     </p:extLst>
   </p:cSld>
@@ -13284,7 +13285,7 @@
           <p:cNvPr id="2" name="TextBox 1">
             <a:extLst>
               <a:ext uri="{FF2B5EF4-FFF2-40B4-BE49-F238E27FC236}">
-                <a16:creationId xmlns:a16="http://schemas.microsoft.com/office/drawing/2014/main" id="{2F9F70F2-1658-0701-A6E4-7AAF9E51C8B3}"/>
+                <a16:creationId xmlns:a16="http://schemas.microsoft.com/office/drawing/2014/main" id="{E38DDA63-65CD-64DB-119E-F7793702C5B9}"/>
               </a:ext>
             </a:extLst>
           </p:cNvPr>
@@ -13335,7 +13336,7 @@
           <p:cNvPr id="3" name="TextBox 2">
             <a:extLst>
               <a:ext uri="{FF2B5EF4-FFF2-40B4-BE49-F238E27FC236}">
-                <a16:creationId xmlns:a16="http://schemas.microsoft.com/office/drawing/2014/main" id="{BCBAF8E4-DAE8-E1D5-BB63-1927D857E3B8}"/>
+                <a16:creationId xmlns:a16="http://schemas.microsoft.com/office/drawing/2014/main" id="{C1D76C15-0A70-D15F-F3F0-91F519E4BE6D}"/>
               </a:ext>
             </a:extLst>
           </p:cNvPr>
@@ -13380,7 +13381,7 @@
           <p:cNvPr id="4" name="Table 3">
             <a:extLst>
               <a:ext uri="{FF2B5EF4-FFF2-40B4-BE49-F238E27FC236}">
-                <a16:creationId xmlns:a16="http://schemas.microsoft.com/office/drawing/2014/main" id="{94E83E3F-A893-C10E-0FA8-2AE749464F9E}"/>
+                <a16:creationId xmlns:a16="http://schemas.microsoft.com/office/drawing/2014/main" id="{581E48DE-A050-192E-DAD2-C860B86C4FC3}"/>
               </a:ext>
             </a:extLst>
           </p:cNvPr>
@@ -13390,7 +13391,7 @@
           <p:nvPr>
             <p:extLst>
               <p:ext uri="{D42A27DB-BD31-4B8C-83A1-F6EECF244321}">
-                <p14:modId xmlns:p14="http://schemas.microsoft.com/office/powerpoint/2010/main" val="1327209385"/>
+                <p14:modId xmlns:p14="http://schemas.microsoft.com/office/powerpoint/2010/main" val="1171025875"/>
               </p:ext>
             </p:extLst>
           </p:nvPr>
@@ -13409,56 +13410,56 @@
                 <a:gridCol w="1584960">
                   <a:extLst>
                     <a:ext uri="{9D8B030D-6E8A-4147-A177-3AD203B41FA5}">
-                      <a16:colId xmlns:a16="http://schemas.microsoft.com/office/drawing/2014/main" val="2715082950"/>
+                      <a16:colId xmlns:a16="http://schemas.microsoft.com/office/drawing/2014/main" val="2075132339"/>
                     </a:ext>
                   </a:extLst>
                 </a:gridCol>
                 <a:gridCol w="717006">
                   <a:extLst>
                     <a:ext uri="{9D8B030D-6E8A-4147-A177-3AD203B41FA5}">
-                      <a16:colId xmlns:a16="http://schemas.microsoft.com/office/drawing/2014/main" val="3407961996"/>
+                      <a16:colId xmlns:a16="http://schemas.microsoft.com/office/drawing/2014/main" val="2504642742"/>
                     </a:ext>
                   </a:extLst>
                 </a:gridCol>
                 <a:gridCol w="717006">
                   <a:extLst>
                     <a:ext uri="{9D8B030D-6E8A-4147-A177-3AD203B41FA5}">
-                      <a16:colId xmlns:a16="http://schemas.microsoft.com/office/drawing/2014/main" val="4261590597"/>
+                      <a16:colId xmlns:a16="http://schemas.microsoft.com/office/drawing/2014/main" val="1951022659"/>
                     </a:ext>
                   </a:extLst>
                 </a:gridCol>
                 <a:gridCol w="717006">
                   <a:extLst>
                     <a:ext uri="{9D8B030D-6E8A-4147-A177-3AD203B41FA5}">
-                      <a16:colId xmlns:a16="http://schemas.microsoft.com/office/drawing/2014/main" val="3958344650"/>
+                      <a16:colId xmlns:a16="http://schemas.microsoft.com/office/drawing/2014/main" val="319813761"/>
                     </a:ext>
                   </a:extLst>
                 </a:gridCol>
                 <a:gridCol w="717006">
                   <a:extLst>
                     <a:ext uri="{9D8B030D-6E8A-4147-A177-3AD203B41FA5}">
-                      <a16:colId xmlns:a16="http://schemas.microsoft.com/office/drawing/2014/main" val="99529858"/>
+                      <a16:colId xmlns:a16="http://schemas.microsoft.com/office/drawing/2014/main" val="375247295"/>
                     </a:ext>
                   </a:extLst>
                 </a:gridCol>
                 <a:gridCol w="717006">
                   <a:extLst>
                     <a:ext uri="{9D8B030D-6E8A-4147-A177-3AD203B41FA5}">
-                      <a16:colId xmlns:a16="http://schemas.microsoft.com/office/drawing/2014/main" val="1691453584"/>
+                      <a16:colId xmlns:a16="http://schemas.microsoft.com/office/drawing/2014/main" val="2255226207"/>
                     </a:ext>
                   </a:extLst>
                 </a:gridCol>
                 <a:gridCol w="717006">
                   <a:extLst>
                     <a:ext uri="{9D8B030D-6E8A-4147-A177-3AD203B41FA5}">
-                      <a16:colId xmlns:a16="http://schemas.microsoft.com/office/drawing/2014/main" val="342602242"/>
+                      <a16:colId xmlns:a16="http://schemas.microsoft.com/office/drawing/2014/main" val="2164332006"/>
                     </a:ext>
                   </a:extLst>
                 </a:gridCol>
                 <a:gridCol w="717006">
                   <a:extLst>
                     <a:ext uri="{9D8B030D-6E8A-4147-A177-3AD203B41FA5}">
-                      <a16:colId xmlns:a16="http://schemas.microsoft.com/office/drawing/2014/main" val="42534539"/>
+                      <a16:colId xmlns:a16="http://schemas.microsoft.com/office/drawing/2014/main" val="3686009805"/>
                     </a:ext>
                   </a:extLst>
                 </a:gridCol>
@@ -13642,7 +13643,7 @@
                 </a:tc>
                 <a:extLst>
                   <a:ext uri="{0D108BD9-81ED-4DB2-BD59-A6C34878D82A}">
-                    <a16:rowId xmlns:a16="http://schemas.microsoft.com/office/drawing/2014/main" val="2636982203"/>
+                    <a16:rowId xmlns:a16="http://schemas.microsoft.com/office/drawing/2014/main" val="4289828238"/>
                   </a:ext>
                 </a:extLst>
               </a:tr>
@@ -13832,7 +13833,7 @@
                 </a:tc>
                 <a:extLst>
                   <a:ext uri="{0D108BD9-81ED-4DB2-BD59-A6C34878D82A}">
-                    <a16:rowId xmlns:a16="http://schemas.microsoft.com/office/drawing/2014/main" val="1924165171"/>
+                    <a16:rowId xmlns:a16="http://schemas.microsoft.com/office/drawing/2014/main" val="1371416809"/>
                   </a:ext>
                 </a:extLst>
               </a:tr>
@@ -14022,7 +14023,7 @@
                 </a:tc>
                 <a:extLst>
                   <a:ext uri="{0D108BD9-81ED-4DB2-BD59-A6C34878D82A}">
-                    <a16:rowId xmlns:a16="http://schemas.microsoft.com/office/drawing/2014/main" val="2002559535"/>
+                    <a16:rowId xmlns:a16="http://schemas.microsoft.com/office/drawing/2014/main" val="1100631945"/>
                   </a:ext>
                 </a:extLst>
               </a:tr>
@@ -14212,7 +14213,7 @@
                 </a:tc>
                 <a:extLst>
                   <a:ext uri="{0D108BD9-81ED-4DB2-BD59-A6C34878D82A}">
-                    <a16:rowId xmlns:a16="http://schemas.microsoft.com/office/drawing/2014/main" val="4148453169"/>
+                    <a16:rowId xmlns:a16="http://schemas.microsoft.com/office/drawing/2014/main" val="371121278"/>
                   </a:ext>
                 </a:extLst>
               </a:tr>
@@ -14402,7 +14403,7 @@
                 </a:tc>
                 <a:extLst>
                   <a:ext uri="{0D108BD9-81ED-4DB2-BD59-A6C34878D82A}">
-                    <a16:rowId xmlns:a16="http://schemas.microsoft.com/office/drawing/2014/main" val="438379334"/>
+                    <a16:rowId xmlns:a16="http://schemas.microsoft.com/office/drawing/2014/main" val="4112889142"/>
                   </a:ext>
                 </a:extLst>
               </a:tr>
@@ -14592,7 +14593,7 @@
                 </a:tc>
                 <a:extLst>
                   <a:ext uri="{0D108BD9-81ED-4DB2-BD59-A6C34878D82A}">
-                    <a16:rowId xmlns:a16="http://schemas.microsoft.com/office/drawing/2014/main" val="1476248934"/>
+                    <a16:rowId xmlns:a16="http://schemas.microsoft.com/office/drawing/2014/main" val="570115327"/>
                   </a:ext>
                 </a:extLst>
               </a:tr>
@@ -14782,7 +14783,7 @@
                 </a:tc>
                 <a:extLst>
                   <a:ext uri="{0D108BD9-81ED-4DB2-BD59-A6C34878D82A}">
-                    <a16:rowId xmlns:a16="http://schemas.microsoft.com/office/drawing/2014/main" val="2067993597"/>
+                    <a16:rowId xmlns:a16="http://schemas.microsoft.com/office/drawing/2014/main" val="716437064"/>
                   </a:ext>
                 </a:extLst>
               </a:tr>
@@ -14972,7 +14973,7 @@
                 </a:tc>
                 <a:extLst>
                   <a:ext uri="{0D108BD9-81ED-4DB2-BD59-A6C34878D82A}">
-                    <a16:rowId xmlns:a16="http://schemas.microsoft.com/office/drawing/2014/main" val="3275935473"/>
+                    <a16:rowId xmlns:a16="http://schemas.microsoft.com/office/drawing/2014/main" val="3204047109"/>
                   </a:ext>
                 </a:extLst>
               </a:tr>
@@ -14985,7 +14986,7 @@
           <p:cNvPr id="5" name="Table 4">
             <a:extLst>
               <a:ext uri="{FF2B5EF4-FFF2-40B4-BE49-F238E27FC236}">
-                <a16:creationId xmlns:a16="http://schemas.microsoft.com/office/drawing/2014/main" id="{5960BAFD-928D-9FEB-84E6-1E2DBCCD4FF2}"/>
+                <a16:creationId xmlns:a16="http://schemas.microsoft.com/office/drawing/2014/main" id="{935B0703-A65A-B1B3-91E5-8985F187ABF8}"/>
               </a:ext>
             </a:extLst>
           </p:cNvPr>
@@ -14995,7 +14996,7 @@
           <p:nvPr>
             <p:extLst>
               <p:ext uri="{D42A27DB-BD31-4B8C-83A1-F6EECF244321}">
-                <p14:modId xmlns:p14="http://schemas.microsoft.com/office/powerpoint/2010/main" val="3949053906"/>
+                <p14:modId xmlns:p14="http://schemas.microsoft.com/office/powerpoint/2010/main" val="1136556255"/>
               </p:ext>
             </p:extLst>
           </p:nvPr>
@@ -15014,28 +15015,28 @@
                 <a:gridCol w="1437894">
                   <a:extLst>
                     <a:ext uri="{9D8B030D-6E8A-4147-A177-3AD203B41FA5}">
-                      <a16:colId xmlns:a16="http://schemas.microsoft.com/office/drawing/2014/main" val="2454835610"/>
+                      <a16:colId xmlns:a16="http://schemas.microsoft.com/office/drawing/2014/main" val="2298080938"/>
                     </a:ext>
                   </a:extLst>
                 </a:gridCol>
                 <a:gridCol w="930402">
                   <a:extLst>
                     <a:ext uri="{9D8B030D-6E8A-4147-A177-3AD203B41FA5}">
-                      <a16:colId xmlns:a16="http://schemas.microsoft.com/office/drawing/2014/main" val="1312591844"/>
+                      <a16:colId xmlns:a16="http://schemas.microsoft.com/office/drawing/2014/main" val="1351918673"/>
                     </a:ext>
                   </a:extLst>
                 </a:gridCol>
                 <a:gridCol w="930402">
                   <a:extLst>
                     <a:ext uri="{9D8B030D-6E8A-4147-A177-3AD203B41FA5}">
-                      <a16:colId xmlns:a16="http://schemas.microsoft.com/office/drawing/2014/main" val="166808978"/>
+                      <a16:colId xmlns:a16="http://schemas.microsoft.com/office/drawing/2014/main" val="2192284167"/>
                     </a:ext>
                   </a:extLst>
                 </a:gridCol>
                 <a:gridCol w="930402">
                   <a:extLst>
                     <a:ext uri="{9D8B030D-6E8A-4147-A177-3AD203B41FA5}">
-                      <a16:colId xmlns:a16="http://schemas.microsoft.com/office/drawing/2014/main" val="3557439775"/>
+                      <a16:colId xmlns:a16="http://schemas.microsoft.com/office/drawing/2014/main" val="19455310"/>
                     </a:ext>
                   </a:extLst>
                 </a:gridCol>
@@ -15131,7 +15132,7 @@
                 </a:tc>
                 <a:extLst>
                   <a:ext uri="{0D108BD9-81ED-4DB2-BD59-A6C34878D82A}">
-                    <a16:rowId xmlns:a16="http://schemas.microsoft.com/office/drawing/2014/main" val="1923036738"/>
+                    <a16:rowId xmlns:a16="http://schemas.microsoft.com/office/drawing/2014/main" val="78929299"/>
                   </a:ext>
                 </a:extLst>
               </a:tr>
@@ -15226,7 +15227,7 @@
                 </a:tc>
                 <a:extLst>
                   <a:ext uri="{0D108BD9-81ED-4DB2-BD59-A6C34878D82A}">
-                    <a16:rowId xmlns:a16="http://schemas.microsoft.com/office/drawing/2014/main" val="1291286459"/>
+                    <a16:rowId xmlns:a16="http://schemas.microsoft.com/office/drawing/2014/main" val="1561364316"/>
                   </a:ext>
                 </a:extLst>
               </a:tr>
@@ -15321,7 +15322,7 @@
                 </a:tc>
                 <a:extLst>
                   <a:ext uri="{0D108BD9-81ED-4DB2-BD59-A6C34878D82A}">
-                    <a16:rowId xmlns:a16="http://schemas.microsoft.com/office/drawing/2014/main" val="1898136898"/>
+                    <a16:rowId xmlns:a16="http://schemas.microsoft.com/office/drawing/2014/main" val="1770491697"/>
                   </a:ext>
                 </a:extLst>
               </a:tr>
@@ -15416,7 +15417,7 @@
                 </a:tc>
                 <a:extLst>
                   <a:ext uri="{0D108BD9-81ED-4DB2-BD59-A6C34878D82A}">
-                    <a16:rowId xmlns:a16="http://schemas.microsoft.com/office/drawing/2014/main" val="1898726619"/>
+                    <a16:rowId xmlns:a16="http://schemas.microsoft.com/office/drawing/2014/main" val="2244667597"/>
                   </a:ext>
                 </a:extLst>
               </a:tr>
@@ -15511,7 +15512,7 @@
                 </a:tc>
                 <a:extLst>
                   <a:ext uri="{0D108BD9-81ED-4DB2-BD59-A6C34878D82A}">
-                    <a16:rowId xmlns:a16="http://schemas.microsoft.com/office/drawing/2014/main" val="729248688"/>
+                    <a16:rowId xmlns:a16="http://schemas.microsoft.com/office/drawing/2014/main" val="2241191354"/>
                   </a:ext>
                 </a:extLst>
               </a:tr>
@@ -15606,7 +15607,7 @@
                 </a:tc>
                 <a:extLst>
                   <a:ext uri="{0D108BD9-81ED-4DB2-BD59-A6C34878D82A}">
-                    <a16:rowId xmlns:a16="http://schemas.microsoft.com/office/drawing/2014/main" val="3894173314"/>
+                    <a16:rowId xmlns:a16="http://schemas.microsoft.com/office/drawing/2014/main" val="1027938047"/>
                   </a:ext>
                 </a:extLst>
               </a:tr>
@@ -15701,7 +15702,7 @@
                 </a:tc>
                 <a:extLst>
                   <a:ext uri="{0D108BD9-81ED-4DB2-BD59-A6C34878D82A}">
-                    <a16:rowId xmlns:a16="http://schemas.microsoft.com/office/drawing/2014/main" val="2580529309"/>
+                    <a16:rowId xmlns:a16="http://schemas.microsoft.com/office/drawing/2014/main" val="2162683470"/>
                   </a:ext>
                 </a:extLst>
               </a:tr>
@@ -15796,7 +15797,7 @@
                 </a:tc>
                 <a:extLst>
                   <a:ext uri="{0D108BD9-81ED-4DB2-BD59-A6C34878D82A}">
-                    <a16:rowId xmlns:a16="http://schemas.microsoft.com/office/drawing/2014/main" val="2774581049"/>
+                    <a16:rowId xmlns:a16="http://schemas.microsoft.com/office/drawing/2014/main" val="2984071613"/>
                   </a:ext>
                 </a:extLst>
               </a:tr>
@@ -15809,7 +15810,7 @@
           <p:cNvPr id="6" name="TextBox 5">
             <a:extLst>
               <a:ext uri="{FF2B5EF4-FFF2-40B4-BE49-F238E27FC236}">
-                <a16:creationId xmlns:a16="http://schemas.microsoft.com/office/drawing/2014/main" id="{A4BC7B67-2277-6C15-43EC-3E43258C00F7}"/>
+                <a16:creationId xmlns:a16="http://schemas.microsoft.com/office/drawing/2014/main" id="{EE4E320F-B827-C373-2CE2-DF660007FB52}"/>
               </a:ext>
             </a:extLst>
           </p:cNvPr>
@@ -15860,7 +15861,7 @@
           <p:cNvPr id="7" name="TextBox 6">
             <a:extLst>
               <a:ext uri="{FF2B5EF4-FFF2-40B4-BE49-F238E27FC236}">
-                <a16:creationId xmlns:a16="http://schemas.microsoft.com/office/drawing/2014/main" id="{C20D33A3-1F03-2EBC-6C9A-BDED4A577D35}"/>
+                <a16:creationId xmlns:a16="http://schemas.microsoft.com/office/drawing/2014/main" id="{43A7F3AA-9B0B-C757-F08E-5AC900817AEB}"/>
               </a:ext>
             </a:extLst>
           </p:cNvPr>
@@ -15905,7 +15906,7 @@
           <p:cNvPr id="8" name="TextBox 7">
             <a:extLst>
               <a:ext uri="{FF2B5EF4-FFF2-40B4-BE49-F238E27FC236}">
-                <a16:creationId xmlns:a16="http://schemas.microsoft.com/office/drawing/2014/main" id="{36FB96D1-D2DF-E964-1AA3-7FE2DC569685}"/>
+                <a16:creationId xmlns:a16="http://schemas.microsoft.com/office/drawing/2014/main" id="{3D4C13FE-E112-25F8-27B0-EEF53AA19D1C}"/>
               </a:ext>
             </a:extLst>
           </p:cNvPr>
@@ -15956,7 +15957,7 @@
           <p:cNvPr id="9" name="TextBox 8">
             <a:extLst>
               <a:ext uri="{FF2B5EF4-FFF2-40B4-BE49-F238E27FC236}">
-                <a16:creationId xmlns:a16="http://schemas.microsoft.com/office/drawing/2014/main" id="{509C9231-3729-3319-67E7-52770A201A65}"/>
+                <a16:creationId xmlns:a16="http://schemas.microsoft.com/office/drawing/2014/main" id="{E022CAA2-5A47-BA2B-DCB4-1B7C6859ABAA}"/>
               </a:ext>
             </a:extLst>
           </p:cNvPr>
@@ -16005,7 +16006,7 @@
     </p:spTree>
     <p:extLst>
       <p:ext uri="{BB962C8B-B14F-4D97-AF65-F5344CB8AC3E}">
-        <p14:creationId xmlns:p14="http://schemas.microsoft.com/office/powerpoint/2010/main" val="306408192"/>
+        <p14:creationId xmlns:p14="http://schemas.microsoft.com/office/powerpoint/2010/main" val="570693752"/>
       </p:ext>
     </p:extLst>
   </p:cSld>
@@ -16045,7 +16046,7 @@
           <p:cNvPr id="2" name="TextBox 1">
             <a:extLst>
               <a:ext uri="{FF2B5EF4-FFF2-40B4-BE49-F238E27FC236}">
-                <a16:creationId xmlns:a16="http://schemas.microsoft.com/office/drawing/2014/main" id="{2795A164-9597-8CD5-E296-55503A658442}"/>
+                <a16:creationId xmlns:a16="http://schemas.microsoft.com/office/drawing/2014/main" id="{61AE863F-7572-BA80-4348-2F74B109C45B}"/>
               </a:ext>
             </a:extLst>
           </p:cNvPr>
@@ -16090,7 +16091,7 @@
           <p:cNvPr id="3" name="TextBox 2">
             <a:extLst>
               <a:ext uri="{FF2B5EF4-FFF2-40B4-BE49-F238E27FC236}">
-                <a16:creationId xmlns:a16="http://schemas.microsoft.com/office/drawing/2014/main" id="{133AA931-10EB-ADA7-09B9-CC4D8D0E9D58}"/>
+                <a16:creationId xmlns:a16="http://schemas.microsoft.com/office/drawing/2014/main" id="{FDAFD808-4D61-8FA5-2245-D4D164C648DD}"/>
               </a:ext>
             </a:extLst>
           </p:cNvPr>
@@ -16135,7 +16136,7 @@
           <p:cNvPr id="5" name="Picture 4">
             <a:extLst>
               <a:ext uri="{FF2B5EF4-FFF2-40B4-BE49-F238E27FC236}">
-                <a16:creationId xmlns:a16="http://schemas.microsoft.com/office/drawing/2014/main" id="{304D09C4-C7D7-FAEB-C5C5-F5647920A440}"/>
+                <a16:creationId xmlns:a16="http://schemas.microsoft.com/office/drawing/2014/main" id="{D41799D9-7DCF-35B8-12A3-EDFCC693A99D}"/>
               </a:ext>
             </a:extLst>
           </p:cNvPr>
@@ -16171,7 +16172,7 @@
           <p:cNvPr id="6" name="TextBox 5">
             <a:extLst>
               <a:ext uri="{FF2B5EF4-FFF2-40B4-BE49-F238E27FC236}">
-                <a16:creationId xmlns:a16="http://schemas.microsoft.com/office/drawing/2014/main" id="{BF663FCF-57B3-9154-3CD4-DAFE33931493}"/>
+                <a16:creationId xmlns:a16="http://schemas.microsoft.com/office/drawing/2014/main" id="{595FE17A-7998-EB42-80AA-AFA3984EF6F0}"/>
               </a:ext>
             </a:extLst>
           </p:cNvPr>
@@ -16216,7 +16217,7 @@
           <p:cNvPr id="7" name="TextBox 6">
             <a:extLst>
               <a:ext uri="{FF2B5EF4-FFF2-40B4-BE49-F238E27FC236}">
-                <a16:creationId xmlns:a16="http://schemas.microsoft.com/office/drawing/2014/main" id="{1879A0DE-8BA3-2AD2-3855-FA533420659E}"/>
+                <a16:creationId xmlns:a16="http://schemas.microsoft.com/office/drawing/2014/main" id="{C5AA0F2D-023A-99DD-2504-91D4FC7B3A6F}"/>
               </a:ext>
             </a:extLst>
           </p:cNvPr>
@@ -16261,7 +16262,7 @@
           <p:cNvPr id="8" name="TextBox 7">
             <a:extLst>
               <a:ext uri="{FF2B5EF4-FFF2-40B4-BE49-F238E27FC236}">
-                <a16:creationId xmlns:a16="http://schemas.microsoft.com/office/drawing/2014/main" id="{3F8D7B92-3C61-819B-A494-5E2ECCB23D8A}"/>
+                <a16:creationId xmlns:a16="http://schemas.microsoft.com/office/drawing/2014/main" id="{A13F4364-A497-4711-609E-E8ED719B54D4}"/>
               </a:ext>
             </a:extLst>
           </p:cNvPr>
@@ -16306,7 +16307,7 @@
           <p:cNvPr id="10" name="Picture 9">
             <a:extLst>
               <a:ext uri="{FF2B5EF4-FFF2-40B4-BE49-F238E27FC236}">
-                <a16:creationId xmlns:a16="http://schemas.microsoft.com/office/drawing/2014/main" id="{63D4F075-24D3-6DFD-FCDF-22378D2F6EA5}"/>
+                <a16:creationId xmlns:a16="http://schemas.microsoft.com/office/drawing/2014/main" id="{E2880E09-9A1B-B27C-B5E8-B6A637F5D1F5}"/>
               </a:ext>
             </a:extLst>
           </p:cNvPr>
@@ -16342,7 +16343,7 @@
           <p:cNvPr id="11" name="TextBox 10">
             <a:extLst>
               <a:ext uri="{FF2B5EF4-FFF2-40B4-BE49-F238E27FC236}">
-                <a16:creationId xmlns:a16="http://schemas.microsoft.com/office/drawing/2014/main" id="{5C6AE7D8-C2CD-41F6-4314-ED6BF88292AE}"/>
+                <a16:creationId xmlns:a16="http://schemas.microsoft.com/office/drawing/2014/main" id="{D953FCE6-90C7-11CD-CD29-DFCF77D36569}"/>
               </a:ext>
             </a:extLst>
           </p:cNvPr>
@@ -16387,7 +16388,7 @@
           <p:cNvPr id="12" name="TextBox 11">
             <a:extLst>
               <a:ext uri="{FF2B5EF4-FFF2-40B4-BE49-F238E27FC236}">
-                <a16:creationId xmlns:a16="http://schemas.microsoft.com/office/drawing/2014/main" id="{B34EFB1B-E6E6-EDF7-D66A-07EBAA77CF7D}"/>
+                <a16:creationId xmlns:a16="http://schemas.microsoft.com/office/drawing/2014/main" id="{8B015249-AA48-0ABF-9D99-30BFC4B0995A}"/>
               </a:ext>
             </a:extLst>
           </p:cNvPr>
@@ -16432,7 +16433,7 @@
           <p:cNvPr id="13" name="TextBox 12">
             <a:extLst>
               <a:ext uri="{FF2B5EF4-FFF2-40B4-BE49-F238E27FC236}">
-                <a16:creationId xmlns:a16="http://schemas.microsoft.com/office/drawing/2014/main" id="{B6211425-3BB0-DB9A-2553-416FC3347E09}"/>
+                <a16:creationId xmlns:a16="http://schemas.microsoft.com/office/drawing/2014/main" id="{A3CCAE77-ACEA-24A7-773D-31450E43264C}"/>
               </a:ext>
             </a:extLst>
           </p:cNvPr>
@@ -16477,7 +16478,7 @@
           <p:cNvPr id="15" name="Picture 14">
             <a:extLst>
               <a:ext uri="{FF2B5EF4-FFF2-40B4-BE49-F238E27FC236}">
-                <a16:creationId xmlns:a16="http://schemas.microsoft.com/office/drawing/2014/main" id="{646378AE-BFED-1067-76E1-0D4716817926}"/>
+                <a16:creationId xmlns:a16="http://schemas.microsoft.com/office/drawing/2014/main" id="{74642ED5-CB12-8C02-9003-5A9FF0B3CA19}"/>
               </a:ext>
             </a:extLst>
           </p:cNvPr>
@@ -16513,7 +16514,7 @@
           <p:cNvPr id="16" name="TextBox 15">
             <a:extLst>
               <a:ext uri="{FF2B5EF4-FFF2-40B4-BE49-F238E27FC236}">
-                <a16:creationId xmlns:a16="http://schemas.microsoft.com/office/drawing/2014/main" id="{87FB62BB-7FC8-DDB6-DB13-3F4F40A1CDA2}"/>
+                <a16:creationId xmlns:a16="http://schemas.microsoft.com/office/drawing/2014/main" id="{5C96E212-71A6-8C75-1216-1567D6E68B04}"/>
               </a:ext>
             </a:extLst>
           </p:cNvPr>
@@ -16558,7 +16559,7 @@
           <p:cNvPr id="17" name="TextBox 16">
             <a:extLst>
               <a:ext uri="{FF2B5EF4-FFF2-40B4-BE49-F238E27FC236}">
-                <a16:creationId xmlns:a16="http://schemas.microsoft.com/office/drawing/2014/main" id="{14BA968D-0F81-34A0-9CAC-B2136E3D2FC0}"/>
+                <a16:creationId xmlns:a16="http://schemas.microsoft.com/office/drawing/2014/main" id="{1A6A32EF-CC52-98DC-25E8-8587F10FB7A5}"/>
               </a:ext>
             </a:extLst>
           </p:cNvPr>
@@ -16603,7 +16604,7 @@
           <p:cNvPr id="18" name="TextBox 17">
             <a:extLst>
               <a:ext uri="{FF2B5EF4-FFF2-40B4-BE49-F238E27FC236}">
-                <a16:creationId xmlns:a16="http://schemas.microsoft.com/office/drawing/2014/main" id="{397D0F80-7A41-18FF-1BB5-7374899F9421}"/>
+                <a16:creationId xmlns:a16="http://schemas.microsoft.com/office/drawing/2014/main" id="{5BA8E716-524F-0780-3141-217793085AED}"/>
               </a:ext>
             </a:extLst>
           </p:cNvPr>
@@ -16648,7 +16649,7 @@
           <p:cNvPr id="20" name="Picture 19">
             <a:extLst>
               <a:ext uri="{FF2B5EF4-FFF2-40B4-BE49-F238E27FC236}">
-                <a16:creationId xmlns:a16="http://schemas.microsoft.com/office/drawing/2014/main" id="{5D9E540E-5201-6006-A1EB-D046CA119051}"/>
+                <a16:creationId xmlns:a16="http://schemas.microsoft.com/office/drawing/2014/main" id="{9C7B279E-2190-5A50-17F6-E9217271844C}"/>
               </a:ext>
             </a:extLst>
           </p:cNvPr>
@@ -16684,7 +16685,7 @@
           <p:cNvPr id="21" name="TextBox 20">
             <a:extLst>
               <a:ext uri="{FF2B5EF4-FFF2-40B4-BE49-F238E27FC236}">
-                <a16:creationId xmlns:a16="http://schemas.microsoft.com/office/drawing/2014/main" id="{88EE9EF4-D7D0-1985-BBF4-E63EE288440B}"/>
+                <a16:creationId xmlns:a16="http://schemas.microsoft.com/office/drawing/2014/main" id="{DC1E23BB-581A-349F-FBED-AA9D319B0AD4}"/>
               </a:ext>
             </a:extLst>
           </p:cNvPr>
@@ -16729,7 +16730,7 @@
           <p:cNvPr id="22" name="TextBox 21">
             <a:extLst>
               <a:ext uri="{FF2B5EF4-FFF2-40B4-BE49-F238E27FC236}">
-                <a16:creationId xmlns:a16="http://schemas.microsoft.com/office/drawing/2014/main" id="{962BF3A0-C520-B5BD-7012-241153384CD6}"/>
+                <a16:creationId xmlns:a16="http://schemas.microsoft.com/office/drawing/2014/main" id="{DA8BD4D2-A288-7435-0563-DA2A8464B04A}"/>
               </a:ext>
             </a:extLst>
           </p:cNvPr>
@@ -16774,7 +16775,7 @@
           <p:cNvPr id="23" name="TextBox 22">
             <a:extLst>
               <a:ext uri="{FF2B5EF4-FFF2-40B4-BE49-F238E27FC236}">
-                <a16:creationId xmlns:a16="http://schemas.microsoft.com/office/drawing/2014/main" id="{275E4A08-A544-3650-BD29-849C5D3021A4}"/>
+                <a16:creationId xmlns:a16="http://schemas.microsoft.com/office/drawing/2014/main" id="{65B4728E-62BA-CB9B-D2FF-CC3B542E0FC3}"/>
               </a:ext>
             </a:extLst>
           </p:cNvPr>
@@ -16819,7 +16820,7 @@
           <p:cNvPr id="24" name="TextBox 23">
             <a:extLst>
               <a:ext uri="{FF2B5EF4-FFF2-40B4-BE49-F238E27FC236}">
-                <a16:creationId xmlns:a16="http://schemas.microsoft.com/office/drawing/2014/main" id="{54B217D8-6FB9-4F5C-2688-079262B8C3DB}"/>
+                <a16:creationId xmlns:a16="http://schemas.microsoft.com/office/drawing/2014/main" id="{DD7F15E2-4C1F-7D98-AED6-EA9C41891249}"/>
               </a:ext>
             </a:extLst>
           </p:cNvPr>
@@ -16868,7 +16869,7 @@
     </p:spTree>
     <p:extLst>
       <p:ext uri="{BB962C8B-B14F-4D97-AF65-F5344CB8AC3E}">
-        <p14:creationId xmlns:p14="http://schemas.microsoft.com/office/powerpoint/2010/main" val="2860621262"/>
+        <p14:creationId xmlns:p14="http://schemas.microsoft.com/office/powerpoint/2010/main" val="684431782"/>
       </p:ext>
     </p:extLst>
   </p:cSld>

</xml_diff>